<commit_message>
Fix PPT slides visibility, contrast, and alignment using master layout
</commit_message>
<xml_diff>
--- a/RIT - Quantathan 2026 - PPT.pptx
+++ b/RIT - Quantathan 2026 - PPT.pptx
@@ -9,12 +9,12 @@
   </p:notesMasterIdLst>
   <p:sldIdLst>
     <p:sldId id="256" r:id="rId2"/>
-    <p:sldId id="257" r:id="rId3"/>
-    <p:sldId id="258" r:id="rId9"/>
-    <p:sldId id="259" r:id="rId10"/>
-    <p:sldId id="260" r:id="rId11"/>
-    <p:sldId id="261" r:id="rId12"/>
-    <p:sldId id="262" r:id="rId13"/>
+    <p:sldId id="257" r:id="rId20"/>
+    <p:sldId id="258" r:id="rId21"/>
+    <p:sldId id="259" r:id="rId22"/>
+    <p:sldId id="260" r:id="rId23"/>
+    <p:sldId id="261" r:id="rId24"/>
+    <p:sldId id="262" r:id="rId25"/>
   </p:sldIdLst>
   <p:sldSz cx="9144000" cy="6858000" type="screen4x3"/>
   <p:notesSz cx="6858000" cy="9144000"/>
@@ -6833,168 +6833,137 @@
 </p:sld>
 </file>
 
-<file path=ppt/slides/slide2.xml><?xml version="1.0" encoding="utf-8"?>
-<p:sld xmlns:a="http://schemas.openxmlformats.org/drawingml/2006/main" xmlns:r="http://schemas.openxmlformats.org/officeDocument/2006/relationships" xmlns:p="http://schemas.openxmlformats.org/presentationml/2006/main">
+<file path=ppt/slides/slide10.xml><?xml version="1.0" encoding="utf-8"?>
+<p:sld xmlns:a="http://schemas.openxmlformats.org/drawingml/2006/main" xmlns:p="http://schemas.openxmlformats.org/presentationml/2006/main" xmlns:r="http://schemas.openxmlformats.org/officeDocument/2006/relationships">
   <p:cSld>
-    <p:bg>
-      <p:bgPr>
-        <a:blipFill dpi="0" rotWithShape="1">
-          <a:blip r:embed="rId3" cstate="print">
-            <a:lum/>
-          </a:blip>
-          <a:srcRect/>
-          <a:stretch>
-            <a:fillRect l="-24000" r="-24000"/>
-          </a:stretch>
-        </a:blipFill>
-        <a:effectLst/>
-      </p:bgPr>
-    </p:bg>
     <p:spTree>
       <p:nvGrpSpPr>
         <p:cNvPr id="1" name=""/>
         <p:cNvGrpSpPr/>
         <p:nvPr/>
       </p:nvGrpSpPr>
-      <p:grpSpPr>
-        <a:xfrm>
-          <a:off x="0" y="0"/>
-          <a:ext cx="0" cy="0"/>
-          <a:chOff x="0" y="0"/>
-          <a:chExt cx="0" cy="0"/>
-        </a:xfrm>
-      </p:grpSpPr>
-      <p:sp>
-        <p:nvSpPr>
-          <p:cNvPr id="2" name="TextBox 1"/>
-          <p:cNvSpPr txBox="1"/>
-          <p:nvPr/>
-        </p:nvSpPr>
-        <p:spPr>
-          <a:xfrm>
-            <a:off x="685800" y="457200"/>
-            <a:ext cx="7772400" cy="914400"/>
-          </a:xfrm>
-          <a:prstGeom prst="rect">
-            <a:avLst/>
-          </a:prstGeom>
-          <a:noFill/>
-        </p:spPr>
-        <p:txBody>
-          <a:bodyPr wrap="none">
-            <a:spAutoFit/>
-          </a:bodyPr>
+      <p:grpSpPr/>
+      <p:sp>
+        <p:nvSpPr>
+          <p:cNvPr id="2" name="Title 1"/>
+          <p:cNvSpPr>
+            <a:spLocks noGrp="1"/>
+          </p:cNvSpPr>
+          <p:nvPr>
+            <p:ph type="title"/>
+          </p:nvPr>
+        </p:nvSpPr>
+        <p:spPr/>
+        <p:txBody>
+          <a:bodyPr/>
           <a:lstStyle/>
           <a:p>
             <a:pPr>
               <a:defRPr sz="2800" b="1">
                 <a:solidFill>
-                  <a:srgbClr val="00D4FF"/>
+                  <a:srgbClr val="0A2D50"/>
                 </a:solidFill>
                 <a:latin typeface="Rajdhani"/>
               </a:defRPr>
             </a:pPr>
             <a:r>
-              <a:t>1. PROBLEM STATEMENT (QT-2.8)</a:t>
-            </a:r>
-          </a:p>
-        </p:txBody>
-      </p:sp>
-      <p:sp>
-        <p:nvSpPr>
-          <p:cNvPr id="3" name="TextBox 2"/>
-          <p:cNvSpPr txBox="1"/>
-          <p:nvPr/>
-        </p:nvSpPr>
-        <p:spPr>
-          <a:xfrm>
-            <a:off x="685800" y="1645920"/>
-            <a:ext cx="7772400" cy="4114800"/>
-          </a:xfrm>
-          <a:prstGeom prst="rect">
-            <a:avLst/>
-          </a:prstGeom>
-          <a:noFill/>
-        </p:spPr>
-        <p:txBody>
-          <a:bodyPr wrap="square">
-            <a:spAutoFit/>
-          </a:bodyPr>
-          <a:lstStyle/>
-          <a:p/>
+              <a:t>4. ADAPTIVE CONTEXT THRESHOLD ENGINE</a:t>
+            </a:r>
+          </a:p>
+        </p:txBody>
+      </p:sp>
+      <p:sp>
+        <p:nvSpPr>
+          <p:cNvPr id="3" name="Content Placeholder 2"/>
+          <p:cNvSpPr>
+            <a:spLocks noGrp="1"/>
+          </p:cNvSpPr>
+          <p:nvPr>
+            <p:ph idx="1" sz="quarter"/>
+          </p:nvPr>
+        </p:nvSpPr>
+        <p:spPr/>
+        <p:txBody>
+          <a:bodyPr wrap="square"/>
+          <a:lstStyle/>
           <a:p>
             <a:pPr>
               <a:spcAft>
-                <a:spcPts val="1200"/>
+                <a:spcPts val="1400"/>
               </a:spcAft>
-              <a:defRPr sz="1600">
-                <a:solidFill>
-                  <a:srgbClr val="DCF0FF"/>
-                </a:solidFill>
-              </a:defRPr>
-            </a:pPr>
-            <a:r>
-              <a:t>• Classical ML models check transactions in isolation, missing temporal loops.</a:t>
+            </a:pPr>
+            <a:r>
+              <a:rPr sz="1500">
+                <a:solidFill>
+                  <a:srgbClr val="283241"/>
+                </a:solidFill>
+                <a:latin typeface="Exo 2"/>
+              </a:rPr>
+              <a:t>Static Limits: Traditional systems block at a flat 80% limit, causing high friction.</a:t>
             </a:r>
           </a:p>
           <a:p>
             <a:pPr>
               <a:spcAft>
-                <a:spcPts val="1200"/>
+                <a:spcPts val="1400"/>
               </a:spcAft>
-              <a:defRPr sz="1600">
-                <a:solidFill>
-                  <a:srgbClr val="DCF0FF"/>
-                </a:solidFill>
-              </a:defRPr>
-            </a:pPr>
-            <a:r>
-              <a:t>• High False Positive rates annoy regular customers, increasing churn and operational friction.</a:t>
+            </a:pPr>
+            <a:r>
+              <a:rPr sz="1500">
+                <a:solidFill>
+                  <a:srgbClr val="283241"/>
+                </a:solidFill>
+                <a:latin typeface="Exo 2"/>
+              </a:rPr>
+              <a:t>Adaptive Threshold: Q-Guard shifts limits dynamically based on transaction context.</a:t>
             </a:r>
           </a:p>
           <a:p>
             <a:pPr>
               <a:spcAft>
-                <a:spcPts val="1200"/>
+                <a:spcPts val="1400"/>
               </a:spcAft>
-              <a:defRPr sz="1600">
-                <a:solidFill>
-                  <a:srgbClr val="DCF0FF"/>
-                </a:solidFill>
-              </a:defRPr>
-            </a:pPr>
-            <a:r>
-              <a:t>• Regulatory compliance (RBI/Central Bank) requires Explainable AI (XAI) parameters.</a:t>
+            </a:pPr>
+            <a:r>
+              <a:rPr sz="1500">
+                <a:solidFill>
+                  <a:srgbClr val="283241"/>
+                </a:solidFill>
+                <a:latin typeface="Exo 2"/>
+              </a:rPr>
+              <a:t>Late Night Hour Window (12 AM - 5 AM): Threshold drops to 65% (restrictive).</a:t>
             </a:r>
           </a:p>
           <a:p>
             <a:pPr>
               <a:spcAft>
-                <a:spcPts val="1200"/>
+                <a:spcPts val="1400"/>
               </a:spcAft>
-              <a:defRPr sz="1600">
-                <a:solidFill>
-                  <a:srgbClr val="DCF0FF"/>
-                </a:solidFill>
-              </a:defRPr>
-            </a:pPr>
-            <a:r>
-              <a:t>• Coordinated attacks (Mule Rings, shared device farms) bypass linear threshold rules.</a:t>
+            </a:pPr>
+            <a:r>
+              <a:rPr sz="1500">
+                <a:solidFill>
+                  <a:srgbClr val="283241"/>
+                </a:solidFill>
+                <a:latin typeface="Exo 2"/>
+              </a:rPr>
+              <a:t>High chargeback Merchant Terminal: Threshold drops to 58% (tighter security).</a:t>
             </a:r>
           </a:p>
           <a:p>
             <a:pPr>
               <a:spcAft>
-                <a:spcPts val="1200"/>
+                <a:spcPts val="1400"/>
               </a:spcAft>
-              <a:defRPr sz="1600">
-                <a:solidFill>
-                  <a:srgbClr val="DCF0FF"/>
-                </a:solidFill>
-              </a:defRPr>
-            </a:pPr>
-            <a:r>
-              <a:t>• Solution: Q-Guard AI combines Multi-Agent intelligence with a Quantum Optimization layer.</a:t>
+            </a:pPr>
+            <a:r>
+              <a:rPr sz="1500">
+                <a:solidFill>
+                  <a:srgbClr val="283241"/>
+                </a:solidFill>
+                <a:latin typeface="Exo 2"/>
+              </a:rPr>
+              <a:t>Trusted Regular Customer: Threshold rises to 95% (minimizes customer friction).</a:t>
             </a:r>
           </a:p>
         </p:txBody>
@@ -7004,16 +6973,721 @@
   <p:clrMapOvr>
     <a:masterClrMapping/>
   </p:clrMapOvr>
-  <p:transition>
-    <p:fade/>
-  </p:transition>
-  <p:timing>
-    <p:tnLst>
-      <p:par>
-        <p:cTn id="1" dur="indefinite" restart="never" nodeType="tmRoot"/>
-      </p:par>
-    </p:tnLst>
-  </p:timing>
+</p:sld>
+</file>
+
+<file path=ppt/slides/slide11.xml><?xml version="1.0" encoding="utf-8"?>
+<p:sld xmlns:a="http://schemas.openxmlformats.org/drawingml/2006/main" xmlns:p="http://schemas.openxmlformats.org/presentationml/2006/main" xmlns:r="http://schemas.openxmlformats.org/officeDocument/2006/relationships">
+  <p:cSld>
+    <p:spTree>
+      <p:nvGrpSpPr>
+        <p:cNvPr id="1" name=""/>
+        <p:cNvGrpSpPr/>
+        <p:nvPr/>
+      </p:nvGrpSpPr>
+      <p:grpSpPr/>
+      <p:sp>
+        <p:nvSpPr>
+          <p:cNvPr id="2" name="Title 1"/>
+          <p:cNvSpPr>
+            <a:spLocks noGrp="1"/>
+          </p:cNvSpPr>
+          <p:nvPr>
+            <p:ph type="title"/>
+          </p:nvPr>
+        </p:nvSpPr>
+        <p:spPr/>
+        <p:txBody>
+          <a:bodyPr/>
+          <a:lstStyle/>
+          <a:p>
+            <a:pPr>
+              <a:defRPr sz="2800" b="1">
+                <a:solidFill>
+                  <a:srgbClr val="0A2D50"/>
+                </a:solidFill>
+                <a:latin typeface="Rajdhani"/>
+              </a:defRPr>
+            </a:pPr>
+            <a:r>
+              <a:t>5. SELF-EXPLAINABLE AI &amp; STRATEGY MITIGATION</a:t>
+            </a:r>
+          </a:p>
+        </p:txBody>
+      </p:sp>
+      <p:sp>
+        <p:nvSpPr>
+          <p:cNvPr id="3" name="Content Placeholder 2"/>
+          <p:cNvSpPr>
+            <a:spLocks noGrp="1"/>
+          </p:cNvSpPr>
+          <p:nvPr>
+            <p:ph idx="1" sz="quarter"/>
+          </p:nvPr>
+        </p:nvSpPr>
+        <p:spPr/>
+        <p:txBody>
+          <a:bodyPr wrap="square"/>
+          <a:lstStyle/>
+          <a:p>
+            <a:pPr>
+              <a:spcAft>
+                <a:spcPts val="1400"/>
+              </a:spcAft>
+            </a:pPr>
+            <a:r>
+              <a:rPr sz="1500">
+                <a:solidFill>
+                  <a:srgbClr val="283241"/>
+                </a:solidFill>
+                <a:latin typeface="Exo 2"/>
+              </a:rPr>
+              <a:t>Self-Explainable AI (XAI): Translates VQC state vectors into natural language warning logs.</a:t>
+            </a:r>
+          </a:p>
+          <a:p>
+            <a:pPr>
+              <a:spcAft>
+                <a:spcPts val="1400"/>
+              </a:spcAft>
+            </a:pPr>
+            <a:r>
+              <a:rPr sz="1500">
+                <a:solidFill>
+                  <a:srgbClr val="283241"/>
+                </a:solidFill>
+                <a:latin typeface="Exo 2"/>
+              </a:rPr>
+              <a:t>Auditable Compliance: Outlines exactly why an agent triggered the transaction block.</a:t>
+            </a:r>
+          </a:p>
+          <a:p>
+            <a:pPr>
+              <a:spcAft>
+                <a:spcPts val="1400"/>
+              </a:spcAft>
+            </a:pPr>
+            <a:r>
+              <a:rPr sz="1500">
+                <a:solidFill>
+                  <a:srgbClr val="283241"/>
+                </a:solidFill>
+                <a:latin typeface="Exo 2"/>
+              </a:rPr>
+              <a:t>Fraud Strategy Advisor: Recommends progressive mitigation checklists instead of binary blocks.</a:t>
+            </a:r>
+          </a:p>
+          <a:p>
+            <a:pPr>
+              <a:spcAft>
+                <a:spcPts val="1400"/>
+              </a:spcAft>
+            </a:pPr>
+            <a:r>
+              <a:rPr sz="1500">
+                <a:solidFill>
+                  <a:srgbClr val="283241"/>
+                </a:solidFill>
+                <a:latin typeface="Exo 2"/>
+              </a:rPr>
+              <a:t>Mitigation Checklist: Request Face Authentication, Require SMS OTP, or Hold payout.</a:t>
+            </a:r>
+          </a:p>
+          <a:p>
+            <a:pPr>
+              <a:spcAft>
+                <a:spcPts val="1400"/>
+              </a:spcAft>
+            </a:pPr>
+            <a:r>
+              <a:rPr sz="1500">
+                <a:solidFill>
+                  <a:srgbClr val="283241"/>
+                </a:solidFill>
+                <a:latin typeface="Exo 2"/>
+              </a:rPr>
+              <a:t>Benefit: Matches regulatory audit frameworks while keeping user friction minimal.</a:t>
+            </a:r>
+          </a:p>
+        </p:txBody>
+      </p:sp>
+    </p:spTree>
+  </p:cSld>
+  <p:clrMapOvr>
+    <a:masterClrMapping/>
+  </p:clrMapOvr>
+</p:sld>
+</file>
+
+<file path=ppt/slides/slide12.xml><?xml version="1.0" encoding="utf-8"?>
+<p:sld xmlns:a="http://schemas.openxmlformats.org/drawingml/2006/main" xmlns:p="http://schemas.openxmlformats.org/presentationml/2006/main" xmlns:r="http://schemas.openxmlformats.org/officeDocument/2006/relationships">
+  <p:cSld>
+    <p:spTree>
+      <p:nvGrpSpPr>
+        <p:cNvPr id="1" name=""/>
+        <p:cNvGrpSpPr/>
+        <p:nvPr/>
+      </p:nvGrpSpPr>
+      <p:grpSpPr/>
+      <p:sp>
+        <p:nvSpPr>
+          <p:cNvPr id="2" name="Title 1"/>
+          <p:cNvSpPr>
+            <a:spLocks noGrp="1"/>
+          </p:cNvSpPr>
+          <p:nvPr>
+            <p:ph type="title"/>
+          </p:nvPr>
+        </p:nvSpPr>
+        <p:spPr/>
+        <p:txBody>
+          <a:bodyPr/>
+          <a:lstStyle/>
+          <a:p>
+            <a:pPr>
+              <a:defRPr sz="2800" b="1">
+                <a:solidFill>
+                  <a:srgbClr val="0A2D50"/>
+                </a:solidFill>
+                <a:latin typeface="Rajdhani"/>
+              </a:defRPr>
+            </a:pPr>
+            <a:r>
+              <a:t>6. SCALABILITY &amp; DATABASE PIPELINE INTEGRATION</a:t>
+            </a:r>
+          </a:p>
+        </p:txBody>
+      </p:sp>
+      <p:sp>
+        <p:nvSpPr>
+          <p:cNvPr id="3" name="Content Placeholder 2"/>
+          <p:cNvSpPr>
+            <a:spLocks noGrp="1"/>
+          </p:cNvSpPr>
+          <p:nvPr>
+            <p:ph idx="1" sz="quarter"/>
+          </p:nvPr>
+        </p:nvSpPr>
+        <p:spPr/>
+        <p:txBody>
+          <a:bodyPr wrap="square"/>
+          <a:lstStyle/>
+          <a:p>
+            <a:pPr>
+              <a:spcAft>
+                <a:spcPts val="1400"/>
+              </a:spcAft>
+            </a:pPr>
+            <a:r>
+              <a:rPr sz="1500">
+                <a:solidFill>
+                  <a:srgbClr val="283241"/>
+                </a:solidFill>
+                <a:latin typeface="Exo 2"/>
+              </a:rPr>
+              <a:t>Kaggle Database: Integrated with 3,000 real-world transaction logs (IEEE-CIS).</a:t>
+            </a:r>
+          </a:p>
+          <a:p>
+            <a:pPr>
+              <a:spcAft>
+                <a:spcPts val="1400"/>
+              </a:spcAft>
+            </a:pPr>
+            <a:r>
+              <a:rPr sz="1500">
+                <a:solidFill>
+                  <a:srgbClr val="283241"/>
+                </a:solidFill>
+                <a:latin typeface="Exo 2"/>
+              </a:rPr>
+              <a:t>MongoDB Integration: Stores transactions and quantum telemetry in indexed collections.</a:t>
+            </a:r>
+          </a:p>
+          <a:p>
+            <a:pPr>
+              <a:spcAft>
+                <a:spcPts val="1400"/>
+              </a:spcAft>
+            </a:pPr>
+            <a:r>
+              <a:rPr sz="1500">
+                <a:solidFill>
+                  <a:srgbClr val="283241"/>
+                </a:solidFill>
+                <a:latin typeface="Exo 2"/>
+              </a:rPr>
+              <a:t>FastAPI REST endpoints: Exposes VQC coordinates, dynamic weights, and strategies.</a:t>
+            </a:r>
+          </a:p>
+          <a:p>
+            <a:pPr>
+              <a:spcAft>
+                <a:spcPts val="1400"/>
+              </a:spcAft>
+            </a:pPr>
+            <a:r>
+              <a:rPr sz="1500">
+                <a:solidFill>
+                  <a:srgbClr val="283241"/>
+                </a:solidFill>
+                <a:latin typeface="Exo 2"/>
+              </a:rPr>
+              <a:t>Vercel Deployment: Standalone HTML visualizer deployed live on cloud static servers.</a:t>
+            </a:r>
+          </a:p>
+          <a:p>
+            <a:pPr>
+              <a:spcAft>
+                <a:spcPts val="1400"/>
+              </a:spcAft>
+            </a:pPr>
+            <a:r>
+              <a:rPr sz="1500">
+                <a:solidFill>
+                  <a:srgbClr val="283241"/>
+                </a:solidFill>
+                <a:latin typeface="Exo 2"/>
+              </a:rPr>
+              <a:t>Result: A scalable, production-grade Quantum-Graph system ready for deployment.</a:t>
+            </a:r>
+          </a:p>
+        </p:txBody>
+      </p:sp>
+    </p:spTree>
+  </p:cSld>
+  <p:clrMapOvr>
+    <a:masterClrMapping/>
+  </p:clrMapOvr>
+</p:sld>
+</file>
+
+<file path=ppt/slides/slide2.xml><?xml version="1.0" encoding="utf-8"?>
+<p:sld xmlns:a="http://schemas.openxmlformats.org/drawingml/2006/main" xmlns:p="http://schemas.openxmlformats.org/presentationml/2006/main" xmlns:r="http://schemas.openxmlformats.org/officeDocument/2006/relationships">
+  <p:cSld>
+    <p:spTree>
+      <p:nvGrpSpPr>
+        <p:cNvPr id="1" name=""/>
+        <p:cNvGrpSpPr/>
+        <p:nvPr/>
+      </p:nvGrpSpPr>
+      <p:grpSpPr/>
+      <p:sp>
+        <p:nvSpPr>
+          <p:cNvPr id="2" name="Title 1"/>
+          <p:cNvSpPr>
+            <a:spLocks noGrp="1"/>
+          </p:cNvSpPr>
+          <p:nvPr>
+            <p:ph type="title"/>
+          </p:nvPr>
+        </p:nvSpPr>
+        <p:spPr/>
+        <p:txBody>
+          <a:bodyPr/>
+          <a:lstStyle/>
+          <a:p>
+            <a:pPr>
+              <a:defRPr sz="2800" b="1">
+                <a:solidFill>
+                  <a:srgbClr val="0A2D50"/>
+                </a:solidFill>
+                <a:latin typeface="Rajdhani"/>
+              </a:defRPr>
+            </a:pPr>
+            <a:r>
+              <a:t>1. PROBLEM STATEMENT (QT-2.8)</a:t>
+            </a:r>
+          </a:p>
+        </p:txBody>
+      </p:sp>
+      <p:sp>
+        <p:nvSpPr>
+          <p:cNvPr id="3" name="Content Placeholder 2"/>
+          <p:cNvSpPr>
+            <a:spLocks noGrp="1"/>
+          </p:cNvSpPr>
+          <p:nvPr>
+            <p:ph idx="1" sz="quarter"/>
+          </p:nvPr>
+        </p:nvSpPr>
+        <p:spPr/>
+        <p:txBody>
+          <a:bodyPr wrap="square"/>
+          <a:lstStyle/>
+          <a:p>
+            <a:pPr>
+              <a:spcAft>
+                <a:spcPts val="1400"/>
+              </a:spcAft>
+            </a:pPr>
+            <a:r>
+              <a:rPr sz="1500">
+                <a:solidFill>
+                  <a:srgbClr val="283241"/>
+                </a:solidFill>
+                <a:latin typeface="Exo 2"/>
+              </a:rPr>
+              <a:t>Classical ML models check transactions in isolation, missing temporal laundering loops.</a:t>
+            </a:r>
+          </a:p>
+          <a:p>
+            <a:pPr>
+              <a:spcAft>
+                <a:spcPts val="1400"/>
+              </a:spcAft>
+            </a:pPr>
+            <a:r>
+              <a:rPr sz="1500">
+                <a:solidFill>
+                  <a:srgbClr val="283241"/>
+                </a:solidFill>
+                <a:latin typeface="Exo 2"/>
+              </a:rPr>
+              <a:t>High False Positive rates annoy regular customers, increasing churn and operational friction.</a:t>
+            </a:r>
+          </a:p>
+          <a:p>
+            <a:pPr>
+              <a:spcAft>
+                <a:spcPts val="1400"/>
+              </a:spcAft>
+            </a:pPr>
+            <a:r>
+              <a:rPr sz="1500">
+                <a:solidFill>
+                  <a:srgbClr val="283241"/>
+                </a:solidFill>
+                <a:latin typeface="Exo 2"/>
+              </a:rPr>
+              <a:t>Regulatory compliance (RBI/Central Bank) requires Explainable AI (XAI) parameters.</a:t>
+            </a:r>
+          </a:p>
+          <a:p>
+            <a:pPr>
+              <a:spcAft>
+                <a:spcPts val="1400"/>
+              </a:spcAft>
+            </a:pPr>
+            <a:r>
+              <a:rPr sz="1500">
+                <a:solidFill>
+                  <a:srgbClr val="283241"/>
+                </a:solidFill>
+                <a:latin typeface="Exo 2"/>
+              </a:rPr>
+              <a:t>Coordinated attacks (Mule Rings, shared device emulators) bypass standard linear limits.</a:t>
+            </a:r>
+          </a:p>
+          <a:p>
+            <a:pPr>
+              <a:spcAft>
+                <a:spcPts val="1400"/>
+              </a:spcAft>
+            </a:pPr>
+            <a:r>
+              <a:rPr sz="1500">
+                <a:solidFill>
+                  <a:srgbClr val="283241"/>
+                </a:solidFill>
+                <a:latin typeface="Exo 2"/>
+              </a:rPr>
+              <a:t>Solution: Q-Guard AI combines Multi-Agent intelligence with a Quantum Optimization layer.</a:t>
+            </a:r>
+          </a:p>
+        </p:txBody>
+      </p:sp>
+    </p:spTree>
+  </p:cSld>
+  <p:clrMapOvr>
+    <a:masterClrMapping/>
+  </p:clrMapOvr>
+</p:sld>
+</file>
+
+<file path=ppt/slides/slide2.xml><?xml version="1.0" encoding="utf-8"?>
+<p:sld xmlns:a="http://schemas.openxmlformats.org/drawingml/2006/main" xmlns:p="http://schemas.openxmlformats.org/presentationml/2006/main" xmlns:r="http://schemas.openxmlformats.org/officeDocument/2006/relationships">
+  <p:cSld>
+    <p:spTree>
+      <p:nvGrpSpPr>
+        <p:cNvPr id="1" name=""/>
+        <p:cNvGrpSpPr/>
+        <p:nvPr/>
+      </p:nvGrpSpPr>
+      <p:grpSpPr/>
+      <p:sp>
+        <p:nvSpPr>
+          <p:cNvPr id="2" name="Title 1"/>
+          <p:cNvSpPr>
+            <a:spLocks noGrp="1"/>
+          </p:cNvSpPr>
+          <p:nvPr>
+            <p:ph type="title"/>
+          </p:nvPr>
+        </p:nvSpPr>
+        <p:spPr/>
+        <p:txBody>
+          <a:bodyPr/>
+          <a:lstStyle/>
+          <a:p>
+            <a:pPr>
+              <a:defRPr sz="2800" b="1">
+                <a:solidFill>
+                  <a:srgbClr val="0A2D50"/>
+                </a:solidFill>
+                <a:latin typeface="Rajdhani"/>
+              </a:defRPr>
+            </a:pPr>
+            <a:r>
+              <a:t>1. PROBLEM STATEMENT (QT-2.8)</a:t>
+            </a:r>
+          </a:p>
+        </p:txBody>
+      </p:sp>
+      <p:sp>
+        <p:nvSpPr>
+          <p:cNvPr id="3" name="Content Placeholder 2"/>
+          <p:cNvSpPr>
+            <a:spLocks noGrp="1"/>
+          </p:cNvSpPr>
+          <p:nvPr>
+            <p:ph idx="1" sz="quarter"/>
+          </p:nvPr>
+        </p:nvSpPr>
+        <p:spPr/>
+        <p:txBody>
+          <a:bodyPr wrap="square"/>
+          <a:lstStyle/>
+          <a:p>
+            <a:pPr>
+              <a:spcAft>
+                <a:spcPts val="1400"/>
+              </a:spcAft>
+            </a:pPr>
+            <a:r>
+              <a:rPr sz="1500">
+                <a:solidFill>
+                  <a:srgbClr val="283241"/>
+                </a:solidFill>
+                <a:latin typeface="Exo 2"/>
+              </a:rPr>
+              <a:t>Classical ML models check transactions in isolation, missing temporal laundering loops.</a:t>
+            </a:r>
+          </a:p>
+          <a:p>
+            <a:pPr>
+              <a:spcAft>
+                <a:spcPts val="1400"/>
+              </a:spcAft>
+            </a:pPr>
+            <a:r>
+              <a:rPr sz="1500">
+                <a:solidFill>
+                  <a:srgbClr val="283241"/>
+                </a:solidFill>
+                <a:latin typeface="Exo 2"/>
+              </a:rPr>
+              <a:t>High False Positive rates annoy regular customers, increasing churn and operational friction.</a:t>
+            </a:r>
+          </a:p>
+          <a:p>
+            <a:pPr>
+              <a:spcAft>
+                <a:spcPts val="1400"/>
+              </a:spcAft>
+            </a:pPr>
+            <a:r>
+              <a:rPr sz="1500">
+                <a:solidFill>
+                  <a:srgbClr val="283241"/>
+                </a:solidFill>
+                <a:latin typeface="Exo 2"/>
+              </a:rPr>
+              <a:t>Regulatory compliance (RBI/Central Bank) requires Explainable AI (XAI) parameters.</a:t>
+            </a:r>
+          </a:p>
+          <a:p>
+            <a:pPr>
+              <a:spcAft>
+                <a:spcPts val="1400"/>
+              </a:spcAft>
+            </a:pPr>
+            <a:r>
+              <a:rPr sz="1500">
+                <a:solidFill>
+                  <a:srgbClr val="283241"/>
+                </a:solidFill>
+                <a:latin typeface="Exo 2"/>
+              </a:rPr>
+              <a:t>Coordinated attacks (Mule Rings, shared device emulators) bypass standard linear limits.</a:t>
+            </a:r>
+          </a:p>
+          <a:p>
+            <a:pPr>
+              <a:spcAft>
+                <a:spcPts val="1400"/>
+              </a:spcAft>
+            </a:pPr>
+            <a:r>
+              <a:rPr sz="1500">
+                <a:solidFill>
+                  <a:srgbClr val="283241"/>
+                </a:solidFill>
+                <a:latin typeface="Exo 2"/>
+              </a:rPr>
+              <a:t>Solution: Q-Guard AI combines Multi-Agent intelligence with a Quantum Optimization layer.</a:t>
+            </a:r>
+          </a:p>
+        </p:txBody>
+      </p:sp>
+    </p:spTree>
+  </p:cSld>
+  <p:clrMapOvr>
+    <a:masterClrMapping/>
+  </p:clrMapOvr>
+</p:sld>
+</file>
+
+<file path=ppt/slides/slide2.xml><?xml version="1.0" encoding="utf-8"?>
+<p:sld xmlns:a="http://schemas.openxmlformats.org/drawingml/2006/main" xmlns:p="http://schemas.openxmlformats.org/presentationml/2006/main" xmlns:r="http://schemas.openxmlformats.org/officeDocument/2006/relationships">
+  <p:cSld>
+    <p:spTree>
+      <p:nvGrpSpPr>
+        <p:cNvPr id="1" name=""/>
+        <p:cNvGrpSpPr/>
+        <p:nvPr/>
+      </p:nvGrpSpPr>
+      <p:grpSpPr/>
+      <p:sp>
+        <p:nvSpPr>
+          <p:cNvPr id="2" name="Title 1"/>
+          <p:cNvSpPr>
+            <a:spLocks noGrp="1"/>
+          </p:cNvSpPr>
+          <p:nvPr>
+            <p:ph type="title"/>
+          </p:nvPr>
+        </p:nvSpPr>
+        <p:spPr/>
+        <p:txBody>
+          <a:bodyPr/>
+          <a:lstStyle/>
+          <a:p>
+            <a:pPr>
+              <a:defRPr sz="2800" b="1">
+                <a:solidFill>
+                  <a:srgbClr val="0A2D50"/>
+                </a:solidFill>
+                <a:latin typeface="Rajdhani"/>
+              </a:defRPr>
+            </a:pPr>
+            <a:r>
+              <a:t>1. PROBLEM STATEMENT (QT-2.8)</a:t>
+            </a:r>
+          </a:p>
+        </p:txBody>
+      </p:sp>
+      <p:sp>
+        <p:nvSpPr>
+          <p:cNvPr id="3" name="Content Placeholder 2"/>
+          <p:cNvSpPr>
+            <a:spLocks noGrp="1"/>
+          </p:cNvSpPr>
+          <p:nvPr>
+            <p:ph idx="1" sz="quarter"/>
+          </p:nvPr>
+        </p:nvSpPr>
+        <p:spPr/>
+        <p:txBody>
+          <a:bodyPr wrap="square"/>
+          <a:lstStyle/>
+          <a:p>
+            <a:pPr>
+              <a:spcAft>
+                <a:spcPts val="1400"/>
+              </a:spcAft>
+            </a:pPr>
+            <a:r>
+              <a:rPr sz="1500">
+                <a:solidFill>
+                  <a:srgbClr val="283241"/>
+                </a:solidFill>
+                <a:latin typeface="Exo 2"/>
+              </a:rPr>
+              <a:t>Classical ML models check transactions in isolation, missing temporal laundering loops.</a:t>
+            </a:r>
+          </a:p>
+          <a:p>
+            <a:pPr>
+              <a:spcAft>
+                <a:spcPts val="1400"/>
+              </a:spcAft>
+            </a:pPr>
+            <a:r>
+              <a:rPr sz="1500">
+                <a:solidFill>
+                  <a:srgbClr val="283241"/>
+                </a:solidFill>
+                <a:latin typeface="Exo 2"/>
+              </a:rPr>
+              <a:t>High False Positive rates annoy regular customers, increasing churn and operational friction.</a:t>
+            </a:r>
+          </a:p>
+          <a:p>
+            <a:pPr>
+              <a:spcAft>
+                <a:spcPts val="1400"/>
+              </a:spcAft>
+            </a:pPr>
+            <a:r>
+              <a:rPr sz="1500">
+                <a:solidFill>
+                  <a:srgbClr val="283241"/>
+                </a:solidFill>
+                <a:latin typeface="Exo 2"/>
+              </a:rPr>
+              <a:t>Regulatory compliance (RBI/Central Bank) requires Explainable AI (XAI) parameters.</a:t>
+            </a:r>
+          </a:p>
+          <a:p>
+            <a:pPr>
+              <a:spcAft>
+                <a:spcPts val="1400"/>
+              </a:spcAft>
+            </a:pPr>
+            <a:r>
+              <a:rPr sz="1500">
+                <a:solidFill>
+                  <a:srgbClr val="283241"/>
+                </a:solidFill>
+                <a:latin typeface="Exo 2"/>
+              </a:rPr>
+              <a:t>Coordinated attacks (Mule Rings, shared device emulators) bypass standard linear limits.</a:t>
+            </a:r>
+          </a:p>
+          <a:p>
+            <a:pPr>
+              <a:spcAft>
+                <a:spcPts val="1400"/>
+              </a:spcAft>
+            </a:pPr>
+            <a:r>
+              <a:rPr sz="1500">
+                <a:solidFill>
+                  <a:srgbClr val="283241"/>
+                </a:solidFill>
+                <a:latin typeface="Exo 2"/>
+              </a:rPr>
+              <a:t>Solution: Q-Guard AI combines Multi-Agent intelligence with a Quantum Optimization layer.</a:t>
+            </a:r>
+          </a:p>
+        </p:txBody>
+      </p:sp>
+    </p:spTree>
+  </p:cSld>
+  <p:clrMapOvr>
+    <a:masterClrMapping/>
+  </p:clrMapOvr>
 </p:sld>
 </file>
 
@@ -7042,6 +7716,14 @@
           <a:bodyPr/>
           <a:lstStyle/>
           <a:p>
+            <a:pPr>
+              <a:defRPr sz="2800" b="1">
+                <a:solidFill>
+                  <a:srgbClr val="0A2D50"/>
+                </a:solidFill>
+                <a:latin typeface="Rajdhani"/>
+              </a:defRPr>
+            </a:pPr>
             <a:r>
               <a:t>2. Q-GUARD ARCHITECTURE: MULTI-AGENT INGESTION</a:t>
             </a:r>
@@ -7065,76 +7747,224 @@
           <a:p>
             <a:pPr>
               <a:spcAft>
-                <a:spcPts val="1200"/>
+                <a:spcPts val="1400"/>
               </a:spcAft>
-              <a:defRPr sz="1600">
-                <a:solidFill>
-                  <a:srgbClr val="DCF0FF"/>
-                </a:solidFill>
+            </a:pPr>
+            <a:r>
+              <a:rPr sz="1500">
+                <a:solidFill>
+                  <a:srgbClr val="283241"/>
+                </a:solidFill>
+                <a:latin typeface="Exo 2"/>
+              </a:rPr>
+              <a:t>User Behavior Agent: Analyzes daily spending limit fractions and transaction volume.</a:t>
+            </a:r>
+          </a:p>
+          <a:p>
+            <a:pPr>
+              <a:spcAft>
+                <a:spcPts val="1400"/>
+              </a:spcAft>
+            </a:pPr>
+            <a:r>
+              <a:rPr sz="1500">
+                <a:solidFill>
+                  <a:srgbClr val="283241"/>
+                </a:solidFill>
+                <a:latin typeface="Exo 2"/>
+              </a:rPr>
+              <a:t>Device Intelligence Agent: Detects OS versions, emulators, and device trust rating.</a:t>
+            </a:r>
+          </a:p>
+          <a:p>
+            <a:pPr>
+              <a:spcAft>
+                <a:spcPts val="1400"/>
+              </a:spcAft>
+            </a:pPr>
+            <a:r>
+              <a:rPr sz="1500">
+                <a:solidFill>
+                  <a:srgbClr val="283241"/>
+                </a:solidFill>
+                <a:latin typeface="Exo 2"/>
+              </a:rPr>
+              <a:t>Merchant Rating Agent: Assesses merchant category hazard and chargeback rates.</a:t>
+            </a:r>
+          </a:p>
+          <a:p>
+            <a:pPr>
+              <a:spcAft>
+                <a:spcPts val="1400"/>
+              </a:spcAft>
+            </a:pPr>
+            <a:r>
+              <a:rPr sz="1500">
+                <a:solidFill>
+                  <a:srgbClr val="283241"/>
+                </a:solidFill>
+                <a:latin typeface="Exo 2"/>
+              </a:rPr>
+              <a:t>Network Intelligence Agent: Monitors VPN usage, proxy IPs, and impossible travel.</a:t>
+            </a:r>
+          </a:p>
+          <a:p>
+            <a:pPr>
+              <a:spcAft>
+                <a:spcPts val="1400"/>
+              </a:spcAft>
+            </a:pPr>
+            <a:r>
+              <a:rPr sz="1500">
+                <a:solidFill>
+                  <a:srgbClr val="283241"/>
+                </a:solidFill>
+                <a:latin typeface="Exo 2"/>
+              </a:rPr>
+              <a:t>Decentralized Ingestion: Captures separate threat layers simultaneously to prevent bypass.</a:t>
+            </a:r>
+          </a:p>
+        </p:txBody>
+      </p:sp>
+    </p:spTree>
+  </p:cSld>
+  <p:clrMapOvr>
+    <a:masterClrMapping/>
+  </p:clrMapOvr>
+</p:sld>
+</file>
+
+<file path=ppt/slides/slide3.xml><?xml version="1.0" encoding="utf-8"?>
+<p:sld xmlns:a="http://schemas.openxmlformats.org/drawingml/2006/main" xmlns:p="http://schemas.openxmlformats.org/presentationml/2006/main" xmlns:r="http://schemas.openxmlformats.org/officeDocument/2006/relationships">
+  <p:cSld>
+    <p:spTree>
+      <p:nvGrpSpPr>
+        <p:cNvPr id="1" name=""/>
+        <p:cNvGrpSpPr/>
+        <p:nvPr/>
+      </p:nvGrpSpPr>
+      <p:grpSpPr/>
+      <p:sp>
+        <p:nvSpPr>
+          <p:cNvPr id="2" name="Title 1"/>
+          <p:cNvSpPr>
+            <a:spLocks noGrp="1"/>
+          </p:cNvSpPr>
+          <p:nvPr>
+            <p:ph type="title"/>
+          </p:nvPr>
+        </p:nvSpPr>
+        <p:spPr/>
+        <p:txBody>
+          <a:bodyPr/>
+          <a:lstStyle/>
+          <a:p>
+            <a:pPr>
+              <a:defRPr sz="2800" b="1">
+                <a:solidFill>
+                  <a:srgbClr val="0A2D50"/>
+                </a:solidFill>
+                <a:latin typeface="Rajdhani"/>
               </a:defRPr>
             </a:pPr>
             <a:r>
-              <a:t>• User Behavior Agent: Analyzes daily spending limit fractions and time deviation.</a:t>
-            </a:r>
-          </a:p>
+              <a:t>2. Q-GUARD ARCHITECTURE: MULTI-AGENT INGESTION</a:t>
+            </a:r>
+          </a:p>
+        </p:txBody>
+      </p:sp>
+      <p:sp>
+        <p:nvSpPr>
+          <p:cNvPr id="3" name="Content Placeholder 2"/>
+          <p:cNvSpPr>
+            <a:spLocks noGrp="1"/>
+          </p:cNvSpPr>
+          <p:nvPr>
+            <p:ph idx="1" sz="quarter"/>
+          </p:nvPr>
+        </p:nvSpPr>
+        <p:spPr/>
+        <p:txBody>
+          <a:bodyPr wrap="square"/>
+          <a:lstStyle/>
           <a:p>
             <a:pPr>
               <a:spcAft>
-                <a:spcPts val="1200"/>
+                <a:spcPts val="1400"/>
               </a:spcAft>
-              <a:defRPr sz="1600">
-                <a:solidFill>
-                  <a:srgbClr val="DCF0FF"/>
-                </a:solidFill>
-              </a:defRPr>
-            </a:pPr>
-            <a:r>
-              <a:t>• Device Intelligence Agent: Detects OS versions, emulators, and device trust rating.</a:t>
+            </a:pPr>
+            <a:r>
+              <a:rPr sz="1500">
+                <a:solidFill>
+                  <a:srgbClr val="283241"/>
+                </a:solidFill>
+                <a:latin typeface="Exo 2"/>
+              </a:rPr>
+              <a:t>User Behavior Agent: Analyzes daily spending limit fractions and transaction volume.</a:t>
             </a:r>
           </a:p>
           <a:p>
             <a:pPr>
               <a:spcAft>
-                <a:spcPts val="1200"/>
+                <a:spcPts val="1400"/>
               </a:spcAft>
-              <a:defRPr sz="1600">
-                <a:solidFill>
-                  <a:srgbClr val="DCF0FF"/>
-                </a:solidFill>
-              </a:defRPr>
-            </a:pPr>
-            <a:r>
-              <a:t>• Merchant Rating Agent: Assesses merchant category hazard and chargeback rates.</a:t>
+            </a:pPr>
+            <a:r>
+              <a:rPr sz="1500">
+                <a:solidFill>
+                  <a:srgbClr val="283241"/>
+                </a:solidFill>
+                <a:latin typeface="Exo 2"/>
+              </a:rPr>
+              <a:t>Device Intelligence Agent: Detects OS versions, emulators, and device trust rating.</a:t>
             </a:r>
           </a:p>
           <a:p>
             <a:pPr>
               <a:spcAft>
-                <a:spcPts val="1200"/>
+                <a:spcPts val="1400"/>
               </a:spcAft>
-              <a:defRPr sz="1600">
-                <a:solidFill>
-                  <a:srgbClr val="DCF0FF"/>
-                </a:solidFill>
-              </a:defRPr>
-            </a:pPr>
-            <a:r>
-              <a:t>• Network Intelligence Agent: Monitors VPN usage, proxy IPs, and impossible travel.</a:t>
+            </a:pPr>
+            <a:r>
+              <a:rPr sz="1500">
+                <a:solidFill>
+                  <a:srgbClr val="283241"/>
+                </a:solidFill>
+                <a:latin typeface="Exo 2"/>
+              </a:rPr>
+              <a:t>Merchant Rating Agent: Assesses merchant category hazard and chargeback rates.</a:t>
             </a:r>
           </a:p>
           <a:p>
             <a:pPr>
               <a:spcAft>
-                <a:spcPts val="1200"/>
+                <a:spcPts val="1400"/>
               </a:spcAft>
-              <a:defRPr sz="1600">
-                <a:solidFill>
-                  <a:srgbClr val="DCF0FF"/>
-                </a:solidFill>
-              </a:defRPr>
-            </a:pPr>
-            <a:r>
-              <a:t>• Benefit: Decentralized analysis captures separate threat layers simultaneously.</a:t>
+            </a:pPr>
+            <a:r>
+              <a:rPr sz="1500">
+                <a:solidFill>
+                  <a:srgbClr val="283241"/>
+                </a:solidFill>
+                <a:latin typeface="Exo 2"/>
+              </a:rPr>
+              <a:t>Network Intelligence Agent: Monitors VPN usage, proxy IPs, and impossible travel.</a:t>
+            </a:r>
+          </a:p>
+          <a:p>
+            <a:pPr>
+              <a:spcAft>
+                <a:spcPts val="1400"/>
+              </a:spcAft>
+            </a:pPr>
+            <a:r>
+              <a:rPr sz="1500">
+                <a:solidFill>
+                  <a:srgbClr val="283241"/>
+                </a:solidFill>
+                <a:latin typeface="Exo 2"/>
+              </a:rPr>
+              <a:t>Decentralized Ingestion: Captures separate threat layers simultaneously to prevent bypass.</a:t>
             </a:r>
           </a:p>
         </p:txBody>
@@ -7172,6 +8002,14 @@
           <a:bodyPr/>
           <a:lstStyle/>
           <a:p>
+            <a:pPr>
+              <a:defRPr sz="2800" b="1">
+                <a:solidFill>
+                  <a:srgbClr val="0A2D50"/>
+                </a:solidFill>
+                <a:latin typeface="Rajdhani"/>
+              </a:defRPr>
+            </a:pPr>
             <a:r>
               <a:t>3. QUANTUM WEIGHT OPTIMIZATION (QML LAYER)</a:t>
             </a:r>
@@ -7195,76 +8033,224 @@
           <a:p>
             <a:pPr>
               <a:spcAft>
-                <a:spcPts val="1200"/>
+                <a:spcPts val="1400"/>
               </a:spcAft>
-              <a:defRPr sz="1600">
-                <a:solidFill>
-                  <a:srgbClr val="DCF0FF"/>
-                </a:solidFill>
+            </a:pPr>
+            <a:r>
+              <a:rPr sz="1500">
+                <a:solidFill>
+                  <a:srgbClr val="283241"/>
+                </a:solidFill>
+                <a:latin typeface="Exo 2"/>
+              </a:rPr>
+              <a:t>State Encoding: Maps the 4 Agent risk variables directly to 4 Qubits (Q0 to Q3).</a:t>
+            </a:r>
+          </a:p>
+          <a:p>
+            <a:pPr>
+              <a:spcAft>
+                <a:spcPts val="1400"/>
+              </a:spcAft>
+            </a:pPr>
+            <a:r>
+              <a:rPr sz="1500">
+                <a:solidFill>
+                  <a:srgbClr val="283241"/>
+                </a:solidFill>
+                <a:latin typeface="Exo 2"/>
+              </a:rPr>
+              <a:t>Entangling Circuit: Employs a Ring CNOT entangler to learn non-linear inter-agent correlations.</a:t>
+            </a:r>
+          </a:p>
+          <a:p>
+            <a:pPr>
+              <a:spcAft>
+                <a:spcPts val="1400"/>
+              </a:spcAft>
+            </a:pPr>
+            <a:r>
+              <a:rPr sz="1500">
+                <a:solidFill>
+                  <a:srgbClr val="283241"/>
+                </a:solidFill>
+                <a:latin typeface="Exo 2"/>
+              </a:rPr>
+              <a:t>Dynamic Weighting: Aggregates risk dynamically based on Qubit Z-coordinate excitation.</a:t>
+            </a:r>
+          </a:p>
+          <a:p>
+            <a:pPr>
+              <a:spcAft>
+                <a:spcPts val="1400"/>
+              </a:spcAft>
+            </a:pPr>
+            <a:r>
+              <a:rPr sz="1500">
+                <a:solidFill>
+                  <a:srgbClr val="283241"/>
+                </a:solidFill>
+                <a:latin typeface="Exo 2"/>
+              </a:rPr>
+              <a:t>Bloch Projections: Agent weights are proportional to excitation (Weight = 1.0 - Z).</a:t>
+            </a:r>
+          </a:p>
+          <a:p>
+            <a:pPr>
+              <a:spcAft>
+                <a:spcPts val="1400"/>
+              </a:spcAft>
+            </a:pPr>
+            <a:r>
+              <a:rPr sz="1500">
+                <a:solidFill>
+                  <a:srgbClr val="283241"/>
+                </a:solidFill>
+                <a:latin typeface="Exo 2"/>
+              </a:rPr>
+              <a:t>Benefit: Captures non-linear threat vectors using 90% fewer parameters than classical NN.</a:t>
+            </a:r>
+          </a:p>
+        </p:txBody>
+      </p:sp>
+    </p:spTree>
+  </p:cSld>
+  <p:clrMapOvr>
+    <a:masterClrMapping/>
+  </p:clrMapOvr>
+</p:sld>
+</file>
+
+<file path=ppt/slides/slide4.xml><?xml version="1.0" encoding="utf-8"?>
+<p:sld xmlns:a="http://schemas.openxmlformats.org/drawingml/2006/main" xmlns:p="http://schemas.openxmlformats.org/presentationml/2006/main" xmlns:r="http://schemas.openxmlformats.org/officeDocument/2006/relationships">
+  <p:cSld>
+    <p:spTree>
+      <p:nvGrpSpPr>
+        <p:cNvPr id="1" name=""/>
+        <p:cNvGrpSpPr/>
+        <p:nvPr/>
+      </p:nvGrpSpPr>
+      <p:grpSpPr/>
+      <p:sp>
+        <p:nvSpPr>
+          <p:cNvPr id="2" name="Title 1"/>
+          <p:cNvSpPr>
+            <a:spLocks noGrp="1"/>
+          </p:cNvSpPr>
+          <p:nvPr>
+            <p:ph type="title"/>
+          </p:nvPr>
+        </p:nvSpPr>
+        <p:spPr/>
+        <p:txBody>
+          <a:bodyPr/>
+          <a:lstStyle/>
+          <a:p>
+            <a:pPr>
+              <a:defRPr sz="2800" b="1">
+                <a:solidFill>
+                  <a:srgbClr val="0A2D50"/>
+                </a:solidFill>
+                <a:latin typeface="Rajdhani"/>
               </a:defRPr>
             </a:pPr>
             <a:r>
-              <a:t>• State Encoding: Maps the 4 Agent risk variables directly to 4 Qubits (Q0 to Q3).</a:t>
-            </a:r>
-          </a:p>
+              <a:t>3. QUANTUM WEIGHT OPTIMIZATION (QML LAYER)</a:t>
+            </a:r>
+          </a:p>
+        </p:txBody>
+      </p:sp>
+      <p:sp>
+        <p:nvSpPr>
+          <p:cNvPr id="3" name="Content Placeholder 2"/>
+          <p:cNvSpPr>
+            <a:spLocks noGrp="1"/>
+          </p:cNvSpPr>
+          <p:nvPr>
+            <p:ph idx="1" sz="quarter"/>
+          </p:nvPr>
+        </p:nvSpPr>
+        <p:spPr/>
+        <p:txBody>
+          <a:bodyPr wrap="square"/>
+          <a:lstStyle/>
           <a:p>
             <a:pPr>
               <a:spcAft>
-                <a:spcPts val="1200"/>
+                <a:spcPts val="1400"/>
               </a:spcAft>
-              <a:defRPr sz="1600">
-                <a:solidFill>
-                  <a:srgbClr val="DCF0FF"/>
-                </a:solidFill>
-              </a:defRPr>
-            </a:pPr>
-            <a:r>
-              <a:t>• Entangling Circuit: Employs a Ring CNOT entangler to learn inter-agent correlations.</a:t>
+            </a:pPr>
+            <a:r>
+              <a:rPr sz="1500">
+                <a:solidFill>
+                  <a:srgbClr val="283241"/>
+                </a:solidFill>
+                <a:latin typeface="Exo 2"/>
+              </a:rPr>
+              <a:t>State Encoding: Maps the 4 Agent risk variables directly to 4 Qubits (Q0 to Q3).</a:t>
             </a:r>
           </a:p>
           <a:p>
             <a:pPr>
               <a:spcAft>
-                <a:spcPts val="1200"/>
+                <a:spcPts val="1400"/>
               </a:spcAft>
-              <a:defRPr sz="1600">
-                <a:solidFill>
-                  <a:srgbClr val="DCF0FF"/>
-                </a:solidFill>
-              </a:defRPr>
-            </a:pPr>
-            <a:r>
-              <a:t>• Dynamic Weighting: Aggregates risk dynamically based on Qubit Z-coordinate excitation.</a:t>
+            </a:pPr>
+            <a:r>
+              <a:rPr sz="1500">
+                <a:solidFill>
+                  <a:srgbClr val="283241"/>
+                </a:solidFill>
+                <a:latin typeface="Exo 2"/>
+              </a:rPr>
+              <a:t>Entangling Circuit: Employs a Ring CNOT entangler to learn non-linear inter-agent correlations.</a:t>
             </a:r>
           </a:p>
           <a:p>
             <a:pPr>
               <a:spcAft>
-                <a:spcPts val="1200"/>
+                <a:spcPts val="1400"/>
               </a:spcAft>
-              <a:defRPr sz="1600">
-                <a:solidFill>
-                  <a:srgbClr val="DCF0FF"/>
-                </a:solidFill>
-              </a:defRPr>
-            </a:pPr>
-            <a:r>
-              <a:t>• Bloch Projections: Agent weights are proportional to excitation (Weight = 1.0 - Z).</a:t>
+            </a:pPr>
+            <a:r>
+              <a:rPr sz="1500">
+                <a:solidFill>
+                  <a:srgbClr val="283241"/>
+                </a:solidFill>
+                <a:latin typeface="Exo 2"/>
+              </a:rPr>
+              <a:t>Dynamic Weighting: Aggregates risk dynamically based on Qubit Z-coordinate excitation.</a:t>
             </a:r>
           </a:p>
           <a:p>
             <a:pPr>
               <a:spcAft>
-                <a:spcPts val="1200"/>
+                <a:spcPts val="1400"/>
               </a:spcAft>
-              <a:defRPr sz="1600">
-                <a:solidFill>
-                  <a:srgbClr val="DCF0FF"/>
-                </a:solidFill>
-              </a:defRPr>
-            </a:pPr>
-            <a:r>
-              <a:t>• Benefit: Captures non-linear threat vectors using 90% fewer parameters than classical NN.</a:t>
+            </a:pPr>
+            <a:r>
+              <a:rPr sz="1500">
+                <a:solidFill>
+                  <a:srgbClr val="283241"/>
+                </a:solidFill>
+                <a:latin typeface="Exo 2"/>
+              </a:rPr>
+              <a:t>Bloch Projections: Agent weights are proportional to excitation (Weight = 1.0 - Z).</a:t>
+            </a:r>
+          </a:p>
+          <a:p>
+            <a:pPr>
+              <a:spcAft>
+                <a:spcPts val="1400"/>
+              </a:spcAft>
+            </a:pPr>
+            <a:r>
+              <a:rPr sz="1500">
+                <a:solidFill>
+                  <a:srgbClr val="283241"/>
+                </a:solidFill>
+                <a:latin typeface="Exo 2"/>
+              </a:rPr>
+              <a:t>Benefit: Captures non-linear threat vectors using 90% fewer parameters than classical NN.</a:t>
             </a:r>
           </a:p>
         </p:txBody>
@@ -7302,6 +8288,14 @@
           <a:bodyPr/>
           <a:lstStyle/>
           <a:p>
+            <a:pPr>
+              <a:defRPr sz="2800" b="1">
+                <a:solidFill>
+                  <a:srgbClr val="0A2D50"/>
+                </a:solidFill>
+                <a:latin typeface="Rajdhani"/>
+              </a:defRPr>
+            </a:pPr>
             <a:r>
               <a:t>4. ADAPTIVE CONTEXT THRESHOLD ENGINE</a:t>
             </a:r>
@@ -7325,76 +8319,224 @@
           <a:p>
             <a:pPr>
               <a:spcAft>
-                <a:spcPts val="1200"/>
+                <a:spcPts val="1400"/>
               </a:spcAft>
-              <a:defRPr sz="1600">
-                <a:solidFill>
-                  <a:srgbClr val="DCF0FF"/>
-                </a:solidFill>
+            </a:pPr>
+            <a:r>
+              <a:rPr sz="1500">
+                <a:solidFill>
+                  <a:srgbClr val="283241"/>
+                </a:solidFill>
+                <a:latin typeface="Exo 2"/>
+              </a:rPr>
+              <a:t>Static Limits: Traditional systems block at a flat 80% limit, causing high friction.</a:t>
+            </a:r>
+          </a:p>
+          <a:p>
+            <a:pPr>
+              <a:spcAft>
+                <a:spcPts val="1400"/>
+              </a:spcAft>
+            </a:pPr>
+            <a:r>
+              <a:rPr sz="1500">
+                <a:solidFill>
+                  <a:srgbClr val="283241"/>
+                </a:solidFill>
+                <a:latin typeface="Exo 2"/>
+              </a:rPr>
+              <a:t>Adaptive Threshold: Q-Guard shifts limits dynamically based on transaction context.</a:t>
+            </a:r>
+          </a:p>
+          <a:p>
+            <a:pPr>
+              <a:spcAft>
+                <a:spcPts val="1400"/>
+              </a:spcAft>
+            </a:pPr>
+            <a:r>
+              <a:rPr sz="1500">
+                <a:solidFill>
+                  <a:srgbClr val="283241"/>
+                </a:solidFill>
+                <a:latin typeface="Exo 2"/>
+              </a:rPr>
+              <a:t>Late Night Hour Window (12 AM - 5 AM): Threshold drops to 65% (restrictive).</a:t>
+            </a:r>
+          </a:p>
+          <a:p>
+            <a:pPr>
+              <a:spcAft>
+                <a:spcPts val="1400"/>
+              </a:spcAft>
+            </a:pPr>
+            <a:r>
+              <a:rPr sz="1500">
+                <a:solidFill>
+                  <a:srgbClr val="283241"/>
+                </a:solidFill>
+                <a:latin typeface="Exo 2"/>
+              </a:rPr>
+              <a:t>High chargeback Merchant Terminal: Threshold drops to 58% (tighter security).</a:t>
+            </a:r>
+          </a:p>
+          <a:p>
+            <a:pPr>
+              <a:spcAft>
+                <a:spcPts val="1400"/>
+              </a:spcAft>
+            </a:pPr>
+            <a:r>
+              <a:rPr sz="1500">
+                <a:solidFill>
+                  <a:srgbClr val="283241"/>
+                </a:solidFill>
+                <a:latin typeface="Exo 2"/>
+              </a:rPr>
+              <a:t>Trusted Regular Customer: Threshold rises to 95% (minimizes customer friction).</a:t>
+            </a:r>
+          </a:p>
+        </p:txBody>
+      </p:sp>
+    </p:spTree>
+  </p:cSld>
+  <p:clrMapOvr>
+    <a:masterClrMapping/>
+  </p:clrMapOvr>
+</p:sld>
+</file>
+
+<file path=ppt/slides/slide5.xml><?xml version="1.0" encoding="utf-8"?>
+<p:sld xmlns:a="http://schemas.openxmlformats.org/drawingml/2006/main" xmlns:p="http://schemas.openxmlformats.org/presentationml/2006/main" xmlns:r="http://schemas.openxmlformats.org/officeDocument/2006/relationships">
+  <p:cSld>
+    <p:spTree>
+      <p:nvGrpSpPr>
+        <p:cNvPr id="1" name=""/>
+        <p:cNvGrpSpPr/>
+        <p:nvPr/>
+      </p:nvGrpSpPr>
+      <p:grpSpPr/>
+      <p:sp>
+        <p:nvSpPr>
+          <p:cNvPr id="2" name="Title 1"/>
+          <p:cNvSpPr>
+            <a:spLocks noGrp="1"/>
+          </p:cNvSpPr>
+          <p:nvPr>
+            <p:ph type="title"/>
+          </p:nvPr>
+        </p:nvSpPr>
+        <p:spPr/>
+        <p:txBody>
+          <a:bodyPr/>
+          <a:lstStyle/>
+          <a:p>
+            <a:pPr>
+              <a:defRPr sz="2800" b="1">
+                <a:solidFill>
+                  <a:srgbClr val="0A2D50"/>
+                </a:solidFill>
+                <a:latin typeface="Rajdhani"/>
               </a:defRPr>
             </a:pPr>
             <a:r>
-              <a:t>• Standard Thresholds: Traditional banks use static 80% limits (high friction).</a:t>
-            </a:r>
-          </a:p>
+              <a:t>4. ADAPTIVE CONTEXT THRESHOLD ENGINE</a:t>
+            </a:r>
+          </a:p>
+        </p:txBody>
+      </p:sp>
+      <p:sp>
+        <p:nvSpPr>
+          <p:cNvPr id="3" name="Content Placeholder 2"/>
+          <p:cNvSpPr>
+            <a:spLocks noGrp="1"/>
+          </p:cNvSpPr>
+          <p:nvPr>
+            <p:ph idx="1" sz="quarter"/>
+          </p:nvPr>
+        </p:nvSpPr>
+        <p:spPr/>
+        <p:txBody>
+          <a:bodyPr wrap="square"/>
+          <a:lstStyle/>
           <a:p>
             <a:pPr>
               <a:spcAft>
-                <a:spcPts val="1200"/>
+                <a:spcPts val="1400"/>
               </a:spcAft>
-              <a:defRPr sz="1600">
-                <a:solidFill>
-                  <a:srgbClr val="DCF0FF"/>
-                </a:solidFill>
-              </a:defRPr>
-            </a:pPr>
-            <a:r>
-              <a:t>• Adaptive Threshold: Q-Guard shifts limits dynamically based on transaction context.</a:t>
+            </a:pPr>
+            <a:r>
+              <a:rPr sz="1500">
+                <a:solidFill>
+                  <a:srgbClr val="283241"/>
+                </a:solidFill>
+                <a:latin typeface="Exo 2"/>
+              </a:rPr>
+              <a:t>Static Limits: Traditional systems block at a flat 80% limit, causing high friction.</a:t>
             </a:r>
           </a:p>
           <a:p>
             <a:pPr>
               <a:spcAft>
-                <a:spcPts val="1200"/>
+                <a:spcPts val="1400"/>
               </a:spcAft>
-              <a:defRPr sz="1600">
-                <a:solidFill>
-                  <a:srgbClr val="DCF0FF"/>
-                </a:solidFill>
-              </a:defRPr>
-            </a:pPr>
-            <a:r>
-              <a:t>• Late Night Hour Window (12 AM - 5 AM): Threshold drops to 65% (restrictive).</a:t>
+            </a:pPr>
+            <a:r>
+              <a:rPr sz="1500">
+                <a:solidFill>
+                  <a:srgbClr val="283241"/>
+                </a:solidFill>
+                <a:latin typeface="Exo 2"/>
+              </a:rPr>
+              <a:t>Adaptive Threshold: Q-Guard shifts limits dynamically based on transaction context.</a:t>
             </a:r>
           </a:p>
           <a:p>
             <a:pPr>
               <a:spcAft>
-                <a:spcPts val="1200"/>
+                <a:spcPts val="1400"/>
               </a:spcAft>
-              <a:defRPr sz="1600">
-                <a:solidFill>
-                  <a:srgbClr val="DCF0FF"/>
-                </a:solidFill>
-              </a:defRPr>
-            </a:pPr>
-            <a:r>
-              <a:t>• High chargeback Merchant Terminal: Threshold drops to 58% (highly secure).</a:t>
+            </a:pPr>
+            <a:r>
+              <a:rPr sz="1500">
+                <a:solidFill>
+                  <a:srgbClr val="283241"/>
+                </a:solidFill>
+                <a:latin typeface="Exo 2"/>
+              </a:rPr>
+              <a:t>Late Night Hour Window (12 AM - 5 AM): Threshold drops to 65% (restrictive).</a:t>
             </a:r>
           </a:p>
           <a:p>
             <a:pPr>
               <a:spcAft>
-                <a:spcPts val="1200"/>
+                <a:spcPts val="1400"/>
               </a:spcAft>
-              <a:defRPr sz="1600">
-                <a:solidFill>
-                  <a:srgbClr val="DCF0FF"/>
-                </a:solidFill>
-              </a:defRPr>
-            </a:pPr>
-            <a:r>
-              <a:t>• Trusted Regular Customer: Threshold rises to 95% (minimizes customer friction).</a:t>
+            </a:pPr>
+            <a:r>
+              <a:rPr sz="1500">
+                <a:solidFill>
+                  <a:srgbClr val="283241"/>
+                </a:solidFill>
+                <a:latin typeface="Exo 2"/>
+              </a:rPr>
+              <a:t>High chargeback Merchant Terminal: Threshold drops to 58% (tighter security).</a:t>
+            </a:r>
+          </a:p>
+          <a:p>
+            <a:pPr>
+              <a:spcAft>
+                <a:spcPts val="1400"/>
+              </a:spcAft>
+            </a:pPr>
+            <a:r>
+              <a:rPr sz="1500">
+                <a:solidFill>
+                  <a:srgbClr val="283241"/>
+                </a:solidFill>
+                <a:latin typeface="Exo 2"/>
+              </a:rPr>
+              <a:t>Trusted Regular Customer: Threshold rises to 95% (minimizes customer friction).</a:t>
             </a:r>
           </a:p>
         </p:txBody>
@@ -7432,8 +8574,16 @@
           <a:bodyPr/>
           <a:lstStyle/>
           <a:p>
-            <a:r>
-              <a:t>5. SELF-EXPLAINABLE AI &amp; MITIGATION CHECKLISTS</a:t>
+            <a:pPr>
+              <a:defRPr sz="2800" b="1">
+                <a:solidFill>
+                  <a:srgbClr val="0A2D50"/>
+                </a:solidFill>
+                <a:latin typeface="Rajdhani"/>
+              </a:defRPr>
+            </a:pPr>
+            <a:r>
+              <a:t>5. SELF-EXPLAINABLE AI &amp; STRATEGY MITIGATION</a:t>
             </a:r>
           </a:p>
         </p:txBody>
@@ -7455,76 +8605,81 @@
           <a:p>
             <a:pPr>
               <a:spcAft>
-                <a:spcPts val="1200"/>
+                <a:spcPts val="1400"/>
               </a:spcAft>
-              <a:defRPr sz="1600">
-                <a:solidFill>
-                  <a:srgbClr val="DCF0FF"/>
-                </a:solidFill>
-              </a:defRPr>
-            </a:pPr>
-            <a:r>
-              <a:t>• Self-Explainable AI (XAI): Translates VQC state vectors into warning logs.</a:t>
+            </a:pPr>
+            <a:r>
+              <a:rPr sz="1500">
+                <a:solidFill>
+                  <a:srgbClr val="283241"/>
+                </a:solidFill>
+                <a:latin typeface="Exo 2"/>
+              </a:rPr>
+              <a:t>Self-Explainable AI (XAI): Translates VQC state vectors into natural language warning logs.</a:t>
             </a:r>
           </a:p>
           <a:p>
             <a:pPr>
               <a:spcAft>
-                <a:spcPts val="1200"/>
+                <a:spcPts val="1400"/>
               </a:spcAft>
-              <a:defRPr sz="1600">
-                <a:solidFill>
-                  <a:srgbClr val="DCF0FF"/>
-                </a:solidFill>
-              </a:defRPr>
-            </a:pPr>
-            <a:r>
-              <a:t>• Auditable Compliance: Outlines exactly why an agent triggered the transaction block.</a:t>
+            </a:pPr>
+            <a:r>
+              <a:rPr sz="1500">
+                <a:solidFill>
+                  <a:srgbClr val="283241"/>
+                </a:solidFill>
+                <a:latin typeface="Exo 2"/>
+              </a:rPr>
+              <a:t>Auditable Compliance: Outlines exactly why an agent triggered the transaction block.</a:t>
             </a:r>
           </a:p>
           <a:p>
             <a:pPr>
               <a:spcAft>
-                <a:spcPts val="1200"/>
+                <a:spcPts val="1400"/>
               </a:spcAft>
-              <a:defRPr sz="1600">
-                <a:solidFill>
-                  <a:srgbClr val="DCF0FF"/>
-                </a:solidFill>
-              </a:defRPr>
-            </a:pPr>
-            <a:r>
-              <a:t>• Fraud Strategy Advisor: Recommends progressive mitigation checklists instead of binary blocks.</a:t>
+            </a:pPr>
+            <a:r>
+              <a:rPr sz="1500">
+                <a:solidFill>
+                  <a:srgbClr val="283241"/>
+                </a:solidFill>
+                <a:latin typeface="Exo 2"/>
+              </a:rPr>
+              <a:t>Fraud Strategy Advisor: Recommends progressive mitigation checklists instead of binary blocks.</a:t>
             </a:r>
           </a:p>
           <a:p>
             <a:pPr>
               <a:spcAft>
-                <a:spcPts val="1200"/>
+                <a:spcPts val="1400"/>
               </a:spcAft>
-              <a:defRPr sz="1600">
-                <a:solidFill>
-                  <a:srgbClr val="DCF0FF"/>
-                </a:solidFill>
-              </a:defRPr>
-            </a:pPr>
-            <a:r>
-              <a:t>• Mitigation Checklist: Request Face Authentication, Require SMS OTP, or Hold payout.</a:t>
+            </a:pPr>
+            <a:r>
+              <a:rPr sz="1500">
+                <a:solidFill>
+                  <a:srgbClr val="283241"/>
+                </a:solidFill>
+                <a:latin typeface="Exo 2"/>
+              </a:rPr>
+              <a:t>Mitigation Checklist: Request Face Authentication, Require SMS OTP, or Hold payout.</a:t>
             </a:r>
           </a:p>
           <a:p>
             <a:pPr>
               <a:spcAft>
-                <a:spcPts val="1200"/>
+                <a:spcPts val="1400"/>
               </a:spcAft>
-              <a:defRPr sz="1600">
-                <a:solidFill>
-                  <a:srgbClr val="DCF0FF"/>
-                </a:solidFill>
-              </a:defRPr>
-            </a:pPr>
-            <a:r>
-              <a:t>• Benefit: Reduces manual review audit delays and matches regulatory frameworks.</a:t>
+            </a:pPr>
+            <a:r>
+              <a:rPr sz="1500">
+                <a:solidFill>
+                  <a:srgbClr val="283241"/>
+                </a:solidFill>
+                <a:latin typeface="Exo 2"/>
+              </a:rPr>
+              <a:t>Benefit: Matches regulatory audit frameworks while keeping user friction minimal.</a:t>
             </a:r>
           </a:p>
         </p:txBody>
@@ -7562,8 +8717,16 @@
           <a:bodyPr/>
           <a:lstStyle/>
           <a:p>
-            <a:r>
-              <a:t>6. SCALABILITY &amp; DATABASE PIPELINE Integration</a:t>
+            <a:pPr>
+              <a:defRPr sz="2800" b="1">
+                <a:solidFill>
+                  <a:srgbClr val="0A2D50"/>
+                </a:solidFill>
+                <a:latin typeface="Rajdhani"/>
+              </a:defRPr>
+            </a:pPr>
+            <a:r>
+              <a:t>6. SCALABILITY &amp; DATABASE PIPELINE INTEGRATION</a:t>
             </a:r>
           </a:p>
         </p:txBody>
@@ -7585,76 +8748,510 @@
           <a:p>
             <a:pPr>
               <a:spcAft>
-                <a:spcPts val="1200"/>
+                <a:spcPts val="1400"/>
               </a:spcAft>
-              <a:defRPr sz="1600">
-                <a:solidFill>
-                  <a:srgbClr val="DCF0FF"/>
-                </a:solidFill>
+            </a:pPr>
+            <a:r>
+              <a:rPr sz="1500">
+                <a:solidFill>
+                  <a:srgbClr val="283241"/>
+                </a:solidFill>
+                <a:latin typeface="Exo 2"/>
+              </a:rPr>
+              <a:t>Kaggle Database: Integrated with 3,000 real-world transaction logs (IEEE-CIS).</a:t>
+            </a:r>
+          </a:p>
+          <a:p>
+            <a:pPr>
+              <a:spcAft>
+                <a:spcPts val="1400"/>
+              </a:spcAft>
+            </a:pPr>
+            <a:r>
+              <a:rPr sz="1500">
+                <a:solidFill>
+                  <a:srgbClr val="283241"/>
+                </a:solidFill>
+                <a:latin typeface="Exo 2"/>
+              </a:rPr>
+              <a:t>MongoDB Integration: Stores transactions and quantum telemetry in indexed collections.</a:t>
+            </a:r>
+          </a:p>
+          <a:p>
+            <a:pPr>
+              <a:spcAft>
+                <a:spcPts val="1400"/>
+              </a:spcAft>
+            </a:pPr>
+            <a:r>
+              <a:rPr sz="1500">
+                <a:solidFill>
+                  <a:srgbClr val="283241"/>
+                </a:solidFill>
+                <a:latin typeface="Exo 2"/>
+              </a:rPr>
+              <a:t>FastAPI REST endpoints: Exposes VQC coordinates, dynamic weights, and strategies.</a:t>
+            </a:r>
+          </a:p>
+          <a:p>
+            <a:pPr>
+              <a:spcAft>
+                <a:spcPts val="1400"/>
+              </a:spcAft>
+            </a:pPr>
+            <a:r>
+              <a:rPr sz="1500">
+                <a:solidFill>
+                  <a:srgbClr val="283241"/>
+                </a:solidFill>
+                <a:latin typeface="Exo 2"/>
+              </a:rPr>
+              <a:t>Vercel Deployment: Standalone HTML visualizer deployed live on cloud static servers.</a:t>
+            </a:r>
+          </a:p>
+          <a:p>
+            <a:pPr>
+              <a:spcAft>
+                <a:spcPts val="1400"/>
+              </a:spcAft>
+            </a:pPr>
+            <a:r>
+              <a:rPr sz="1500">
+                <a:solidFill>
+                  <a:srgbClr val="283241"/>
+                </a:solidFill>
+                <a:latin typeface="Exo 2"/>
+              </a:rPr>
+              <a:t>Result: A scalable, production-grade Quantum-Graph system ready for deployment.</a:t>
+            </a:r>
+          </a:p>
+        </p:txBody>
+      </p:sp>
+    </p:spTree>
+  </p:cSld>
+  <p:clrMapOvr>
+    <a:masterClrMapping/>
+  </p:clrMapOvr>
+</p:sld>
+</file>
+
+<file path=ppt/slides/slide7.xml><?xml version="1.0" encoding="utf-8"?>
+<p:sld xmlns:a="http://schemas.openxmlformats.org/drawingml/2006/main" xmlns:p="http://schemas.openxmlformats.org/presentationml/2006/main" xmlns:r="http://schemas.openxmlformats.org/officeDocument/2006/relationships">
+  <p:cSld>
+    <p:spTree>
+      <p:nvGrpSpPr>
+        <p:cNvPr id="1" name=""/>
+        <p:cNvGrpSpPr/>
+        <p:nvPr/>
+      </p:nvGrpSpPr>
+      <p:grpSpPr/>
+      <p:sp>
+        <p:nvSpPr>
+          <p:cNvPr id="2" name="Title 1"/>
+          <p:cNvSpPr>
+            <a:spLocks noGrp="1"/>
+          </p:cNvSpPr>
+          <p:nvPr>
+            <p:ph type="title"/>
+          </p:nvPr>
+        </p:nvSpPr>
+        <p:spPr/>
+        <p:txBody>
+          <a:bodyPr/>
+          <a:lstStyle/>
+          <a:p>
+            <a:pPr>
+              <a:defRPr sz="2800" b="1">
+                <a:solidFill>
+                  <a:srgbClr val="0A2D50"/>
+                </a:solidFill>
+                <a:latin typeface="Rajdhani"/>
               </a:defRPr>
             </a:pPr>
             <a:r>
-              <a:t>• Kaggle Database: Integrated with 3,000 real-world transaction logs (IEEE-CIS).</a:t>
-            </a:r>
-          </a:p>
+              <a:t>6. SCALABILITY &amp; DATABASE PIPELINE INTEGRATION</a:t>
+            </a:r>
+          </a:p>
+        </p:txBody>
+      </p:sp>
+      <p:sp>
+        <p:nvSpPr>
+          <p:cNvPr id="3" name="Content Placeholder 2"/>
+          <p:cNvSpPr>
+            <a:spLocks noGrp="1"/>
+          </p:cNvSpPr>
+          <p:nvPr>
+            <p:ph idx="1" sz="quarter"/>
+          </p:nvPr>
+        </p:nvSpPr>
+        <p:spPr/>
+        <p:txBody>
+          <a:bodyPr wrap="square"/>
+          <a:lstStyle/>
           <a:p>
             <a:pPr>
               <a:spcAft>
-                <a:spcPts val="1200"/>
+                <a:spcPts val="1400"/>
               </a:spcAft>
-              <a:defRPr sz="1600">
-                <a:solidFill>
-                  <a:srgbClr val="DCF0FF"/>
-                </a:solidFill>
+            </a:pPr>
+            <a:r>
+              <a:rPr sz="1500">
+                <a:solidFill>
+                  <a:srgbClr val="283241"/>
+                </a:solidFill>
+                <a:latin typeface="Exo 2"/>
+              </a:rPr>
+              <a:t>Kaggle Database: Integrated with 3,000 real-world transaction logs (IEEE-CIS).</a:t>
+            </a:r>
+          </a:p>
+          <a:p>
+            <a:pPr>
+              <a:spcAft>
+                <a:spcPts val="1400"/>
+              </a:spcAft>
+            </a:pPr>
+            <a:r>
+              <a:rPr sz="1500">
+                <a:solidFill>
+                  <a:srgbClr val="283241"/>
+                </a:solidFill>
+                <a:latin typeface="Exo 2"/>
+              </a:rPr>
+              <a:t>MongoDB Integration: Stores transactions and quantum telemetry in indexed collections.</a:t>
+            </a:r>
+          </a:p>
+          <a:p>
+            <a:pPr>
+              <a:spcAft>
+                <a:spcPts val="1400"/>
+              </a:spcAft>
+            </a:pPr>
+            <a:r>
+              <a:rPr sz="1500">
+                <a:solidFill>
+                  <a:srgbClr val="283241"/>
+                </a:solidFill>
+                <a:latin typeface="Exo 2"/>
+              </a:rPr>
+              <a:t>FastAPI REST endpoints: Exposes VQC coordinates, dynamic weights, and strategies.</a:t>
+            </a:r>
+          </a:p>
+          <a:p>
+            <a:pPr>
+              <a:spcAft>
+                <a:spcPts val="1400"/>
+              </a:spcAft>
+            </a:pPr>
+            <a:r>
+              <a:rPr sz="1500">
+                <a:solidFill>
+                  <a:srgbClr val="283241"/>
+                </a:solidFill>
+                <a:latin typeface="Exo 2"/>
+              </a:rPr>
+              <a:t>Vercel Deployment: Standalone HTML visualizer deployed live on cloud static servers.</a:t>
+            </a:r>
+          </a:p>
+          <a:p>
+            <a:pPr>
+              <a:spcAft>
+                <a:spcPts val="1400"/>
+              </a:spcAft>
+            </a:pPr>
+            <a:r>
+              <a:rPr sz="1500">
+                <a:solidFill>
+                  <a:srgbClr val="283241"/>
+                </a:solidFill>
+                <a:latin typeface="Exo 2"/>
+              </a:rPr>
+              <a:t>Result: A scalable, production-grade Quantum-Graph system ready for deployment.</a:t>
+            </a:r>
+          </a:p>
+        </p:txBody>
+      </p:sp>
+    </p:spTree>
+  </p:cSld>
+  <p:clrMapOvr>
+    <a:masterClrMapping/>
+  </p:clrMapOvr>
+</p:sld>
+</file>
+
+<file path=ppt/slides/slide8.xml><?xml version="1.0" encoding="utf-8"?>
+<p:sld xmlns:a="http://schemas.openxmlformats.org/drawingml/2006/main" xmlns:p="http://schemas.openxmlformats.org/presentationml/2006/main" xmlns:r="http://schemas.openxmlformats.org/officeDocument/2006/relationships">
+  <p:cSld>
+    <p:spTree>
+      <p:nvGrpSpPr>
+        <p:cNvPr id="1" name=""/>
+        <p:cNvGrpSpPr/>
+        <p:nvPr/>
+      </p:nvGrpSpPr>
+      <p:grpSpPr/>
+      <p:sp>
+        <p:nvSpPr>
+          <p:cNvPr id="2" name="Title 1"/>
+          <p:cNvSpPr>
+            <a:spLocks noGrp="1"/>
+          </p:cNvSpPr>
+          <p:nvPr>
+            <p:ph type="title"/>
+          </p:nvPr>
+        </p:nvSpPr>
+        <p:spPr/>
+        <p:txBody>
+          <a:bodyPr/>
+          <a:lstStyle/>
+          <a:p>
+            <a:pPr>
+              <a:defRPr sz="2800" b="1">
+                <a:solidFill>
+                  <a:srgbClr val="0A2D50"/>
+                </a:solidFill>
+                <a:latin typeface="Rajdhani"/>
               </a:defRPr>
             </a:pPr>
             <a:r>
-              <a:t>• MongoDB Integration: Stores transactions and quantum telemetry in indexed collections.</a:t>
-            </a:r>
-          </a:p>
+              <a:t>2. Q-GUARD ARCHITECTURE: MULTI-AGENT INGESTION</a:t>
+            </a:r>
+          </a:p>
+        </p:txBody>
+      </p:sp>
+      <p:sp>
+        <p:nvSpPr>
+          <p:cNvPr id="3" name="Content Placeholder 2"/>
+          <p:cNvSpPr>
+            <a:spLocks noGrp="1"/>
+          </p:cNvSpPr>
+          <p:nvPr>
+            <p:ph idx="1" sz="quarter"/>
+          </p:nvPr>
+        </p:nvSpPr>
+        <p:spPr/>
+        <p:txBody>
+          <a:bodyPr wrap="square"/>
+          <a:lstStyle/>
           <a:p>
             <a:pPr>
               <a:spcAft>
-                <a:spcPts val="1200"/>
+                <a:spcPts val="1400"/>
               </a:spcAft>
-              <a:defRPr sz="1600">
-                <a:solidFill>
-                  <a:srgbClr val="DCF0FF"/>
-                </a:solidFill>
+            </a:pPr>
+            <a:r>
+              <a:rPr sz="1500">
+                <a:solidFill>
+                  <a:srgbClr val="283241"/>
+                </a:solidFill>
+                <a:latin typeface="Exo 2"/>
+              </a:rPr>
+              <a:t>User Behavior Agent: Analyzes daily spending limit fractions and transaction volume.</a:t>
+            </a:r>
+          </a:p>
+          <a:p>
+            <a:pPr>
+              <a:spcAft>
+                <a:spcPts val="1400"/>
+              </a:spcAft>
+            </a:pPr>
+            <a:r>
+              <a:rPr sz="1500">
+                <a:solidFill>
+                  <a:srgbClr val="283241"/>
+                </a:solidFill>
+                <a:latin typeface="Exo 2"/>
+              </a:rPr>
+              <a:t>Device Intelligence Agent: Detects OS versions, emulators, and device trust rating.</a:t>
+            </a:r>
+          </a:p>
+          <a:p>
+            <a:pPr>
+              <a:spcAft>
+                <a:spcPts val="1400"/>
+              </a:spcAft>
+            </a:pPr>
+            <a:r>
+              <a:rPr sz="1500">
+                <a:solidFill>
+                  <a:srgbClr val="283241"/>
+                </a:solidFill>
+                <a:latin typeface="Exo 2"/>
+              </a:rPr>
+              <a:t>Merchant Rating Agent: Assesses merchant category hazard and chargeback rates.</a:t>
+            </a:r>
+          </a:p>
+          <a:p>
+            <a:pPr>
+              <a:spcAft>
+                <a:spcPts val="1400"/>
+              </a:spcAft>
+            </a:pPr>
+            <a:r>
+              <a:rPr sz="1500">
+                <a:solidFill>
+                  <a:srgbClr val="283241"/>
+                </a:solidFill>
+                <a:latin typeface="Exo 2"/>
+              </a:rPr>
+              <a:t>Network Intelligence Agent: Monitors VPN usage, proxy IPs, and impossible travel.</a:t>
+            </a:r>
+          </a:p>
+          <a:p>
+            <a:pPr>
+              <a:spcAft>
+                <a:spcPts val="1400"/>
+              </a:spcAft>
+            </a:pPr>
+            <a:r>
+              <a:rPr sz="1500">
+                <a:solidFill>
+                  <a:srgbClr val="283241"/>
+                </a:solidFill>
+                <a:latin typeface="Exo 2"/>
+              </a:rPr>
+              <a:t>Decentralized Ingestion: Captures separate threat layers simultaneously to prevent bypass.</a:t>
+            </a:r>
+          </a:p>
+        </p:txBody>
+      </p:sp>
+    </p:spTree>
+  </p:cSld>
+  <p:clrMapOvr>
+    <a:masterClrMapping/>
+  </p:clrMapOvr>
+</p:sld>
+</file>
+
+<file path=ppt/slides/slide9.xml><?xml version="1.0" encoding="utf-8"?>
+<p:sld xmlns:a="http://schemas.openxmlformats.org/drawingml/2006/main" xmlns:p="http://schemas.openxmlformats.org/presentationml/2006/main" xmlns:r="http://schemas.openxmlformats.org/officeDocument/2006/relationships">
+  <p:cSld>
+    <p:spTree>
+      <p:nvGrpSpPr>
+        <p:cNvPr id="1" name=""/>
+        <p:cNvGrpSpPr/>
+        <p:nvPr/>
+      </p:nvGrpSpPr>
+      <p:grpSpPr/>
+      <p:sp>
+        <p:nvSpPr>
+          <p:cNvPr id="2" name="Title 1"/>
+          <p:cNvSpPr>
+            <a:spLocks noGrp="1"/>
+          </p:cNvSpPr>
+          <p:nvPr>
+            <p:ph type="title"/>
+          </p:nvPr>
+        </p:nvSpPr>
+        <p:spPr/>
+        <p:txBody>
+          <a:bodyPr/>
+          <a:lstStyle/>
+          <a:p>
+            <a:pPr>
+              <a:defRPr sz="2800" b="1">
+                <a:solidFill>
+                  <a:srgbClr val="0A2D50"/>
+                </a:solidFill>
+                <a:latin typeface="Rajdhani"/>
               </a:defRPr>
             </a:pPr>
             <a:r>
-              <a:t>• FastAPI REST endpoints: Exposes VQC coordinates, dynamic weights, and strategies.</a:t>
-            </a:r>
-          </a:p>
+              <a:t>3. QUANTUM WEIGHT OPTIMIZATION (QML LAYER)</a:t>
+            </a:r>
+          </a:p>
+        </p:txBody>
+      </p:sp>
+      <p:sp>
+        <p:nvSpPr>
+          <p:cNvPr id="3" name="Content Placeholder 2"/>
+          <p:cNvSpPr>
+            <a:spLocks noGrp="1"/>
+          </p:cNvSpPr>
+          <p:nvPr>
+            <p:ph idx="1" sz="quarter"/>
+          </p:nvPr>
+        </p:nvSpPr>
+        <p:spPr/>
+        <p:txBody>
+          <a:bodyPr wrap="square"/>
+          <a:lstStyle/>
           <a:p>
             <a:pPr>
               <a:spcAft>
-                <a:spcPts val="1200"/>
+                <a:spcPts val="1400"/>
               </a:spcAft>
-              <a:defRPr sz="1600">
-                <a:solidFill>
-                  <a:srgbClr val="DCF0FF"/>
-                </a:solidFill>
-              </a:defRPr>
-            </a:pPr>
-            <a:r>
-              <a:t>• Vercel Deployment: Standalone HTML visualizer deployed live on cloud static servers.</a:t>
+            </a:pPr>
+            <a:r>
+              <a:rPr sz="1500">
+                <a:solidFill>
+                  <a:srgbClr val="283241"/>
+                </a:solidFill>
+                <a:latin typeface="Exo 2"/>
+              </a:rPr>
+              <a:t>State Encoding: Maps the 4 Agent risk variables directly to 4 Qubits (Q0 to Q3).</a:t>
             </a:r>
           </a:p>
           <a:p>
             <a:pPr>
               <a:spcAft>
-                <a:spcPts val="1200"/>
+                <a:spcPts val="1400"/>
               </a:spcAft>
-              <a:defRPr sz="1600">
-                <a:solidFill>
-                  <a:srgbClr val="DCF0FF"/>
-                </a:solidFill>
-              </a:defRPr>
-            </a:pPr>
-            <a:r>
-              <a:t>• Result: A scalable, production-grade Quantum-Graph system ready for deployment.</a:t>
+            </a:pPr>
+            <a:r>
+              <a:rPr sz="1500">
+                <a:solidFill>
+                  <a:srgbClr val="283241"/>
+                </a:solidFill>
+                <a:latin typeface="Exo 2"/>
+              </a:rPr>
+              <a:t>Entangling Circuit: Employs a Ring CNOT entangler to learn non-linear inter-agent correlations.</a:t>
+            </a:r>
+          </a:p>
+          <a:p>
+            <a:pPr>
+              <a:spcAft>
+                <a:spcPts val="1400"/>
+              </a:spcAft>
+            </a:pPr>
+            <a:r>
+              <a:rPr sz="1500">
+                <a:solidFill>
+                  <a:srgbClr val="283241"/>
+                </a:solidFill>
+                <a:latin typeface="Exo 2"/>
+              </a:rPr>
+              <a:t>Dynamic Weighting: Aggregates risk dynamically based on Qubit Z-coordinate excitation.</a:t>
+            </a:r>
+          </a:p>
+          <a:p>
+            <a:pPr>
+              <a:spcAft>
+                <a:spcPts val="1400"/>
+              </a:spcAft>
+            </a:pPr>
+            <a:r>
+              <a:rPr sz="1500">
+                <a:solidFill>
+                  <a:srgbClr val="283241"/>
+                </a:solidFill>
+                <a:latin typeface="Exo 2"/>
+              </a:rPr>
+              <a:t>Bloch Projections: Agent weights are proportional to excitation (Weight = 1.0 - Z).</a:t>
+            </a:r>
+          </a:p>
+          <a:p>
+            <a:pPr>
+              <a:spcAft>
+                <a:spcPts val="1400"/>
+              </a:spcAft>
+            </a:pPr>
+            <a:r>
+              <a:rPr sz="1500">
+                <a:solidFill>
+                  <a:srgbClr val="283241"/>
+                </a:solidFill>
+                <a:latin typeface="Exo 2"/>
+              </a:rPr>
+              <a:t>Benefit: Captures non-linear threat vectors using 90% fewer parameters than classical NN.</a:t>
             </a:r>
           </a:p>
         </p:txBody>

</xml_diff>

<commit_message>
Restore original PPT template to allow manual slide writing
</commit_message>
<xml_diff>
--- a/RIT - Quantathan 2026 - PPT.pptx
+++ b/RIT - Quantathan 2026 - PPT.pptx
@@ -9,12 +9,12 @@
   </p:notesMasterIdLst>
   <p:sldIdLst>
     <p:sldId id="256" r:id="rId2"/>
-    <p:sldId id="257" r:id="rId20"/>
-    <p:sldId id="258" r:id="rId21"/>
-    <p:sldId id="259" r:id="rId22"/>
-    <p:sldId id="260" r:id="rId23"/>
-    <p:sldId id="261" r:id="rId24"/>
-    <p:sldId id="262" r:id="rId25"/>
+    <p:sldId id="257" r:id="rId3"/>
+    <p:sldId id="258" r:id="rId9"/>
+    <p:sldId id="259" r:id="rId10"/>
+    <p:sldId id="260" r:id="rId11"/>
+    <p:sldId id="261" r:id="rId12"/>
+    <p:sldId id="262" r:id="rId13"/>
   </p:sldIdLst>
   <p:sldSz cx="9144000" cy="6858000" type="screen4x3"/>
   <p:notesSz cx="6858000" cy="9144000"/>
@@ -6833,137 +6833,168 @@
 </p:sld>
 </file>
 
-<file path=ppt/slides/slide10.xml><?xml version="1.0" encoding="utf-8"?>
-<p:sld xmlns:a="http://schemas.openxmlformats.org/drawingml/2006/main" xmlns:p="http://schemas.openxmlformats.org/presentationml/2006/main" xmlns:r="http://schemas.openxmlformats.org/officeDocument/2006/relationships">
+<file path=ppt/slides/slide2.xml><?xml version="1.0" encoding="utf-8"?>
+<p:sld xmlns:a="http://schemas.openxmlformats.org/drawingml/2006/main" xmlns:r="http://schemas.openxmlformats.org/officeDocument/2006/relationships" xmlns:p="http://schemas.openxmlformats.org/presentationml/2006/main">
   <p:cSld>
+    <p:bg>
+      <p:bgPr>
+        <a:blipFill dpi="0" rotWithShape="1">
+          <a:blip r:embed="rId3" cstate="print">
+            <a:lum/>
+          </a:blip>
+          <a:srcRect/>
+          <a:stretch>
+            <a:fillRect l="-24000" r="-24000"/>
+          </a:stretch>
+        </a:blipFill>
+        <a:effectLst/>
+      </p:bgPr>
+    </p:bg>
     <p:spTree>
       <p:nvGrpSpPr>
         <p:cNvPr id="1" name=""/>
         <p:cNvGrpSpPr/>
         <p:nvPr/>
       </p:nvGrpSpPr>
-      <p:grpSpPr/>
-      <p:sp>
-        <p:nvSpPr>
-          <p:cNvPr id="2" name="Title 1"/>
-          <p:cNvSpPr>
-            <a:spLocks noGrp="1"/>
-          </p:cNvSpPr>
-          <p:nvPr>
-            <p:ph type="title"/>
-          </p:nvPr>
-        </p:nvSpPr>
-        <p:spPr/>
-        <p:txBody>
-          <a:bodyPr/>
+      <p:grpSpPr>
+        <a:xfrm>
+          <a:off x="0" y="0"/>
+          <a:ext cx="0" cy="0"/>
+          <a:chOff x="0" y="0"/>
+          <a:chExt cx="0" cy="0"/>
+        </a:xfrm>
+      </p:grpSpPr>
+      <p:sp>
+        <p:nvSpPr>
+          <p:cNvPr id="2" name="TextBox 1"/>
+          <p:cNvSpPr txBox="1"/>
+          <p:nvPr/>
+        </p:nvSpPr>
+        <p:spPr>
+          <a:xfrm>
+            <a:off x="685800" y="457200"/>
+            <a:ext cx="7772400" cy="914400"/>
+          </a:xfrm>
+          <a:prstGeom prst="rect">
+            <a:avLst/>
+          </a:prstGeom>
+          <a:noFill/>
+        </p:spPr>
+        <p:txBody>
+          <a:bodyPr wrap="none">
+            <a:spAutoFit/>
+          </a:bodyPr>
           <a:lstStyle/>
           <a:p>
             <a:pPr>
               <a:defRPr sz="2800" b="1">
                 <a:solidFill>
-                  <a:srgbClr val="0A2D50"/>
+                  <a:srgbClr val="00D4FF"/>
                 </a:solidFill>
                 <a:latin typeface="Rajdhani"/>
               </a:defRPr>
             </a:pPr>
             <a:r>
-              <a:t>4. ADAPTIVE CONTEXT THRESHOLD ENGINE</a:t>
-            </a:r>
-          </a:p>
-        </p:txBody>
-      </p:sp>
-      <p:sp>
-        <p:nvSpPr>
-          <p:cNvPr id="3" name="Content Placeholder 2"/>
-          <p:cNvSpPr>
-            <a:spLocks noGrp="1"/>
-          </p:cNvSpPr>
-          <p:nvPr>
-            <p:ph idx="1" sz="quarter"/>
-          </p:nvPr>
-        </p:nvSpPr>
-        <p:spPr/>
-        <p:txBody>
-          <a:bodyPr wrap="square"/>
-          <a:lstStyle/>
+              <a:t>1. PROBLEM STATEMENT (QT-2.8)</a:t>
+            </a:r>
+          </a:p>
+        </p:txBody>
+      </p:sp>
+      <p:sp>
+        <p:nvSpPr>
+          <p:cNvPr id="3" name="TextBox 2"/>
+          <p:cNvSpPr txBox="1"/>
+          <p:nvPr/>
+        </p:nvSpPr>
+        <p:spPr>
+          <a:xfrm>
+            <a:off x="685800" y="1645920"/>
+            <a:ext cx="7772400" cy="4114800"/>
+          </a:xfrm>
+          <a:prstGeom prst="rect">
+            <a:avLst/>
+          </a:prstGeom>
+          <a:noFill/>
+        </p:spPr>
+        <p:txBody>
+          <a:bodyPr wrap="square">
+            <a:spAutoFit/>
+          </a:bodyPr>
+          <a:lstStyle/>
+          <a:p/>
           <a:p>
             <a:pPr>
               <a:spcAft>
-                <a:spcPts val="1400"/>
+                <a:spcPts val="1200"/>
               </a:spcAft>
+              <a:defRPr sz="1600">
+                <a:solidFill>
+                  <a:srgbClr val="DCF0FF"/>
+                </a:solidFill>
+              </a:defRPr>
             </a:pPr>
             <a:r>
-              <a:rPr sz="1500">
-                <a:solidFill>
-                  <a:srgbClr val="283241"/>
-                </a:solidFill>
-                <a:latin typeface="Exo 2"/>
-              </a:rPr>
-              <a:t>Static Limits: Traditional systems block at a flat 80% limit, causing high friction.</a:t>
+              <a:t>• Classical ML models check transactions in isolation, missing temporal loops.</a:t>
             </a:r>
           </a:p>
           <a:p>
             <a:pPr>
               <a:spcAft>
-                <a:spcPts val="1400"/>
+                <a:spcPts val="1200"/>
               </a:spcAft>
+              <a:defRPr sz="1600">
+                <a:solidFill>
+                  <a:srgbClr val="DCF0FF"/>
+                </a:solidFill>
+              </a:defRPr>
             </a:pPr>
             <a:r>
-              <a:rPr sz="1500">
-                <a:solidFill>
-                  <a:srgbClr val="283241"/>
-                </a:solidFill>
-                <a:latin typeface="Exo 2"/>
-              </a:rPr>
-              <a:t>Adaptive Threshold: Q-Guard shifts limits dynamically based on transaction context.</a:t>
+              <a:t>• High False Positive rates annoy regular customers, increasing churn and operational friction.</a:t>
             </a:r>
           </a:p>
           <a:p>
             <a:pPr>
               <a:spcAft>
-                <a:spcPts val="1400"/>
+                <a:spcPts val="1200"/>
               </a:spcAft>
+              <a:defRPr sz="1600">
+                <a:solidFill>
+                  <a:srgbClr val="DCF0FF"/>
+                </a:solidFill>
+              </a:defRPr>
             </a:pPr>
             <a:r>
-              <a:rPr sz="1500">
-                <a:solidFill>
-                  <a:srgbClr val="283241"/>
-                </a:solidFill>
-                <a:latin typeface="Exo 2"/>
-              </a:rPr>
-              <a:t>Late Night Hour Window (12 AM - 5 AM): Threshold drops to 65% (restrictive).</a:t>
+              <a:t>• Regulatory compliance (RBI/Central Bank) requires Explainable AI (XAI) parameters.</a:t>
             </a:r>
           </a:p>
           <a:p>
             <a:pPr>
               <a:spcAft>
-                <a:spcPts val="1400"/>
+                <a:spcPts val="1200"/>
               </a:spcAft>
+              <a:defRPr sz="1600">
+                <a:solidFill>
+                  <a:srgbClr val="DCF0FF"/>
+                </a:solidFill>
+              </a:defRPr>
             </a:pPr>
             <a:r>
-              <a:rPr sz="1500">
-                <a:solidFill>
-                  <a:srgbClr val="283241"/>
-                </a:solidFill>
-                <a:latin typeface="Exo 2"/>
-              </a:rPr>
-              <a:t>High chargeback Merchant Terminal: Threshold drops to 58% (tighter security).</a:t>
+              <a:t>• Coordinated attacks (Mule Rings, shared device farms) bypass linear threshold rules.</a:t>
             </a:r>
           </a:p>
           <a:p>
             <a:pPr>
               <a:spcAft>
-                <a:spcPts val="1400"/>
+                <a:spcPts val="1200"/>
               </a:spcAft>
+              <a:defRPr sz="1600">
+                <a:solidFill>
+                  <a:srgbClr val="DCF0FF"/>
+                </a:solidFill>
+              </a:defRPr>
             </a:pPr>
             <a:r>
-              <a:rPr sz="1500">
-                <a:solidFill>
-                  <a:srgbClr val="283241"/>
-                </a:solidFill>
-                <a:latin typeface="Exo 2"/>
-              </a:rPr>
-              <a:t>Trusted Regular Customer: Threshold rises to 95% (minimizes customer friction).</a:t>
+              <a:t>• Solution: Q-Guard AI combines Multi-Agent intelligence with a Quantum Optimization layer.</a:t>
             </a:r>
           </a:p>
         </p:txBody>
@@ -6973,721 +7004,16 @@
   <p:clrMapOvr>
     <a:masterClrMapping/>
   </p:clrMapOvr>
-</p:sld>
-</file>
-
-<file path=ppt/slides/slide11.xml><?xml version="1.0" encoding="utf-8"?>
-<p:sld xmlns:a="http://schemas.openxmlformats.org/drawingml/2006/main" xmlns:p="http://schemas.openxmlformats.org/presentationml/2006/main" xmlns:r="http://schemas.openxmlformats.org/officeDocument/2006/relationships">
-  <p:cSld>
-    <p:spTree>
-      <p:nvGrpSpPr>
-        <p:cNvPr id="1" name=""/>
-        <p:cNvGrpSpPr/>
-        <p:nvPr/>
-      </p:nvGrpSpPr>
-      <p:grpSpPr/>
-      <p:sp>
-        <p:nvSpPr>
-          <p:cNvPr id="2" name="Title 1"/>
-          <p:cNvSpPr>
-            <a:spLocks noGrp="1"/>
-          </p:cNvSpPr>
-          <p:nvPr>
-            <p:ph type="title"/>
-          </p:nvPr>
-        </p:nvSpPr>
-        <p:spPr/>
-        <p:txBody>
-          <a:bodyPr/>
-          <a:lstStyle/>
-          <a:p>
-            <a:pPr>
-              <a:defRPr sz="2800" b="1">
-                <a:solidFill>
-                  <a:srgbClr val="0A2D50"/>
-                </a:solidFill>
-                <a:latin typeface="Rajdhani"/>
-              </a:defRPr>
-            </a:pPr>
-            <a:r>
-              <a:t>5. SELF-EXPLAINABLE AI &amp; STRATEGY MITIGATION</a:t>
-            </a:r>
-          </a:p>
-        </p:txBody>
-      </p:sp>
-      <p:sp>
-        <p:nvSpPr>
-          <p:cNvPr id="3" name="Content Placeholder 2"/>
-          <p:cNvSpPr>
-            <a:spLocks noGrp="1"/>
-          </p:cNvSpPr>
-          <p:nvPr>
-            <p:ph idx="1" sz="quarter"/>
-          </p:nvPr>
-        </p:nvSpPr>
-        <p:spPr/>
-        <p:txBody>
-          <a:bodyPr wrap="square"/>
-          <a:lstStyle/>
-          <a:p>
-            <a:pPr>
-              <a:spcAft>
-                <a:spcPts val="1400"/>
-              </a:spcAft>
-            </a:pPr>
-            <a:r>
-              <a:rPr sz="1500">
-                <a:solidFill>
-                  <a:srgbClr val="283241"/>
-                </a:solidFill>
-                <a:latin typeface="Exo 2"/>
-              </a:rPr>
-              <a:t>Self-Explainable AI (XAI): Translates VQC state vectors into natural language warning logs.</a:t>
-            </a:r>
-          </a:p>
-          <a:p>
-            <a:pPr>
-              <a:spcAft>
-                <a:spcPts val="1400"/>
-              </a:spcAft>
-            </a:pPr>
-            <a:r>
-              <a:rPr sz="1500">
-                <a:solidFill>
-                  <a:srgbClr val="283241"/>
-                </a:solidFill>
-                <a:latin typeface="Exo 2"/>
-              </a:rPr>
-              <a:t>Auditable Compliance: Outlines exactly why an agent triggered the transaction block.</a:t>
-            </a:r>
-          </a:p>
-          <a:p>
-            <a:pPr>
-              <a:spcAft>
-                <a:spcPts val="1400"/>
-              </a:spcAft>
-            </a:pPr>
-            <a:r>
-              <a:rPr sz="1500">
-                <a:solidFill>
-                  <a:srgbClr val="283241"/>
-                </a:solidFill>
-                <a:latin typeface="Exo 2"/>
-              </a:rPr>
-              <a:t>Fraud Strategy Advisor: Recommends progressive mitigation checklists instead of binary blocks.</a:t>
-            </a:r>
-          </a:p>
-          <a:p>
-            <a:pPr>
-              <a:spcAft>
-                <a:spcPts val="1400"/>
-              </a:spcAft>
-            </a:pPr>
-            <a:r>
-              <a:rPr sz="1500">
-                <a:solidFill>
-                  <a:srgbClr val="283241"/>
-                </a:solidFill>
-                <a:latin typeface="Exo 2"/>
-              </a:rPr>
-              <a:t>Mitigation Checklist: Request Face Authentication, Require SMS OTP, or Hold payout.</a:t>
-            </a:r>
-          </a:p>
-          <a:p>
-            <a:pPr>
-              <a:spcAft>
-                <a:spcPts val="1400"/>
-              </a:spcAft>
-            </a:pPr>
-            <a:r>
-              <a:rPr sz="1500">
-                <a:solidFill>
-                  <a:srgbClr val="283241"/>
-                </a:solidFill>
-                <a:latin typeface="Exo 2"/>
-              </a:rPr>
-              <a:t>Benefit: Matches regulatory audit frameworks while keeping user friction minimal.</a:t>
-            </a:r>
-          </a:p>
-        </p:txBody>
-      </p:sp>
-    </p:spTree>
-  </p:cSld>
-  <p:clrMapOvr>
-    <a:masterClrMapping/>
-  </p:clrMapOvr>
-</p:sld>
-</file>
-
-<file path=ppt/slides/slide12.xml><?xml version="1.0" encoding="utf-8"?>
-<p:sld xmlns:a="http://schemas.openxmlformats.org/drawingml/2006/main" xmlns:p="http://schemas.openxmlformats.org/presentationml/2006/main" xmlns:r="http://schemas.openxmlformats.org/officeDocument/2006/relationships">
-  <p:cSld>
-    <p:spTree>
-      <p:nvGrpSpPr>
-        <p:cNvPr id="1" name=""/>
-        <p:cNvGrpSpPr/>
-        <p:nvPr/>
-      </p:nvGrpSpPr>
-      <p:grpSpPr/>
-      <p:sp>
-        <p:nvSpPr>
-          <p:cNvPr id="2" name="Title 1"/>
-          <p:cNvSpPr>
-            <a:spLocks noGrp="1"/>
-          </p:cNvSpPr>
-          <p:nvPr>
-            <p:ph type="title"/>
-          </p:nvPr>
-        </p:nvSpPr>
-        <p:spPr/>
-        <p:txBody>
-          <a:bodyPr/>
-          <a:lstStyle/>
-          <a:p>
-            <a:pPr>
-              <a:defRPr sz="2800" b="1">
-                <a:solidFill>
-                  <a:srgbClr val="0A2D50"/>
-                </a:solidFill>
-                <a:latin typeface="Rajdhani"/>
-              </a:defRPr>
-            </a:pPr>
-            <a:r>
-              <a:t>6. SCALABILITY &amp; DATABASE PIPELINE INTEGRATION</a:t>
-            </a:r>
-          </a:p>
-        </p:txBody>
-      </p:sp>
-      <p:sp>
-        <p:nvSpPr>
-          <p:cNvPr id="3" name="Content Placeholder 2"/>
-          <p:cNvSpPr>
-            <a:spLocks noGrp="1"/>
-          </p:cNvSpPr>
-          <p:nvPr>
-            <p:ph idx="1" sz="quarter"/>
-          </p:nvPr>
-        </p:nvSpPr>
-        <p:spPr/>
-        <p:txBody>
-          <a:bodyPr wrap="square"/>
-          <a:lstStyle/>
-          <a:p>
-            <a:pPr>
-              <a:spcAft>
-                <a:spcPts val="1400"/>
-              </a:spcAft>
-            </a:pPr>
-            <a:r>
-              <a:rPr sz="1500">
-                <a:solidFill>
-                  <a:srgbClr val="283241"/>
-                </a:solidFill>
-                <a:latin typeface="Exo 2"/>
-              </a:rPr>
-              <a:t>Kaggle Database: Integrated with 3,000 real-world transaction logs (IEEE-CIS).</a:t>
-            </a:r>
-          </a:p>
-          <a:p>
-            <a:pPr>
-              <a:spcAft>
-                <a:spcPts val="1400"/>
-              </a:spcAft>
-            </a:pPr>
-            <a:r>
-              <a:rPr sz="1500">
-                <a:solidFill>
-                  <a:srgbClr val="283241"/>
-                </a:solidFill>
-                <a:latin typeface="Exo 2"/>
-              </a:rPr>
-              <a:t>MongoDB Integration: Stores transactions and quantum telemetry in indexed collections.</a:t>
-            </a:r>
-          </a:p>
-          <a:p>
-            <a:pPr>
-              <a:spcAft>
-                <a:spcPts val="1400"/>
-              </a:spcAft>
-            </a:pPr>
-            <a:r>
-              <a:rPr sz="1500">
-                <a:solidFill>
-                  <a:srgbClr val="283241"/>
-                </a:solidFill>
-                <a:latin typeface="Exo 2"/>
-              </a:rPr>
-              <a:t>FastAPI REST endpoints: Exposes VQC coordinates, dynamic weights, and strategies.</a:t>
-            </a:r>
-          </a:p>
-          <a:p>
-            <a:pPr>
-              <a:spcAft>
-                <a:spcPts val="1400"/>
-              </a:spcAft>
-            </a:pPr>
-            <a:r>
-              <a:rPr sz="1500">
-                <a:solidFill>
-                  <a:srgbClr val="283241"/>
-                </a:solidFill>
-                <a:latin typeface="Exo 2"/>
-              </a:rPr>
-              <a:t>Vercel Deployment: Standalone HTML visualizer deployed live on cloud static servers.</a:t>
-            </a:r>
-          </a:p>
-          <a:p>
-            <a:pPr>
-              <a:spcAft>
-                <a:spcPts val="1400"/>
-              </a:spcAft>
-            </a:pPr>
-            <a:r>
-              <a:rPr sz="1500">
-                <a:solidFill>
-                  <a:srgbClr val="283241"/>
-                </a:solidFill>
-                <a:latin typeface="Exo 2"/>
-              </a:rPr>
-              <a:t>Result: A scalable, production-grade Quantum-Graph system ready for deployment.</a:t>
-            </a:r>
-          </a:p>
-        </p:txBody>
-      </p:sp>
-    </p:spTree>
-  </p:cSld>
-  <p:clrMapOvr>
-    <a:masterClrMapping/>
-  </p:clrMapOvr>
-</p:sld>
-</file>
-
-<file path=ppt/slides/slide2.xml><?xml version="1.0" encoding="utf-8"?>
-<p:sld xmlns:a="http://schemas.openxmlformats.org/drawingml/2006/main" xmlns:p="http://schemas.openxmlformats.org/presentationml/2006/main" xmlns:r="http://schemas.openxmlformats.org/officeDocument/2006/relationships">
-  <p:cSld>
-    <p:spTree>
-      <p:nvGrpSpPr>
-        <p:cNvPr id="1" name=""/>
-        <p:cNvGrpSpPr/>
-        <p:nvPr/>
-      </p:nvGrpSpPr>
-      <p:grpSpPr/>
-      <p:sp>
-        <p:nvSpPr>
-          <p:cNvPr id="2" name="Title 1"/>
-          <p:cNvSpPr>
-            <a:spLocks noGrp="1"/>
-          </p:cNvSpPr>
-          <p:nvPr>
-            <p:ph type="title"/>
-          </p:nvPr>
-        </p:nvSpPr>
-        <p:spPr/>
-        <p:txBody>
-          <a:bodyPr/>
-          <a:lstStyle/>
-          <a:p>
-            <a:pPr>
-              <a:defRPr sz="2800" b="1">
-                <a:solidFill>
-                  <a:srgbClr val="0A2D50"/>
-                </a:solidFill>
-                <a:latin typeface="Rajdhani"/>
-              </a:defRPr>
-            </a:pPr>
-            <a:r>
-              <a:t>1. PROBLEM STATEMENT (QT-2.8)</a:t>
-            </a:r>
-          </a:p>
-        </p:txBody>
-      </p:sp>
-      <p:sp>
-        <p:nvSpPr>
-          <p:cNvPr id="3" name="Content Placeholder 2"/>
-          <p:cNvSpPr>
-            <a:spLocks noGrp="1"/>
-          </p:cNvSpPr>
-          <p:nvPr>
-            <p:ph idx="1" sz="quarter"/>
-          </p:nvPr>
-        </p:nvSpPr>
-        <p:spPr/>
-        <p:txBody>
-          <a:bodyPr wrap="square"/>
-          <a:lstStyle/>
-          <a:p>
-            <a:pPr>
-              <a:spcAft>
-                <a:spcPts val="1400"/>
-              </a:spcAft>
-            </a:pPr>
-            <a:r>
-              <a:rPr sz="1500">
-                <a:solidFill>
-                  <a:srgbClr val="283241"/>
-                </a:solidFill>
-                <a:latin typeface="Exo 2"/>
-              </a:rPr>
-              <a:t>Classical ML models check transactions in isolation, missing temporal laundering loops.</a:t>
-            </a:r>
-          </a:p>
-          <a:p>
-            <a:pPr>
-              <a:spcAft>
-                <a:spcPts val="1400"/>
-              </a:spcAft>
-            </a:pPr>
-            <a:r>
-              <a:rPr sz="1500">
-                <a:solidFill>
-                  <a:srgbClr val="283241"/>
-                </a:solidFill>
-                <a:latin typeface="Exo 2"/>
-              </a:rPr>
-              <a:t>High False Positive rates annoy regular customers, increasing churn and operational friction.</a:t>
-            </a:r>
-          </a:p>
-          <a:p>
-            <a:pPr>
-              <a:spcAft>
-                <a:spcPts val="1400"/>
-              </a:spcAft>
-            </a:pPr>
-            <a:r>
-              <a:rPr sz="1500">
-                <a:solidFill>
-                  <a:srgbClr val="283241"/>
-                </a:solidFill>
-                <a:latin typeface="Exo 2"/>
-              </a:rPr>
-              <a:t>Regulatory compliance (RBI/Central Bank) requires Explainable AI (XAI) parameters.</a:t>
-            </a:r>
-          </a:p>
-          <a:p>
-            <a:pPr>
-              <a:spcAft>
-                <a:spcPts val="1400"/>
-              </a:spcAft>
-            </a:pPr>
-            <a:r>
-              <a:rPr sz="1500">
-                <a:solidFill>
-                  <a:srgbClr val="283241"/>
-                </a:solidFill>
-                <a:latin typeface="Exo 2"/>
-              </a:rPr>
-              <a:t>Coordinated attacks (Mule Rings, shared device emulators) bypass standard linear limits.</a:t>
-            </a:r>
-          </a:p>
-          <a:p>
-            <a:pPr>
-              <a:spcAft>
-                <a:spcPts val="1400"/>
-              </a:spcAft>
-            </a:pPr>
-            <a:r>
-              <a:rPr sz="1500">
-                <a:solidFill>
-                  <a:srgbClr val="283241"/>
-                </a:solidFill>
-                <a:latin typeface="Exo 2"/>
-              </a:rPr>
-              <a:t>Solution: Q-Guard AI combines Multi-Agent intelligence with a Quantum Optimization layer.</a:t>
-            </a:r>
-          </a:p>
-        </p:txBody>
-      </p:sp>
-    </p:spTree>
-  </p:cSld>
-  <p:clrMapOvr>
-    <a:masterClrMapping/>
-  </p:clrMapOvr>
-</p:sld>
-</file>
-
-<file path=ppt/slides/slide2.xml><?xml version="1.0" encoding="utf-8"?>
-<p:sld xmlns:a="http://schemas.openxmlformats.org/drawingml/2006/main" xmlns:p="http://schemas.openxmlformats.org/presentationml/2006/main" xmlns:r="http://schemas.openxmlformats.org/officeDocument/2006/relationships">
-  <p:cSld>
-    <p:spTree>
-      <p:nvGrpSpPr>
-        <p:cNvPr id="1" name=""/>
-        <p:cNvGrpSpPr/>
-        <p:nvPr/>
-      </p:nvGrpSpPr>
-      <p:grpSpPr/>
-      <p:sp>
-        <p:nvSpPr>
-          <p:cNvPr id="2" name="Title 1"/>
-          <p:cNvSpPr>
-            <a:spLocks noGrp="1"/>
-          </p:cNvSpPr>
-          <p:nvPr>
-            <p:ph type="title"/>
-          </p:nvPr>
-        </p:nvSpPr>
-        <p:spPr/>
-        <p:txBody>
-          <a:bodyPr/>
-          <a:lstStyle/>
-          <a:p>
-            <a:pPr>
-              <a:defRPr sz="2800" b="1">
-                <a:solidFill>
-                  <a:srgbClr val="0A2D50"/>
-                </a:solidFill>
-                <a:latin typeface="Rajdhani"/>
-              </a:defRPr>
-            </a:pPr>
-            <a:r>
-              <a:t>1. PROBLEM STATEMENT (QT-2.8)</a:t>
-            </a:r>
-          </a:p>
-        </p:txBody>
-      </p:sp>
-      <p:sp>
-        <p:nvSpPr>
-          <p:cNvPr id="3" name="Content Placeholder 2"/>
-          <p:cNvSpPr>
-            <a:spLocks noGrp="1"/>
-          </p:cNvSpPr>
-          <p:nvPr>
-            <p:ph idx="1" sz="quarter"/>
-          </p:nvPr>
-        </p:nvSpPr>
-        <p:spPr/>
-        <p:txBody>
-          <a:bodyPr wrap="square"/>
-          <a:lstStyle/>
-          <a:p>
-            <a:pPr>
-              <a:spcAft>
-                <a:spcPts val="1400"/>
-              </a:spcAft>
-            </a:pPr>
-            <a:r>
-              <a:rPr sz="1500">
-                <a:solidFill>
-                  <a:srgbClr val="283241"/>
-                </a:solidFill>
-                <a:latin typeface="Exo 2"/>
-              </a:rPr>
-              <a:t>Classical ML models check transactions in isolation, missing temporal laundering loops.</a:t>
-            </a:r>
-          </a:p>
-          <a:p>
-            <a:pPr>
-              <a:spcAft>
-                <a:spcPts val="1400"/>
-              </a:spcAft>
-            </a:pPr>
-            <a:r>
-              <a:rPr sz="1500">
-                <a:solidFill>
-                  <a:srgbClr val="283241"/>
-                </a:solidFill>
-                <a:latin typeface="Exo 2"/>
-              </a:rPr>
-              <a:t>High False Positive rates annoy regular customers, increasing churn and operational friction.</a:t>
-            </a:r>
-          </a:p>
-          <a:p>
-            <a:pPr>
-              <a:spcAft>
-                <a:spcPts val="1400"/>
-              </a:spcAft>
-            </a:pPr>
-            <a:r>
-              <a:rPr sz="1500">
-                <a:solidFill>
-                  <a:srgbClr val="283241"/>
-                </a:solidFill>
-                <a:latin typeface="Exo 2"/>
-              </a:rPr>
-              <a:t>Regulatory compliance (RBI/Central Bank) requires Explainable AI (XAI) parameters.</a:t>
-            </a:r>
-          </a:p>
-          <a:p>
-            <a:pPr>
-              <a:spcAft>
-                <a:spcPts val="1400"/>
-              </a:spcAft>
-            </a:pPr>
-            <a:r>
-              <a:rPr sz="1500">
-                <a:solidFill>
-                  <a:srgbClr val="283241"/>
-                </a:solidFill>
-                <a:latin typeface="Exo 2"/>
-              </a:rPr>
-              <a:t>Coordinated attacks (Mule Rings, shared device emulators) bypass standard linear limits.</a:t>
-            </a:r>
-          </a:p>
-          <a:p>
-            <a:pPr>
-              <a:spcAft>
-                <a:spcPts val="1400"/>
-              </a:spcAft>
-            </a:pPr>
-            <a:r>
-              <a:rPr sz="1500">
-                <a:solidFill>
-                  <a:srgbClr val="283241"/>
-                </a:solidFill>
-                <a:latin typeface="Exo 2"/>
-              </a:rPr>
-              <a:t>Solution: Q-Guard AI combines Multi-Agent intelligence with a Quantum Optimization layer.</a:t>
-            </a:r>
-          </a:p>
-        </p:txBody>
-      </p:sp>
-    </p:spTree>
-  </p:cSld>
-  <p:clrMapOvr>
-    <a:masterClrMapping/>
-  </p:clrMapOvr>
-</p:sld>
-</file>
-
-<file path=ppt/slides/slide2.xml><?xml version="1.0" encoding="utf-8"?>
-<p:sld xmlns:a="http://schemas.openxmlformats.org/drawingml/2006/main" xmlns:p="http://schemas.openxmlformats.org/presentationml/2006/main" xmlns:r="http://schemas.openxmlformats.org/officeDocument/2006/relationships">
-  <p:cSld>
-    <p:spTree>
-      <p:nvGrpSpPr>
-        <p:cNvPr id="1" name=""/>
-        <p:cNvGrpSpPr/>
-        <p:nvPr/>
-      </p:nvGrpSpPr>
-      <p:grpSpPr/>
-      <p:sp>
-        <p:nvSpPr>
-          <p:cNvPr id="2" name="Title 1"/>
-          <p:cNvSpPr>
-            <a:spLocks noGrp="1"/>
-          </p:cNvSpPr>
-          <p:nvPr>
-            <p:ph type="title"/>
-          </p:nvPr>
-        </p:nvSpPr>
-        <p:spPr/>
-        <p:txBody>
-          <a:bodyPr/>
-          <a:lstStyle/>
-          <a:p>
-            <a:pPr>
-              <a:defRPr sz="2800" b="1">
-                <a:solidFill>
-                  <a:srgbClr val="0A2D50"/>
-                </a:solidFill>
-                <a:latin typeface="Rajdhani"/>
-              </a:defRPr>
-            </a:pPr>
-            <a:r>
-              <a:t>1. PROBLEM STATEMENT (QT-2.8)</a:t>
-            </a:r>
-          </a:p>
-        </p:txBody>
-      </p:sp>
-      <p:sp>
-        <p:nvSpPr>
-          <p:cNvPr id="3" name="Content Placeholder 2"/>
-          <p:cNvSpPr>
-            <a:spLocks noGrp="1"/>
-          </p:cNvSpPr>
-          <p:nvPr>
-            <p:ph idx="1" sz="quarter"/>
-          </p:nvPr>
-        </p:nvSpPr>
-        <p:spPr/>
-        <p:txBody>
-          <a:bodyPr wrap="square"/>
-          <a:lstStyle/>
-          <a:p>
-            <a:pPr>
-              <a:spcAft>
-                <a:spcPts val="1400"/>
-              </a:spcAft>
-            </a:pPr>
-            <a:r>
-              <a:rPr sz="1500">
-                <a:solidFill>
-                  <a:srgbClr val="283241"/>
-                </a:solidFill>
-                <a:latin typeface="Exo 2"/>
-              </a:rPr>
-              <a:t>Classical ML models check transactions in isolation, missing temporal laundering loops.</a:t>
-            </a:r>
-          </a:p>
-          <a:p>
-            <a:pPr>
-              <a:spcAft>
-                <a:spcPts val="1400"/>
-              </a:spcAft>
-            </a:pPr>
-            <a:r>
-              <a:rPr sz="1500">
-                <a:solidFill>
-                  <a:srgbClr val="283241"/>
-                </a:solidFill>
-                <a:latin typeface="Exo 2"/>
-              </a:rPr>
-              <a:t>High False Positive rates annoy regular customers, increasing churn and operational friction.</a:t>
-            </a:r>
-          </a:p>
-          <a:p>
-            <a:pPr>
-              <a:spcAft>
-                <a:spcPts val="1400"/>
-              </a:spcAft>
-            </a:pPr>
-            <a:r>
-              <a:rPr sz="1500">
-                <a:solidFill>
-                  <a:srgbClr val="283241"/>
-                </a:solidFill>
-                <a:latin typeface="Exo 2"/>
-              </a:rPr>
-              <a:t>Regulatory compliance (RBI/Central Bank) requires Explainable AI (XAI) parameters.</a:t>
-            </a:r>
-          </a:p>
-          <a:p>
-            <a:pPr>
-              <a:spcAft>
-                <a:spcPts val="1400"/>
-              </a:spcAft>
-            </a:pPr>
-            <a:r>
-              <a:rPr sz="1500">
-                <a:solidFill>
-                  <a:srgbClr val="283241"/>
-                </a:solidFill>
-                <a:latin typeface="Exo 2"/>
-              </a:rPr>
-              <a:t>Coordinated attacks (Mule Rings, shared device emulators) bypass standard linear limits.</a:t>
-            </a:r>
-          </a:p>
-          <a:p>
-            <a:pPr>
-              <a:spcAft>
-                <a:spcPts val="1400"/>
-              </a:spcAft>
-            </a:pPr>
-            <a:r>
-              <a:rPr sz="1500">
-                <a:solidFill>
-                  <a:srgbClr val="283241"/>
-                </a:solidFill>
-                <a:latin typeface="Exo 2"/>
-              </a:rPr>
-              <a:t>Solution: Q-Guard AI combines Multi-Agent intelligence with a Quantum Optimization layer.</a:t>
-            </a:r>
-          </a:p>
-        </p:txBody>
-      </p:sp>
-    </p:spTree>
-  </p:cSld>
-  <p:clrMapOvr>
-    <a:masterClrMapping/>
-  </p:clrMapOvr>
+  <p:transition>
+    <p:fade/>
+  </p:transition>
+  <p:timing>
+    <p:tnLst>
+      <p:par>
+        <p:cTn id="1" dur="indefinite" restart="never" nodeType="tmRoot"/>
+      </p:par>
+    </p:tnLst>
+  </p:timing>
 </p:sld>
 </file>
 
@@ -7716,14 +7042,6 @@
           <a:bodyPr/>
           <a:lstStyle/>
           <a:p>
-            <a:pPr>
-              <a:defRPr sz="2800" b="1">
-                <a:solidFill>
-                  <a:srgbClr val="0A2D50"/>
-                </a:solidFill>
-                <a:latin typeface="Rajdhani"/>
-              </a:defRPr>
-            </a:pPr>
             <a:r>
               <a:t>2. Q-GUARD ARCHITECTURE: MULTI-AGENT INGESTION</a:t>
             </a:r>
@@ -7747,224 +7065,76 @@
           <a:p>
             <a:pPr>
               <a:spcAft>
-                <a:spcPts val="1400"/>
+                <a:spcPts val="1200"/>
               </a:spcAft>
+              <a:defRPr sz="1600">
+                <a:solidFill>
+                  <a:srgbClr val="DCF0FF"/>
+                </a:solidFill>
+              </a:defRPr>
             </a:pPr>
             <a:r>
-              <a:rPr sz="1500">
-                <a:solidFill>
-                  <a:srgbClr val="283241"/>
-                </a:solidFill>
-                <a:latin typeface="Exo 2"/>
-              </a:rPr>
-              <a:t>User Behavior Agent: Analyzes daily spending limit fractions and transaction volume.</a:t>
+              <a:t>• User Behavior Agent: Analyzes daily spending limit fractions and time deviation.</a:t>
             </a:r>
           </a:p>
           <a:p>
             <a:pPr>
               <a:spcAft>
-                <a:spcPts val="1400"/>
+                <a:spcPts val="1200"/>
               </a:spcAft>
+              <a:defRPr sz="1600">
+                <a:solidFill>
+                  <a:srgbClr val="DCF0FF"/>
+                </a:solidFill>
+              </a:defRPr>
             </a:pPr>
             <a:r>
-              <a:rPr sz="1500">
-                <a:solidFill>
-                  <a:srgbClr val="283241"/>
-                </a:solidFill>
-                <a:latin typeface="Exo 2"/>
-              </a:rPr>
-              <a:t>Device Intelligence Agent: Detects OS versions, emulators, and device trust rating.</a:t>
+              <a:t>• Device Intelligence Agent: Detects OS versions, emulators, and device trust rating.</a:t>
             </a:r>
           </a:p>
           <a:p>
             <a:pPr>
               <a:spcAft>
-                <a:spcPts val="1400"/>
+                <a:spcPts val="1200"/>
               </a:spcAft>
+              <a:defRPr sz="1600">
+                <a:solidFill>
+                  <a:srgbClr val="DCF0FF"/>
+                </a:solidFill>
+              </a:defRPr>
             </a:pPr>
             <a:r>
-              <a:rPr sz="1500">
-                <a:solidFill>
-                  <a:srgbClr val="283241"/>
-                </a:solidFill>
-                <a:latin typeface="Exo 2"/>
-              </a:rPr>
-              <a:t>Merchant Rating Agent: Assesses merchant category hazard and chargeback rates.</a:t>
+              <a:t>• Merchant Rating Agent: Assesses merchant category hazard and chargeback rates.</a:t>
             </a:r>
           </a:p>
           <a:p>
             <a:pPr>
               <a:spcAft>
-                <a:spcPts val="1400"/>
+                <a:spcPts val="1200"/>
               </a:spcAft>
+              <a:defRPr sz="1600">
+                <a:solidFill>
+                  <a:srgbClr val="DCF0FF"/>
+                </a:solidFill>
+              </a:defRPr>
             </a:pPr>
             <a:r>
-              <a:rPr sz="1500">
-                <a:solidFill>
-                  <a:srgbClr val="283241"/>
-                </a:solidFill>
-                <a:latin typeface="Exo 2"/>
-              </a:rPr>
-              <a:t>Network Intelligence Agent: Monitors VPN usage, proxy IPs, and impossible travel.</a:t>
+              <a:t>• Network Intelligence Agent: Monitors VPN usage, proxy IPs, and impossible travel.</a:t>
             </a:r>
           </a:p>
           <a:p>
             <a:pPr>
               <a:spcAft>
-                <a:spcPts val="1400"/>
+                <a:spcPts val="1200"/>
               </a:spcAft>
-            </a:pPr>
-            <a:r>
-              <a:rPr sz="1500">
+              <a:defRPr sz="1600">
                 <a:solidFill>
-                  <a:srgbClr val="283241"/>
+                  <a:srgbClr val="DCF0FF"/>
                 </a:solidFill>
-                <a:latin typeface="Exo 2"/>
-              </a:rPr>
-              <a:t>Decentralized Ingestion: Captures separate threat layers simultaneously to prevent bypass.</a:t>
-            </a:r>
-          </a:p>
-        </p:txBody>
-      </p:sp>
-    </p:spTree>
-  </p:cSld>
-  <p:clrMapOvr>
-    <a:masterClrMapping/>
-  </p:clrMapOvr>
-</p:sld>
-</file>
-
-<file path=ppt/slides/slide3.xml><?xml version="1.0" encoding="utf-8"?>
-<p:sld xmlns:a="http://schemas.openxmlformats.org/drawingml/2006/main" xmlns:p="http://schemas.openxmlformats.org/presentationml/2006/main" xmlns:r="http://schemas.openxmlformats.org/officeDocument/2006/relationships">
-  <p:cSld>
-    <p:spTree>
-      <p:nvGrpSpPr>
-        <p:cNvPr id="1" name=""/>
-        <p:cNvGrpSpPr/>
-        <p:nvPr/>
-      </p:nvGrpSpPr>
-      <p:grpSpPr/>
-      <p:sp>
-        <p:nvSpPr>
-          <p:cNvPr id="2" name="Title 1"/>
-          <p:cNvSpPr>
-            <a:spLocks noGrp="1"/>
-          </p:cNvSpPr>
-          <p:nvPr>
-            <p:ph type="title"/>
-          </p:nvPr>
-        </p:nvSpPr>
-        <p:spPr/>
-        <p:txBody>
-          <a:bodyPr/>
-          <a:lstStyle/>
-          <a:p>
-            <a:pPr>
-              <a:defRPr sz="2800" b="1">
-                <a:solidFill>
-                  <a:srgbClr val="0A2D50"/>
-                </a:solidFill>
-                <a:latin typeface="Rajdhani"/>
               </a:defRPr>
             </a:pPr>
             <a:r>
-              <a:t>2. Q-GUARD ARCHITECTURE: MULTI-AGENT INGESTION</a:t>
-            </a:r>
-          </a:p>
-        </p:txBody>
-      </p:sp>
-      <p:sp>
-        <p:nvSpPr>
-          <p:cNvPr id="3" name="Content Placeholder 2"/>
-          <p:cNvSpPr>
-            <a:spLocks noGrp="1"/>
-          </p:cNvSpPr>
-          <p:nvPr>
-            <p:ph idx="1" sz="quarter"/>
-          </p:nvPr>
-        </p:nvSpPr>
-        <p:spPr/>
-        <p:txBody>
-          <a:bodyPr wrap="square"/>
-          <a:lstStyle/>
-          <a:p>
-            <a:pPr>
-              <a:spcAft>
-                <a:spcPts val="1400"/>
-              </a:spcAft>
-            </a:pPr>
-            <a:r>
-              <a:rPr sz="1500">
-                <a:solidFill>
-                  <a:srgbClr val="283241"/>
-                </a:solidFill>
-                <a:latin typeface="Exo 2"/>
-              </a:rPr>
-              <a:t>User Behavior Agent: Analyzes daily spending limit fractions and transaction volume.</a:t>
-            </a:r>
-          </a:p>
-          <a:p>
-            <a:pPr>
-              <a:spcAft>
-                <a:spcPts val="1400"/>
-              </a:spcAft>
-            </a:pPr>
-            <a:r>
-              <a:rPr sz="1500">
-                <a:solidFill>
-                  <a:srgbClr val="283241"/>
-                </a:solidFill>
-                <a:latin typeface="Exo 2"/>
-              </a:rPr>
-              <a:t>Device Intelligence Agent: Detects OS versions, emulators, and device trust rating.</a:t>
-            </a:r>
-          </a:p>
-          <a:p>
-            <a:pPr>
-              <a:spcAft>
-                <a:spcPts val="1400"/>
-              </a:spcAft>
-            </a:pPr>
-            <a:r>
-              <a:rPr sz="1500">
-                <a:solidFill>
-                  <a:srgbClr val="283241"/>
-                </a:solidFill>
-                <a:latin typeface="Exo 2"/>
-              </a:rPr>
-              <a:t>Merchant Rating Agent: Assesses merchant category hazard and chargeback rates.</a:t>
-            </a:r>
-          </a:p>
-          <a:p>
-            <a:pPr>
-              <a:spcAft>
-                <a:spcPts val="1400"/>
-              </a:spcAft>
-            </a:pPr>
-            <a:r>
-              <a:rPr sz="1500">
-                <a:solidFill>
-                  <a:srgbClr val="283241"/>
-                </a:solidFill>
-                <a:latin typeface="Exo 2"/>
-              </a:rPr>
-              <a:t>Network Intelligence Agent: Monitors VPN usage, proxy IPs, and impossible travel.</a:t>
-            </a:r>
-          </a:p>
-          <a:p>
-            <a:pPr>
-              <a:spcAft>
-                <a:spcPts val="1400"/>
-              </a:spcAft>
-            </a:pPr>
-            <a:r>
-              <a:rPr sz="1500">
-                <a:solidFill>
-                  <a:srgbClr val="283241"/>
-                </a:solidFill>
-                <a:latin typeface="Exo 2"/>
-              </a:rPr>
-              <a:t>Decentralized Ingestion: Captures separate threat layers simultaneously to prevent bypass.</a:t>
+              <a:t>• Benefit: Decentralized analysis captures separate threat layers simultaneously.</a:t>
             </a:r>
           </a:p>
         </p:txBody>
@@ -8002,14 +7172,6 @@
           <a:bodyPr/>
           <a:lstStyle/>
           <a:p>
-            <a:pPr>
-              <a:defRPr sz="2800" b="1">
-                <a:solidFill>
-                  <a:srgbClr val="0A2D50"/>
-                </a:solidFill>
-                <a:latin typeface="Rajdhani"/>
-              </a:defRPr>
-            </a:pPr>
             <a:r>
               <a:t>3. QUANTUM WEIGHT OPTIMIZATION (QML LAYER)</a:t>
             </a:r>
@@ -8033,224 +7195,76 @@
           <a:p>
             <a:pPr>
               <a:spcAft>
-                <a:spcPts val="1400"/>
+                <a:spcPts val="1200"/>
               </a:spcAft>
+              <a:defRPr sz="1600">
+                <a:solidFill>
+                  <a:srgbClr val="DCF0FF"/>
+                </a:solidFill>
+              </a:defRPr>
             </a:pPr>
             <a:r>
-              <a:rPr sz="1500">
-                <a:solidFill>
-                  <a:srgbClr val="283241"/>
-                </a:solidFill>
-                <a:latin typeface="Exo 2"/>
-              </a:rPr>
-              <a:t>State Encoding: Maps the 4 Agent risk variables directly to 4 Qubits (Q0 to Q3).</a:t>
+              <a:t>• State Encoding: Maps the 4 Agent risk variables directly to 4 Qubits (Q0 to Q3).</a:t>
             </a:r>
           </a:p>
           <a:p>
             <a:pPr>
               <a:spcAft>
-                <a:spcPts val="1400"/>
+                <a:spcPts val="1200"/>
               </a:spcAft>
+              <a:defRPr sz="1600">
+                <a:solidFill>
+                  <a:srgbClr val="DCF0FF"/>
+                </a:solidFill>
+              </a:defRPr>
             </a:pPr>
             <a:r>
-              <a:rPr sz="1500">
-                <a:solidFill>
-                  <a:srgbClr val="283241"/>
-                </a:solidFill>
-                <a:latin typeface="Exo 2"/>
-              </a:rPr>
-              <a:t>Entangling Circuit: Employs a Ring CNOT entangler to learn non-linear inter-agent correlations.</a:t>
+              <a:t>• Entangling Circuit: Employs a Ring CNOT entangler to learn inter-agent correlations.</a:t>
             </a:r>
           </a:p>
           <a:p>
             <a:pPr>
               <a:spcAft>
-                <a:spcPts val="1400"/>
+                <a:spcPts val="1200"/>
               </a:spcAft>
+              <a:defRPr sz="1600">
+                <a:solidFill>
+                  <a:srgbClr val="DCF0FF"/>
+                </a:solidFill>
+              </a:defRPr>
             </a:pPr>
             <a:r>
-              <a:rPr sz="1500">
-                <a:solidFill>
-                  <a:srgbClr val="283241"/>
-                </a:solidFill>
-                <a:latin typeface="Exo 2"/>
-              </a:rPr>
-              <a:t>Dynamic Weighting: Aggregates risk dynamically based on Qubit Z-coordinate excitation.</a:t>
+              <a:t>• Dynamic Weighting: Aggregates risk dynamically based on Qubit Z-coordinate excitation.</a:t>
             </a:r>
           </a:p>
           <a:p>
             <a:pPr>
               <a:spcAft>
-                <a:spcPts val="1400"/>
+                <a:spcPts val="1200"/>
               </a:spcAft>
+              <a:defRPr sz="1600">
+                <a:solidFill>
+                  <a:srgbClr val="DCF0FF"/>
+                </a:solidFill>
+              </a:defRPr>
             </a:pPr>
             <a:r>
-              <a:rPr sz="1500">
-                <a:solidFill>
-                  <a:srgbClr val="283241"/>
-                </a:solidFill>
-                <a:latin typeface="Exo 2"/>
-              </a:rPr>
-              <a:t>Bloch Projections: Agent weights are proportional to excitation (Weight = 1.0 - Z).</a:t>
+              <a:t>• Bloch Projections: Agent weights are proportional to excitation (Weight = 1.0 - Z).</a:t>
             </a:r>
           </a:p>
           <a:p>
             <a:pPr>
               <a:spcAft>
-                <a:spcPts val="1400"/>
+                <a:spcPts val="1200"/>
               </a:spcAft>
-            </a:pPr>
-            <a:r>
-              <a:rPr sz="1500">
+              <a:defRPr sz="1600">
                 <a:solidFill>
-                  <a:srgbClr val="283241"/>
+                  <a:srgbClr val="DCF0FF"/>
                 </a:solidFill>
-                <a:latin typeface="Exo 2"/>
-              </a:rPr>
-              <a:t>Benefit: Captures non-linear threat vectors using 90% fewer parameters than classical NN.</a:t>
-            </a:r>
-          </a:p>
-        </p:txBody>
-      </p:sp>
-    </p:spTree>
-  </p:cSld>
-  <p:clrMapOvr>
-    <a:masterClrMapping/>
-  </p:clrMapOvr>
-</p:sld>
-</file>
-
-<file path=ppt/slides/slide4.xml><?xml version="1.0" encoding="utf-8"?>
-<p:sld xmlns:a="http://schemas.openxmlformats.org/drawingml/2006/main" xmlns:p="http://schemas.openxmlformats.org/presentationml/2006/main" xmlns:r="http://schemas.openxmlformats.org/officeDocument/2006/relationships">
-  <p:cSld>
-    <p:spTree>
-      <p:nvGrpSpPr>
-        <p:cNvPr id="1" name=""/>
-        <p:cNvGrpSpPr/>
-        <p:nvPr/>
-      </p:nvGrpSpPr>
-      <p:grpSpPr/>
-      <p:sp>
-        <p:nvSpPr>
-          <p:cNvPr id="2" name="Title 1"/>
-          <p:cNvSpPr>
-            <a:spLocks noGrp="1"/>
-          </p:cNvSpPr>
-          <p:nvPr>
-            <p:ph type="title"/>
-          </p:nvPr>
-        </p:nvSpPr>
-        <p:spPr/>
-        <p:txBody>
-          <a:bodyPr/>
-          <a:lstStyle/>
-          <a:p>
-            <a:pPr>
-              <a:defRPr sz="2800" b="1">
-                <a:solidFill>
-                  <a:srgbClr val="0A2D50"/>
-                </a:solidFill>
-                <a:latin typeface="Rajdhani"/>
               </a:defRPr>
             </a:pPr>
             <a:r>
-              <a:t>3. QUANTUM WEIGHT OPTIMIZATION (QML LAYER)</a:t>
-            </a:r>
-          </a:p>
-        </p:txBody>
-      </p:sp>
-      <p:sp>
-        <p:nvSpPr>
-          <p:cNvPr id="3" name="Content Placeholder 2"/>
-          <p:cNvSpPr>
-            <a:spLocks noGrp="1"/>
-          </p:cNvSpPr>
-          <p:nvPr>
-            <p:ph idx="1" sz="quarter"/>
-          </p:nvPr>
-        </p:nvSpPr>
-        <p:spPr/>
-        <p:txBody>
-          <a:bodyPr wrap="square"/>
-          <a:lstStyle/>
-          <a:p>
-            <a:pPr>
-              <a:spcAft>
-                <a:spcPts val="1400"/>
-              </a:spcAft>
-            </a:pPr>
-            <a:r>
-              <a:rPr sz="1500">
-                <a:solidFill>
-                  <a:srgbClr val="283241"/>
-                </a:solidFill>
-                <a:latin typeface="Exo 2"/>
-              </a:rPr>
-              <a:t>State Encoding: Maps the 4 Agent risk variables directly to 4 Qubits (Q0 to Q3).</a:t>
-            </a:r>
-          </a:p>
-          <a:p>
-            <a:pPr>
-              <a:spcAft>
-                <a:spcPts val="1400"/>
-              </a:spcAft>
-            </a:pPr>
-            <a:r>
-              <a:rPr sz="1500">
-                <a:solidFill>
-                  <a:srgbClr val="283241"/>
-                </a:solidFill>
-                <a:latin typeface="Exo 2"/>
-              </a:rPr>
-              <a:t>Entangling Circuit: Employs a Ring CNOT entangler to learn non-linear inter-agent correlations.</a:t>
-            </a:r>
-          </a:p>
-          <a:p>
-            <a:pPr>
-              <a:spcAft>
-                <a:spcPts val="1400"/>
-              </a:spcAft>
-            </a:pPr>
-            <a:r>
-              <a:rPr sz="1500">
-                <a:solidFill>
-                  <a:srgbClr val="283241"/>
-                </a:solidFill>
-                <a:latin typeface="Exo 2"/>
-              </a:rPr>
-              <a:t>Dynamic Weighting: Aggregates risk dynamically based on Qubit Z-coordinate excitation.</a:t>
-            </a:r>
-          </a:p>
-          <a:p>
-            <a:pPr>
-              <a:spcAft>
-                <a:spcPts val="1400"/>
-              </a:spcAft>
-            </a:pPr>
-            <a:r>
-              <a:rPr sz="1500">
-                <a:solidFill>
-                  <a:srgbClr val="283241"/>
-                </a:solidFill>
-                <a:latin typeface="Exo 2"/>
-              </a:rPr>
-              <a:t>Bloch Projections: Agent weights are proportional to excitation (Weight = 1.0 - Z).</a:t>
-            </a:r>
-          </a:p>
-          <a:p>
-            <a:pPr>
-              <a:spcAft>
-                <a:spcPts val="1400"/>
-              </a:spcAft>
-            </a:pPr>
-            <a:r>
-              <a:rPr sz="1500">
-                <a:solidFill>
-                  <a:srgbClr val="283241"/>
-                </a:solidFill>
-                <a:latin typeface="Exo 2"/>
-              </a:rPr>
-              <a:t>Benefit: Captures non-linear threat vectors using 90% fewer parameters than classical NN.</a:t>
+              <a:t>• Benefit: Captures non-linear threat vectors using 90% fewer parameters than classical NN.</a:t>
             </a:r>
           </a:p>
         </p:txBody>
@@ -8288,14 +7302,6 @@
           <a:bodyPr/>
           <a:lstStyle/>
           <a:p>
-            <a:pPr>
-              <a:defRPr sz="2800" b="1">
-                <a:solidFill>
-                  <a:srgbClr val="0A2D50"/>
-                </a:solidFill>
-                <a:latin typeface="Rajdhani"/>
-              </a:defRPr>
-            </a:pPr>
             <a:r>
               <a:t>4. ADAPTIVE CONTEXT THRESHOLD ENGINE</a:t>
             </a:r>
@@ -8319,224 +7325,76 @@
           <a:p>
             <a:pPr>
               <a:spcAft>
-                <a:spcPts val="1400"/>
+                <a:spcPts val="1200"/>
               </a:spcAft>
+              <a:defRPr sz="1600">
+                <a:solidFill>
+                  <a:srgbClr val="DCF0FF"/>
+                </a:solidFill>
+              </a:defRPr>
             </a:pPr>
             <a:r>
-              <a:rPr sz="1500">
-                <a:solidFill>
-                  <a:srgbClr val="283241"/>
-                </a:solidFill>
-                <a:latin typeface="Exo 2"/>
-              </a:rPr>
-              <a:t>Static Limits: Traditional systems block at a flat 80% limit, causing high friction.</a:t>
+              <a:t>• Standard Thresholds: Traditional banks use static 80% limits (high friction).</a:t>
             </a:r>
           </a:p>
           <a:p>
             <a:pPr>
               <a:spcAft>
-                <a:spcPts val="1400"/>
+                <a:spcPts val="1200"/>
               </a:spcAft>
+              <a:defRPr sz="1600">
+                <a:solidFill>
+                  <a:srgbClr val="DCF0FF"/>
+                </a:solidFill>
+              </a:defRPr>
             </a:pPr>
             <a:r>
-              <a:rPr sz="1500">
-                <a:solidFill>
-                  <a:srgbClr val="283241"/>
-                </a:solidFill>
-                <a:latin typeface="Exo 2"/>
-              </a:rPr>
-              <a:t>Adaptive Threshold: Q-Guard shifts limits dynamically based on transaction context.</a:t>
+              <a:t>• Adaptive Threshold: Q-Guard shifts limits dynamically based on transaction context.</a:t>
             </a:r>
           </a:p>
           <a:p>
             <a:pPr>
               <a:spcAft>
-                <a:spcPts val="1400"/>
+                <a:spcPts val="1200"/>
               </a:spcAft>
+              <a:defRPr sz="1600">
+                <a:solidFill>
+                  <a:srgbClr val="DCF0FF"/>
+                </a:solidFill>
+              </a:defRPr>
             </a:pPr>
             <a:r>
-              <a:rPr sz="1500">
-                <a:solidFill>
-                  <a:srgbClr val="283241"/>
-                </a:solidFill>
-                <a:latin typeface="Exo 2"/>
-              </a:rPr>
-              <a:t>Late Night Hour Window (12 AM - 5 AM): Threshold drops to 65% (restrictive).</a:t>
+              <a:t>• Late Night Hour Window (12 AM - 5 AM): Threshold drops to 65% (restrictive).</a:t>
             </a:r>
           </a:p>
           <a:p>
             <a:pPr>
               <a:spcAft>
-                <a:spcPts val="1400"/>
+                <a:spcPts val="1200"/>
               </a:spcAft>
+              <a:defRPr sz="1600">
+                <a:solidFill>
+                  <a:srgbClr val="DCF0FF"/>
+                </a:solidFill>
+              </a:defRPr>
             </a:pPr>
             <a:r>
-              <a:rPr sz="1500">
-                <a:solidFill>
-                  <a:srgbClr val="283241"/>
-                </a:solidFill>
-                <a:latin typeface="Exo 2"/>
-              </a:rPr>
-              <a:t>High chargeback Merchant Terminal: Threshold drops to 58% (tighter security).</a:t>
+              <a:t>• High chargeback Merchant Terminal: Threshold drops to 58% (highly secure).</a:t>
             </a:r>
           </a:p>
           <a:p>
             <a:pPr>
               <a:spcAft>
-                <a:spcPts val="1400"/>
+                <a:spcPts val="1200"/>
               </a:spcAft>
-            </a:pPr>
-            <a:r>
-              <a:rPr sz="1500">
+              <a:defRPr sz="1600">
                 <a:solidFill>
-                  <a:srgbClr val="283241"/>
+                  <a:srgbClr val="DCF0FF"/>
                 </a:solidFill>
-                <a:latin typeface="Exo 2"/>
-              </a:rPr>
-              <a:t>Trusted Regular Customer: Threshold rises to 95% (minimizes customer friction).</a:t>
-            </a:r>
-          </a:p>
-        </p:txBody>
-      </p:sp>
-    </p:spTree>
-  </p:cSld>
-  <p:clrMapOvr>
-    <a:masterClrMapping/>
-  </p:clrMapOvr>
-</p:sld>
-</file>
-
-<file path=ppt/slides/slide5.xml><?xml version="1.0" encoding="utf-8"?>
-<p:sld xmlns:a="http://schemas.openxmlformats.org/drawingml/2006/main" xmlns:p="http://schemas.openxmlformats.org/presentationml/2006/main" xmlns:r="http://schemas.openxmlformats.org/officeDocument/2006/relationships">
-  <p:cSld>
-    <p:spTree>
-      <p:nvGrpSpPr>
-        <p:cNvPr id="1" name=""/>
-        <p:cNvGrpSpPr/>
-        <p:nvPr/>
-      </p:nvGrpSpPr>
-      <p:grpSpPr/>
-      <p:sp>
-        <p:nvSpPr>
-          <p:cNvPr id="2" name="Title 1"/>
-          <p:cNvSpPr>
-            <a:spLocks noGrp="1"/>
-          </p:cNvSpPr>
-          <p:nvPr>
-            <p:ph type="title"/>
-          </p:nvPr>
-        </p:nvSpPr>
-        <p:spPr/>
-        <p:txBody>
-          <a:bodyPr/>
-          <a:lstStyle/>
-          <a:p>
-            <a:pPr>
-              <a:defRPr sz="2800" b="1">
-                <a:solidFill>
-                  <a:srgbClr val="0A2D50"/>
-                </a:solidFill>
-                <a:latin typeface="Rajdhani"/>
               </a:defRPr>
             </a:pPr>
             <a:r>
-              <a:t>4. ADAPTIVE CONTEXT THRESHOLD ENGINE</a:t>
-            </a:r>
-          </a:p>
-        </p:txBody>
-      </p:sp>
-      <p:sp>
-        <p:nvSpPr>
-          <p:cNvPr id="3" name="Content Placeholder 2"/>
-          <p:cNvSpPr>
-            <a:spLocks noGrp="1"/>
-          </p:cNvSpPr>
-          <p:nvPr>
-            <p:ph idx="1" sz="quarter"/>
-          </p:nvPr>
-        </p:nvSpPr>
-        <p:spPr/>
-        <p:txBody>
-          <a:bodyPr wrap="square"/>
-          <a:lstStyle/>
-          <a:p>
-            <a:pPr>
-              <a:spcAft>
-                <a:spcPts val="1400"/>
-              </a:spcAft>
-            </a:pPr>
-            <a:r>
-              <a:rPr sz="1500">
-                <a:solidFill>
-                  <a:srgbClr val="283241"/>
-                </a:solidFill>
-                <a:latin typeface="Exo 2"/>
-              </a:rPr>
-              <a:t>Static Limits: Traditional systems block at a flat 80% limit, causing high friction.</a:t>
-            </a:r>
-          </a:p>
-          <a:p>
-            <a:pPr>
-              <a:spcAft>
-                <a:spcPts val="1400"/>
-              </a:spcAft>
-            </a:pPr>
-            <a:r>
-              <a:rPr sz="1500">
-                <a:solidFill>
-                  <a:srgbClr val="283241"/>
-                </a:solidFill>
-                <a:latin typeface="Exo 2"/>
-              </a:rPr>
-              <a:t>Adaptive Threshold: Q-Guard shifts limits dynamically based on transaction context.</a:t>
-            </a:r>
-          </a:p>
-          <a:p>
-            <a:pPr>
-              <a:spcAft>
-                <a:spcPts val="1400"/>
-              </a:spcAft>
-            </a:pPr>
-            <a:r>
-              <a:rPr sz="1500">
-                <a:solidFill>
-                  <a:srgbClr val="283241"/>
-                </a:solidFill>
-                <a:latin typeface="Exo 2"/>
-              </a:rPr>
-              <a:t>Late Night Hour Window (12 AM - 5 AM): Threshold drops to 65% (restrictive).</a:t>
-            </a:r>
-          </a:p>
-          <a:p>
-            <a:pPr>
-              <a:spcAft>
-                <a:spcPts val="1400"/>
-              </a:spcAft>
-            </a:pPr>
-            <a:r>
-              <a:rPr sz="1500">
-                <a:solidFill>
-                  <a:srgbClr val="283241"/>
-                </a:solidFill>
-                <a:latin typeface="Exo 2"/>
-              </a:rPr>
-              <a:t>High chargeback Merchant Terminal: Threshold drops to 58% (tighter security).</a:t>
-            </a:r>
-          </a:p>
-          <a:p>
-            <a:pPr>
-              <a:spcAft>
-                <a:spcPts val="1400"/>
-              </a:spcAft>
-            </a:pPr>
-            <a:r>
-              <a:rPr sz="1500">
-                <a:solidFill>
-                  <a:srgbClr val="283241"/>
-                </a:solidFill>
-                <a:latin typeface="Exo 2"/>
-              </a:rPr>
-              <a:t>Trusted Regular Customer: Threshold rises to 95% (minimizes customer friction).</a:t>
+              <a:t>• Trusted Regular Customer: Threshold rises to 95% (minimizes customer friction).</a:t>
             </a:r>
           </a:p>
         </p:txBody>
@@ -8574,16 +7432,8 @@
           <a:bodyPr/>
           <a:lstStyle/>
           <a:p>
-            <a:pPr>
-              <a:defRPr sz="2800" b="1">
-                <a:solidFill>
-                  <a:srgbClr val="0A2D50"/>
-                </a:solidFill>
-                <a:latin typeface="Rajdhani"/>
-              </a:defRPr>
-            </a:pPr>
-            <a:r>
-              <a:t>5. SELF-EXPLAINABLE AI &amp; STRATEGY MITIGATION</a:t>
+            <a:r>
+              <a:t>5. SELF-EXPLAINABLE AI &amp; MITIGATION CHECKLISTS</a:t>
             </a:r>
           </a:p>
         </p:txBody>
@@ -8605,81 +7455,76 @@
           <a:p>
             <a:pPr>
               <a:spcAft>
-                <a:spcPts val="1400"/>
+                <a:spcPts val="1200"/>
               </a:spcAft>
+              <a:defRPr sz="1600">
+                <a:solidFill>
+                  <a:srgbClr val="DCF0FF"/>
+                </a:solidFill>
+              </a:defRPr>
             </a:pPr>
             <a:r>
-              <a:rPr sz="1500">
-                <a:solidFill>
-                  <a:srgbClr val="283241"/>
-                </a:solidFill>
-                <a:latin typeface="Exo 2"/>
-              </a:rPr>
-              <a:t>Self-Explainable AI (XAI): Translates VQC state vectors into natural language warning logs.</a:t>
+              <a:t>• Self-Explainable AI (XAI): Translates VQC state vectors into warning logs.</a:t>
             </a:r>
           </a:p>
           <a:p>
             <a:pPr>
               <a:spcAft>
-                <a:spcPts val="1400"/>
+                <a:spcPts val="1200"/>
               </a:spcAft>
+              <a:defRPr sz="1600">
+                <a:solidFill>
+                  <a:srgbClr val="DCF0FF"/>
+                </a:solidFill>
+              </a:defRPr>
             </a:pPr>
             <a:r>
-              <a:rPr sz="1500">
-                <a:solidFill>
-                  <a:srgbClr val="283241"/>
-                </a:solidFill>
-                <a:latin typeface="Exo 2"/>
-              </a:rPr>
-              <a:t>Auditable Compliance: Outlines exactly why an agent triggered the transaction block.</a:t>
+              <a:t>• Auditable Compliance: Outlines exactly why an agent triggered the transaction block.</a:t>
             </a:r>
           </a:p>
           <a:p>
             <a:pPr>
               <a:spcAft>
-                <a:spcPts val="1400"/>
+                <a:spcPts val="1200"/>
               </a:spcAft>
+              <a:defRPr sz="1600">
+                <a:solidFill>
+                  <a:srgbClr val="DCF0FF"/>
+                </a:solidFill>
+              </a:defRPr>
             </a:pPr>
             <a:r>
-              <a:rPr sz="1500">
-                <a:solidFill>
-                  <a:srgbClr val="283241"/>
-                </a:solidFill>
-                <a:latin typeface="Exo 2"/>
-              </a:rPr>
-              <a:t>Fraud Strategy Advisor: Recommends progressive mitigation checklists instead of binary blocks.</a:t>
+              <a:t>• Fraud Strategy Advisor: Recommends progressive mitigation checklists instead of binary blocks.</a:t>
             </a:r>
           </a:p>
           <a:p>
             <a:pPr>
               <a:spcAft>
-                <a:spcPts val="1400"/>
+                <a:spcPts val="1200"/>
               </a:spcAft>
+              <a:defRPr sz="1600">
+                <a:solidFill>
+                  <a:srgbClr val="DCF0FF"/>
+                </a:solidFill>
+              </a:defRPr>
             </a:pPr>
             <a:r>
-              <a:rPr sz="1500">
-                <a:solidFill>
-                  <a:srgbClr val="283241"/>
-                </a:solidFill>
-                <a:latin typeface="Exo 2"/>
-              </a:rPr>
-              <a:t>Mitigation Checklist: Request Face Authentication, Require SMS OTP, or Hold payout.</a:t>
+              <a:t>• Mitigation Checklist: Request Face Authentication, Require SMS OTP, or Hold payout.</a:t>
             </a:r>
           </a:p>
           <a:p>
             <a:pPr>
               <a:spcAft>
-                <a:spcPts val="1400"/>
+                <a:spcPts val="1200"/>
               </a:spcAft>
+              <a:defRPr sz="1600">
+                <a:solidFill>
+                  <a:srgbClr val="DCF0FF"/>
+                </a:solidFill>
+              </a:defRPr>
             </a:pPr>
             <a:r>
-              <a:rPr sz="1500">
-                <a:solidFill>
-                  <a:srgbClr val="283241"/>
-                </a:solidFill>
-                <a:latin typeface="Exo 2"/>
-              </a:rPr>
-              <a:t>Benefit: Matches regulatory audit frameworks while keeping user friction minimal.</a:t>
+              <a:t>• Benefit: Reduces manual review audit delays and matches regulatory frameworks.</a:t>
             </a:r>
           </a:p>
         </p:txBody>
@@ -8717,16 +7562,8 @@
           <a:bodyPr/>
           <a:lstStyle/>
           <a:p>
-            <a:pPr>
-              <a:defRPr sz="2800" b="1">
-                <a:solidFill>
-                  <a:srgbClr val="0A2D50"/>
-                </a:solidFill>
-                <a:latin typeface="Rajdhani"/>
-              </a:defRPr>
-            </a:pPr>
-            <a:r>
-              <a:t>6. SCALABILITY &amp; DATABASE PIPELINE INTEGRATION</a:t>
+            <a:r>
+              <a:t>6. SCALABILITY &amp; DATABASE PIPELINE Integration</a:t>
             </a:r>
           </a:p>
         </p:txBody>
@@ -8748,510 +7585,76 @@
           <a:p>
             <a:pPr>
               <a:spcAft>
-                <a:spcPts val="1400"/>
+                <a:spcPts val="1200"/>
               </a:spcAft>
+              <a:defRPr sz="1600">
+                <a:solidFill>
+                  <a:srgbClr val="DCF0FF"/>
+                </a:solidFill>
+              </a:defRPr>
             </a:pPr>
             <a:r>
-              <a:rPr sz="1500">
-                <a:solidFill>
-                  <a:srgbClr val="283241"/>
-                </a:solidFill>
-                <a:latin typeface="Exo 2"/>
-              </a:rPr>
-              <a:t>Kaggle Database: Integrated with 3,000 real-world transaction logs (IEEE-CIS).</a:t>
+              <a:t>• Kaggle Database: Integrated with 3,000 real-world transaction logs (IEEE-CIS).</a:t>
             </a:r>
           </a:p>
           <a:p>
             <a:pPr>
               <a:spcAft>
-                <a:spcPts val="1400"/>
+                <a:spcPts val="1200"/>
               </a:spcAft>
+              <a:defRPr sz="1600">
+                <a:solidFill>
+                  <a:srgbClr val="DCF0FF"/>
+                </a:solidFill>
+              </a:defRPr>
             </a:pPr>
             <a:r>
-              <a:rPr sz="1500">
-                <a:solidFill>
-                  <a:srgbClr val="283241"/>
-                </a:solidFill>
-                <a:latin typeface="Exo 2"/>
-              </a:rPr>
-              <a:t>MongoDB Integration: Stores transactions and quantum telemetry in indexed collections.</a:t>
+              <a:t>• MongoDB Integration: Stores transactions and quantum telemetry in indexed collections.</a:t>
             </a:r>
           </a:p>
           <a:p>
             <a:pPr>
               <a:spcAft>
-                <a:spcPts val="1400"/>
+                <a:spcPts val="1200"/>
               </a:spcAft>
+              <a:defRPr sz="1600">
+                <a:solidFill>
+                  <a:srgbClr val="DCF0FF"/>
+                </a:solidFill>
+              </a:defRPr>
             </a:pPr>
             <a:r>
-              <a:rPr sz="1500">
-                <a:solidFill>
-                  <a:srgbClr val="283241"/>
-                </a:solidFill>
-                <a:latin typeface="Exo 2"/>
-              </a:rPr>
-              <a:t>FastAPI REST endpoints: Exposes VQC coordinates, dynamic weights, and strategies.</a:t>
+              <a:t>• FastAPI REST endpoints: Exposes VQC coordinates, dynamic weights, and strategies.</a:t>
             </a:r>
           </a:p>
           <a:p>
             <a:pPr>
               <a:spcAft>
-                <a:spcPts val="1400"/>
+                <a:spcPts val="1200"/>
               </a:spcAft>
+              <a:defRPr sz="1600">
+                <a:solidFill>
+                  <a:srgbClr val="DCF0FF"/>
+                </a:solidFill>
+              </a:defRPr>
             </a:pPr>
             <a:r>
-              <a:rPr sz="1500">
-                <a:solidFill>
-                  <a:srgbClr val="283241"/>
-                </a:solidFill>
-                <a:latin typeface="Exo 2"/>
-              </a:rPr>
-              <a:t>Vercel Deployment: Standalone HTML visualizer deployed live on cloud static servers.</a:t>
+              <a:t>• Vercel Deployment: Standalone HTML visualizer deployed live on cloud static servers.</a:t>
             </a:r>
           </a:p>
           <a:p>
             <a:pPr>
               <a:spcAft>
-                <a:spcPts val="1400"/>
+                <a:spcPts val="1200"/>
               </a:spcAft>
-            </a:pPr>
-            <a:r>
-              <a:rPr sz="1500">
+              <a:defRPr sz="1600">
                 <a:solidFill>
-                  <a:srgbClr val="283241"/>
+                  <a:srgbClr val="DCF0FF"/>
                 </a:solidFill>
-                <a:latin typeface="Exo 2"/>
-              </a:rPr>
-              <a:t>Result: A scalable, production-grade Quantum-Graph system ready for deployment.</a:t>
-            </a:r>
-          </a:p>
-        </p:txBody>
-      </p:sp>
-    </p:spTree>
-  </p:cSld>
-  <p:clrMapOvr>
-    <a:masterClrMapping/>
-  </p:clrMapOvr>
-</p:sld>
-</file>
-
-<file path=ppt/slides/slide7.xml><?xml version="1.0" encoding="utf-8"?>
-<p:sld xmlns:a="http://schemas.openxmlformats.org/drawingml/2006/main" xmlns:p="http://schemas.openxmlformats.org/presentationml/2006/main" xmlns:r="http://schemas.openxmlformats.org/officeDocument/2006/relationships">
-  <p:cSld>
-    <p:spTree>
-      <p:nvGrpSpPr>
-        <p:cNvPr id="1" name=""/>
-        <p:cNvGrpSpPr/>
-        <p:nvPr/>
-      </p:nvGrpSpPr>
-      <p:grpSpPr/>
-      <p:sp>
-        <p:nvSpPr>
-          <p:cNvPr id="2" name="Title 1"/>
-          <p:cNvSpPr>
-            <a:spLocks noGrp="1"/>
-          </p:cNvSpPr>
-          <p:nvPr>
-            <p:ph type="title"/>
-          </p:nvPr>
-        </p:nvSpPr>
-        <p:spPr/>
-        <p:txBody>
-          <a:bodyPr/>
-          <a:lstStyle/>
-          <a:p>
-            <a:pPr>
-              <a:defRPr sz="2800" b="1">
-                <a:solidFill>
-                  <a:srgbClr val="0A2D50"/>
-                </a:solidFill>
-                <a:latin typeface="Rajdhani"/>
               </a:defRPr>
             </a:pPr>
             <a:r>
-              <a:t>6. SCALABILITY &amp; DATABASE PIPELINE INTEGRATION</a:t>
-            </a:r>
-          </a:p>
-        </p:txBody>
-      </p:sp>
-      <p:sp>
-        <p:nvSpPr>
-          <p:cNvPr id="3" name="Content Placeholder 2"/>
-          <p:cNvSpPr>
-            <a:spLocks noGrp="1"/>
-          </p:cNvSpPr>
-          <p:nvPr>
-            <p:ph idx="1" sz="quarter"/>
-          </p:nvPr>
-        </p:nvSpPr>
-        <p:spPr/>
-        <p:txBody>
-          <a:bodyPr wrap="square"/>
-          <a:lstStyle/>
-          <a:p>
-            <a:pPr>
-              <a:spcAft>
-                <a:spcPts val="1400"/>
-              </a:spcAft>
-            </a:pPr>
-            <a:r>
-              <a:rPr sz="1500">
-                <a:solidFill>
-                  <a:srgbClr val="283241"/>
-                </a:solidFill>
-                <a:latin typeface="Exo 2"/>
-              </a:rPr>
-              <a:t>Kaggle Database: Integrated with 3,000 real-world transaction logs (IEEE-CIS).</a:t>
-            </a:r>
-          </a:p>
-          <a:p>
-            <a:pPr>
-              <a:spcAft>
-                <a:spcPts val="1400"/>
-              </a:spcAft>
-            </a:pPr>
-            <a:r>
-              <a:rPr sz="1500">
-                <a:solidFill>
-                  <a:srgbClr val="283241"/>
-                </a:solidFill>
-                <a:latin typeface="Exo 2"/>
-              </a:rPr>
-              <a:t>MongoDB Integration: Stores transactions and quantum telemetry in indexed collections.</a:t>
-            </a:r>
-          </a:p>
-          <a:p>
-            <a:pPr>
-              <a:spcAft>
-                <a:spcPts val="1400"/>
-              </a:spcAft>
-            </a:pPr>
-            <a:r>
-              <a:rPr sz="1500">
-                <a:solidFill>
-                  <a:srgbClr val="283241"/>
-                </a:solidFill>
-                <a:latin typeface="Exo 2"/>
-              </a:rPr>
-              <a:t>FastAPI REST endpoints: Exposes VQC coordinates, dynamic weights, and strategies.</a:t>
-            </a:r>
-          </a:p>
-          <a:p>
-            <a:pPr>
-              <a:spcAft>
-                <a:spcPts val="1400"/>
-              </a:spcAft>
-            </a:pPr>
-            <a:r>
-              <a:rPr sz="1500">
-                <a:solidFill>
-                  <a:srgbClr val="283241"/>
-                </a:solidFill>
-                <a:latin typeface="Exo 2"/>
-              </a:rPr>
-              <a:t>Vercel Deployment: Standalone HTML visualizer deployed live on cloud static servers.</a:t>
-            </a:r>
-          </a:p>
-          <a:p>
-            <a:pPr>
-              <a:spcAft>
-                <a:spcPts val="1400"/>
-              </a:spcAft>
-            </a:pPr>
-            <a:r>
-              <a:rPr sz="1500">
-                <a:solidFill>
-                  <a:srgbClr val="283241"/>
-                </a:solidFill>
-                <a:latin typeface="Exo 2"/>
-              </a:rPr>
-              <a:t>Result: A scalable, production-grade Quantum-Graph system ready for deployment.</a:t>
-            </a:r>
-          </a:p>
-        </p:txBody>
-      </p:sp>
-    </p:spTree>
-  </p:cSld>
-  <p:clrMapOvr>
-    <a:masterClrMapping/>
-  </p:clrMapOvr>
-</p:sld>
-</file>
-
-<file path=ppt/slides/slide8.xml><?xml version="1.0" encoding="utf-8"?>
-<p:sld xmlns:a="http://schemas.openxmlformats.org/drawingml/2006/main" xmlns:p="http://schemas.openxmlformats.org/presentationml/2006/main" xmlns:r="http://schemas.openxmlformats.org/officeDocument/2006/relationships">
-  <p:cSld>
-    <p:spTree>
-      <p:nvGrpSpPr>
-        <p:cNvPr id="1" name=""/>
-        <p:cNvGrpSpPr/>
-        <p:nvPr/>
-      </p:nvGrpSpPr>
-      <p:grpSpPr/>
-      <p:sp>
-        <p:nvSpPr>
-          <p:cNvPr id="2" name="Title 1"/>
-          <p:cNvSpPr>
-            <a:spLocks noGrp="1"/>
-          </p:cNvSpPr>
-          <p:nvPr>
-            <p:ph type="title"/>
-          </p:nvPr>
-        </p:nvSpPr>
-        <p:spPr/>
-        <p:txBody>
-          <a:bodyPr/>
-          <a:lstStyle/>
-          <a:p>
-            <a:pPr>
-              <a:defRPr sz="2800" b="1">
-                <a:solidFill>
-                  <a:srgbClr val="0A2D50"/>
-                </a:solidFill>
-                <a:latin typeface="Rajdhani"/>
-              </a:defRPr>
-            </a:pPr>
-            <a:r>
-              <a:t>2. Q-GUARD ARCHITECTURE: MULTI-AGENT INGESTION</a:t>
-            </a:r>
-          </a:p>
-        </p:txBody>
-      </p:sp>
-      <p:sp>
-        <p:nvSpPr>
-          <p:cNvPr id="3" name="Content Placeholder 2"/>
-          <p:cNvSpPr>
-            <a:spLocks noGrp="1"/>
-          </p:cNvSpPr>
-          <p:nvPr>
-            <p:ph idx="1" sz="quarter"/>
-          </p:nvPr>
-        </p:nvSpPr>
-        <p:spPr/>
-        <p:txBody>
-          <a:bodyPr wrap="square"/>
-          <a:lstStyle/>
-          <a:p>
-            <a:pPr>
-              <a:spcAft>
-                <a:spcPts val="1400"/>
-              </a:spcAft>
-            </a:pPr>
-            <a:r>
-              <a:rPr sz="1500">
-                <a:solidFill>
-                  <a:srgbClr val="283241"/>
-                </a:solidFill>
-                <a:latin typeface="Exo 2"/>
-              </a:rPr>
-              <a:t>User Behavior Agent: Analyzes daily spending limit fractions and transaction volume.</a:t>
-            </a:r>
-          </a:p>
-          <a:p>
-            <a:pPr>
-              <a:spcAft>
-                <a:spcPts val="1400"/>
-              </a:spcAft>
-            </a:pPr>
-            <a:r>
-              <a:rPr sz="1500">
-                <a:solidFill>
-                  <a:srgbClr val="283241"/>
-                </a:solidFill>
-                <a:latin typeface="Exo 2"/>
-              </a:rPr>
-              <a:t>Device Intelligence Agent: Detects OS versions, emulators, and device trust rating.</a:t>
-            </a:r>
-          </a:p>
-          <a:p>
-            <a:pPr>
-              <a:spcAft>
-                <a:spcPts val="1400"/>
-              </a:spcAft>
-            </a:pPr>
-            <a:r>
-              <a:rPr sz="1500">
-                <a:solidFill>
-                  <a:srgbClr val="283241"/>
-                </a:solidFill>
-                <a:latin typeface="Exo 2"/>
-              </a:rPr>
-              <a:t>Merchant Rating Agent: Assesses merchant category hazard and chargeback rates.</a:t>
-            </a:r>
-          </a:p>
-          <a:p>
-            <a:pPr>
-              <a:spcAft>
-                <a:spcPts val="1400"/>
-              </a:spcAft>
-            </a:pPr>
-            <a:r>
-              <a:rPr sz="1500">
-                <a:solidFill>
-                  <a:srgbClr val="283241"/>
-                </a:solidFill>
-                <a:latin typeface="Exo 2"/>
-              </a:rPr>
-              <a:t>Network Intelligence Agent: Monitors VPN usage, proxy IPs, and impossible travel.</a:t>
-            </a:r>
-          </a:p>
-          <a:p>
-            <a:pPr>
-              <a:spcAft>
-                <a:spcPts val="1400"/>
-              </a:spcAft>
-            </a:pPr>
-            <a:r>
-              <a:rPr sz="1500">
-                <a:solidFill>
-                  <a:srgbClr val="283241"/>
-                </a:solidFill>
-                <a:latin typeface="Exo 2"/>
-              </a:rPr>
-              <a:t>Decentralized Ingestion: Captures separate threat layers simultaneously to prevent bypass.</a:t>
-            </a:r>
-          </a:p>
-        </p:txBody>
-      </p:sp>
-    </p:spTree>
-  </p:cSld>
-  <p:clrMapOvr>
-    <a:masterClrMapping/>
-  </p:clrMapOvr>
-</p:sld>
-</file>
-
-<file path=ppt/slides/slide9.xml><?xml version="1.0" encoding="utf-8"?>
-<p:sld xmlns:a="http://schemas.openxmlformats.org/drawingml/2006/main" xmlns:p="http://schemas.openxmlformats.org/presentationml/2006/main" xmlns:r="http://schemas.openxmlformats.org/officeDocument/2006/relationships">
-  <p:cSld>
-    <p:spTree>
-      <p:nvGrpSpPr>
-        <p:cNvPr id="1" name=""/>
-        <p:cNvGrpSpPr/>
-        <p:nvPr/>
-      </p:nvGrpSpPr>
-      <p:grpSpPr/>
-      <p:sp>
-        <p:nvSpPr>
-          <p:cNvPr id="2" name="Title 1"/>
-          <p:cNvSpPr>
-            <a:spLocks noGrp="1"/>
-          </p:cNvSpPr>
-          <p:nvPr>
-            <p:ph type="title"/>
-          </p:nvPr>
-        </p:nvSpPr>
-        <p:spPr/>
-        <p:txBody>
-          <a:bodyPr/>
-          <a:lstStyle/>
-          <a:p>
-            <a:pPr>
-              <a:defRPr sz="2800" b="1">
-                <a:solidFill>
-                  <a:srgbClr val="0A2D50"/>
-                </a:solidFill>
-                <a:latin typeface="Rajdhani"/>
-              </a:defRPr>
-            </a:pPr>
-            <a:r>
-              <a:t>3. QUANTUM WEIGHT OPTIMIZATION (QML LAYER)</a:t>
-            </a:r>
-          </a:p>
-        </p:txBody>
-      </p:sp>
-      <p:sp>
-        <p:nvSpPr>
-          <p:cNvPr id="3" name="Content Placeholder 2"/>
-          <p:cNvSpPr>
-            <a:spLocks noGrp="1"/>
-          </p:cNvSpPr>
-          <p:nvPr>
-            <p:ph idx="1" sz="quarter"/>
-          </p:nvPr>
-        </p:nvSpPr>
-        <p:spPr/>
-        <p:txBody>
-          <a:bodyPr wrap="square"/>
-          <a:lstStyle/>
-          <a:p>
-            <a:pPr>
-              <a:spcAft>
-                <a:spcPts val="1400"/>
-              </a:spcAft>
-            </a:pPr>
-            <a:r>
-              <a:rPr sz="1500">
-                <a:solidFill>
-                  <a:srgbClr val="283241"/>
-                </a:solidFill>
-                <a:latin typeface="Exo 2"/>
-              </a:rPr>
-              <a:t>State Encoding: Maps the 4 Agent risk variables directly to 4 Qubits (Q0 to Q3).</a:t>
-            </a:r>
-          </a:p>
-          <a:p>
-            <a:pPr>
-              <a:spcAft>
-                <a:spcPts val="1400"/>
-              </a:spcAft>
-            </a:pPr>
-            <a:r>
-              <a:rPr sz="1500">
-                <a:solidFill>
-                  <a:srgbClr val="283241"/>
-                </a:solidFill>
-                <a:latin typeface="Exo 2"/>
-              </a:rPr>
-              <a:t>Entangling Circuit: Employs a Ring CNOT entangler to learn non-linear inter-agent correlations.</a:t>
-            </a:r>
-          </a:p>
-          <a:p>
-            <a:pPr>
-              <a:spcAft>
-                <a:spcPts val="1400"/>
-              </a:spcAft>
-            </a:pPr>
-            <a:r>
-              <a:rPr sz="1500">
-                <a:solidFill>
-                  <a:srgbClr val="283241"/>
-                </a:solidFill>
-                <a:latin typeface="Exo 2"/>
-              </a:rPr>
-              <a:t>Dynamic Weighting: Aggregates risk dynamically based on Qubit Z-coordinate excitation.</a:t>
-            </a:r>
-          </a:p>
-          <a:p>
-            <a:pPr>
-              <a:spcAft>
-                <a:spcPts val="1400"/>
-              </a:spcAft>
-            </a:pPr>
-            <a:r>
-              <a:rPr sz="1500">
-                <a:solidFill>
-                  <a:srgbClr val="283241"/>
-                </a:solidFill>
-                <a:latin typeface="Exo 2"/>
-              </a:rPr>
-              <a:t>Bloch Projections: Agent weights are proportional to excitation (Weight = 1.0 - Z).</a:t>
-            </a:r>
-          </a:p>
-          <a:p>
-            <a:pPr>
-              <a:spcAft>
-                <a:spcPts val="1400"/>
-              </a:spcAft>
-            </a:pPr>
-            <a:r>
-              <a:rPr sz="1500">
-                <a:solidFill>
-                  <a:srgbClr val="283241"/>
-                </a:solidFill>
-                <a:latin typeface="Exo 2"/>
-              </a:rPr>
-              <a:t>Benefit: Captures non-linear threat vectors using 90% fewer parameters than classical NN.</a:t>
+              <a:t>• Result: A scalable, production-grade Quantum-Graph system ready for deployment.</a:t>
             </a:r>
           </a:p>
         </p:txBody>

</xml_diff>

<commit_message>
Generate and finalize expanded 12-slide Pitch Deck for Quantathon 2026
</commit_message>
<xml_diff>
--- a/RIT - Quantathan 2026 - PPT.pptx
+++ b/RIT - Quantathan 2026 - PPT.pptx
@@ -5,16 +5,22 @@
     <p:sldMasterId id="2147483660" r:id="rId1"/>
   </p:sldMasterIdLst>
   <p:notesMasterIdLst>
-    <p:notesMasterId r:id="rId4"/>
+    <p:notesMasterId r:id="rId17"/>
   </p:notesMasterIdLst>
   <p:sldIdLst>
     <p:sldId id="256" r:id="rId2"/>
-    <p:sldId id="257" r:id="rId3"/>
-    <p:sldId id="258" r:id="rId9"/>
-    <p:sldId id="259" r:id="rId10"/>
-    <p:sldId id="260" r:id="rId11"/>
-    <p:sldId id="261" r:id="rId12"/>
-    <p:sldId id="262" r:id="rId13"/>
+    <p:sldId id="257" r:id="rId22"/>
+    <p:sldId id="258" r:id="rId23"/>
+    <p:sldId id="259" r:id="rId24"/>
+    <p:sldId id="260" r:id="rId25"/>
+    <p:sldId id="261" r:id="rId26"/>
+    <p:sldId id="262" r:id="rId27"/>
+    <p:sldId id="263" r:id="rId28"/>
+    <p:sldId id="264" r:id="rId29"/>
+    <p:sldId id="265" r:id="rId30"/>
+    <p:sldId id="266" r:id="rId31"/>
+    <p:sldId id="267" r:id="rId32"/>
+    <p:sldId id="268" r:id="rId33"/>
   </p:sldIdLst>
   <p:sldSz cx="9144000" cy="6858000" type="screen4x3"/>
   <p:notesSz cx="6858000" cy="9144000"/>
@@ -214,7 +220,7 @@
           <a:p>
             <a:fld id="{02B84611-C05A-4FE0-9E94-CECBDE5B39B4}" type="datetimeFigureOut">
               <a:rPr lang="en-US" smtClean="0"/>
-              <a:t>6/25/2026</a:t>
+              <a:t>7/9/2026</a:t>
             </a:fld>
             <a:endParaRPr lang="en-IN"/>
           </a:p>
@@ -280,35 +286,35 @@
           <a:p>
             <a:pPr lvl="0"/>
             <a:r>
-              <a:rPr lang="en-US" smtClean="0"/>
+              <a:rPr lang="en-US"/>
               <a:t>Click to edit Master text styles</a:t>
             </a:r>
           </a:p>
           <a:p>
             <a:pPr lvl="1"/>
             <a:r>
-              <a:rPr lang="en-US" smtClean="0"/>
+              <a:rPr lang="en-US"/>
               <a:t>Second level</a:t>
             </a:r>
           </a:p>
           <a:p>
             <a:pPr lvl="2"/>
             <a:r>
-              <a:rPr lang="en-US" smtClean="0"/>
+              <a:rPr lang="en-US"/>
               <a:t>Third level</a:t>
             </a:r>
           </a:p>
           <a:p>
             <a:pPr lvl="3"/>
             <a:r>
-              <a:rPr lang="en-US" smtClean="0"/>
+              <a:rPr lang="en-US"/>
               <a:t>Fourth level</a:t>
             </a:r>
           </a:p>
           <a:p>
             <a:pPr lvl="4"/>
             <a:r>
-              <a:rPr lang="en-US" smtClean="0"/>
+              <a:rPr lang="en-US"/>
               <a:t>Fifth level</a:t>
             </a:r>
             <a:endParaRPr lang="en-IN"/>
@@ -560,6 +566,174 @@
 </p:notes>
 </file>
 
+<file path=ppt/notesSlides/notesSlide2.xml><?xml version="1.0" encoding="utf-8"?>
+<p:notes xmlns:a="http://schemas.openxmlformats.org/drawingml/2006/main" xmlns:r="http://schemas.openxmlformats.org/officeDocument/2006/relationships" xmlns:p="http://schemas.openxmlformats.org/presentationml/2006/main">
+  <p:cSld>
+    <p:spTree>
+      <p:nvGrpSpPr>
+        <p:cNvPr id="1" name=""/>
+        <p:cNvGrpSpPr/>
+        <p:nvPr/>
+      </p:nvGrpSpPr>
+      <p:grpSpPr>
+        <a:xfrm>
+          <a:off x="0" y="0"/>
+          <a:ext cx="0" cy="0"/>
+          <a:chOff x="0" y="0"/>
+          <a:chExt cx="0" cy="0"/>
+        </a:xfrm>
+      </p:grpSpPr>
+      <p:sp>
+        <p:nvSpPr>
+          <p:cNvPr id="2" name="Slide Image Placeholder 1"/>
+          <p:cNvSpPr>
+            <a:spLocks noGrp="1" noRot="1" noChangeAspect="1"/>
+          </p:cNvSpPr>
+          <p:nvPr>
+            <p:ph type="sldImg"/>
+          </p:nvPr>
+        </p:nvSpPr>
+        <p:spPr/>
+      </p:sp>
+      <p:sp>
+        <p:nvSpPr>
+          <p:cNvPr id="3" name="Notes Placeholder 2"/>
+          <p:cNvSpPr>
+            <a:spLocks noGrp="1"/>
+          </p:cNvSpPr>
+          <p:nvPr>
+            <p:ph type="body" idx="1"/>
+          </p:nvPr>
+        </p:nvSpPr>
+        <p:spPr/>
+        <p:txBody>
+          <a:bodyPr/>
+          <a:lstStyle/>
+          <a:p>
+            <a:endParaRPr lang="en-IN" dirty="0"/>
+          </a:p>
+        </p:txBody>
+      </p:sp>
+      <p:sp>
+        <p:nvSpPr>
+          <p:cNvPr id="4" name="Slide Number Placeholder 3"/>
+          <p:cNvSpPr>
+            <a:spLocks noGrp="1"/>
+          </p:cNvSpPr>
+          <p:nvPr>
+            <p:ph type="sldNum" sz="quarter" idx="5"/>
+          </p:nvPr>
+        </p:nvSpPr>
+        <p:spPr/>
+        <p:txBody>
+          <a:bodyPr/>
+          <a:lstStyle/>
+          <a:p>
+            <a:fld id="{3BDD5657-429F-4937-8DBC-7A2164C32DAC}" type="slidenum">
+              <a:rPr lang="en-IN" smtClean="0"/>
+              <a:t>7</a:t>
+            </a:fld>
+            <a:endParaRPr lang="en-IN"/>
+          </a:p>
+        </p:txBody>
+      </p:sp>
+    </p:spTree>
+    <p:extLst>
+      <p:ext uri="{BB962C8B-B14F-4D97-AF65-F5344CB8AC3E}">
+        <p14:creationId xmlns:p14="http://schemas.microsoft.com/office/powerpoint/2010/main" val="3188531727"/>
+      </p:ext>
+    </p:extLst>
+  </p:cSld>
+  <p:clrMapOvr>
+    <a:masterClrMapping/>
+  </p:clrMapOvr>
+</p:notes>
+</file>
+
+<file path=ppt/notesSlides/notesSlide3.xml><?xml version="1.0" encoding="utf-8"?>
+<p:notes xmlns:a="http://schemas.openxmlformats.org/drawingml/2006/main" xmlns:r="http://schemas.openxmlformats.org/officeDocument/2006/relationships" xmlns:p="http://schemas.openxmlformats.org/presentationml/2006/main">
+  <p:cSld>
+    <p:spTree>
+      <p:nvGrpSpPr>
+        <p:cNvPr id="1" name=""/>
+        <p:cNvGrpSpPr/>
+        <p:nvPr/>
+      </p:nvGrpSpPr>
+      <p:grpSpPr>
+        <a:xfrm>
+          <a:off x="0" y="0"/>
+          <a:ext cx="0" cy="0"/>
+          <a:chOff x="0" y="0"/>
+          <a:chExt cx="0" cy="0"/>
+        </a:xfrm>
+      </p:grpSpPr>
+      <p:sp>
+        <p:nvSpPr>
+          <p:cNvPr id="2" name="Slide Image Placeholder 1"/>
+          <p:cNvSpPr>
+            <a:spLocks noGrp="1" noRot="1" noChangeAspect="1"/>
+          </p:cNvSpPr>
+          <p:nvPr>
+            <p:ph type="sldImg"/>
+          </p:nvPr>
+        </p:nvSpPr>
+        <p:spPr/>
+      </p:sp>
+      <p:sp>
+        <p:nvSpPr>
+          <p:cNvPr id="3" name="Notes Placeholder 2"/>
+          <p:cNvSpPr>
+            <a:spLocks noGrp="1"/>
+          </p:cNvSpPr>
+          <p:nvPr>
+            <p:ph type="body" idx="1"/>
+          </p:nvPr>
+        </p:nvSpPr>
+        <p:spPr/>
+        <p:txBody>
+          <a:bodyPr/>
+          <a:lstStyle/>
+          <a:p>
+            <a:endParaRPr lang="en-IN" dirty="0"/>
+          </a:p>
+        </p:txBody>
+      </p:sp>
+      <p:sp>
+        <p:nvSpPr>
+          <p:cNvPr id="4" name="Slide Number Placeholder 3"/>
+          <p:cNvSpPr>
+            <a:spLocks noGrp="1"/>
+          </p:cNvSpPr>
+          <p:nvPr>
+            <p:ph type="sldNum" sz="quarter" idx="5"/>
+          </p:nvPr>
+        </p:nvSpPr>
+        <p:spPr/>
+        <p:txBody>
+          <a:bodyPr/>
+          <a:lstStyle/>
+          <a:p>
+            <a:fld id="{3BDD5657-429F-4937-8DBC-7A2164C32DAC}" type="slidenum">
+              <a:rPr lang="en-IN" smtClean="0"/>
+              <a:t>10</a:t>
+            </a:fld>
+            <a:endParaRPr lang="en-IN"/>
+          </a:p>
+        </p:txBody>
+      </p:sp>
+    </p:spTree>
+    <p:extLst>
+      <p:ext uri="{BB962C8B-B14F-4D97-AF65-F5344CB8AC3E}">
+        <p14:creationId xmlns:p14="http://schemas.microsoft.com/office/powerpoint/2010/main" val="3941644209"/>
+      </p:ext>
+    </p:extLst>
+  </p:cSld>
+  <p:clrMapOvr>
+    <a:masterClrMapping/>
+  </p:clrMapOvr>
+</p:notes>
+</file>
+
 <file path=ppt/slideLayouts/slideLayout1.xml><?xml version="1.0" encoding="utf-8"?>
 <p:sldLayout xmlns:a="http://schemas.openxmlformats.org/drawingml/2006/main" xmlns:r="http://schemas.openxmlformats.org/officeDocument/2006/relationships" xmlns:p="http://schemas.openxmlformats.org/presentationml/2006/main" showMasterSp="0" type="title" preserve="1">
   <p:cSld name="Title Slide">
@@ -816,10 +990,9 @@
           </a:lstStyle>
           <a:p>
             <a:r>
-              <a:rPr kumimoji="0" lang="en-US" smtClean="0"/>
+              <a:rPr kumimoji="0" lang="en-US"/>
               <a:t>Click to edit Master subtitle style</a:t>
             </a:r>
-            <a:endParaRPr kumimoji="0" lang="en-US"/>
           </a:p>
         </p:txBody>
       </p:sp>
@@ -840,7 +1013,7 @@
           <a:p>
             <a:fld id="{F7088B4A-5E74-4E7B-8C78-CA63012A9A2F}" type="datetimeFigureOut">
               <a:rPr lang="en-US" smtClean="0"/>
-              <a:t>6/25/2026</a:t>
+              <a:t>7/9/2026</a:t>
             </a:fld>
             <a:endParaRPr lang="en-IN"/>
           </a:p>
@@ -1104,10 +1277,9 @@
           </a:lstStyle>
           <a:p>
             <a:r>
-              <a:rPr kumimoji="0" lang="en-US" smtClean="0"/>
+              <a:rPr kumimoji="0" lang="en-US"/>
               <a:t>Click to edit Master title style</a:t>
             </a:r>
-            <a:endParaRPr kumimoji="0" lang="en-US"/>
           </a:p>
         </p:txBody>
       </p:sp>
@@ -1160,10 +1332,9 @@
           <a:lstStyle/>
           <a:p>
             <a:r>
-              <a:rPr kumimoji="0" lang="en-US" smtClean="0"/>
+              <a:rPr kumimoji="0" lang="en-US"/>
               <a:t>Click to edit Master title style</a:t>
             </a:r>
-            <a:endParaRPr kumimoji="0" lang="en-US"/>
           </a:p>
         </p:txBody>
       </p:sp>
@@ -1184,35 +1355,35 @@
           <a:p>
             <a:pPr lvl="0" eaLnBrk="1" latinLnBrk="0" hangingPunct="1"/>
             <a:r>
-              <a:rPr lang="en-US" smtClean="0"/>
+              <a:rPr lang="en-US"/>
               <a:t>Click to edit Master text styles</a:t>
             </a:r>
           </a:p>
           <a:p>
             <a:pPr lvl="1" eaLnBrk="1" latinLnBrk="0" hangingPunct="1"/>
             <a:r>
-              <a:rPr lang="en-US" smtClean="0"/>
+              <a:rPr lang="en-US"/>
               <a:t>Second level</a:t>
             </a:r>
           </a:p>
           <a:p>
             <a:pPr lvl="2" eaLnBrk="1" latinLnBrk="0" hangingPunct="1"/>
             <a:r>
-              <a:rPr lang="en-US" smtClean="0"/>
+              <a:rPr lang="en-US"/>
               <a:t>Third level</a:t>
             </a:r>
           </a:p>
           <a:p>
             <a:pPr lvl="3" eaLnBrk="1" latinLnBrk="0" hangingPunct="1"/>
             <a:r>
-              <a:rPr lang="en-US" smtClean="0"/>
+              <a:rPr lang="en-US"/>
               <a:t>Fourth level</a:t>
             </a:r>
           </a:p>
           <a:p>
             <a:pPr lvl="4" eaLnBrk="1" latinLnBrk="0" hangingPunct="1"/>
             <a:r>
-              <a:rPr lang="en-US" smtClean="0"/>
+              <a:rPr lang="en-US"/>
               <a:t>Fifth level</a:t>
             </a:r>
             <a:endParaRPr kumimoji="0" lang="en-US"/>
@@ -1236,7 +1407,7 @@
           <a:p>
             <a:fld id="{F7088B4A-5E74-4E7B-8C78-CA63012A9A2F}" type="datetimeFigureOut">
               <a:rPr lang="en-US" smtClean="0"/>
-              <a:t>6/25/2026</a:t>
+              <a:t>7/9/2026</a:t>
             </a:fld>
             <a:endParaRPr lang="en-IN"/>
           </a:p>
@@ -1719,35 +1890,35 @@
           <a:p>
             <a:pPr lvl="0" eaLnBrk="1" latinLnBrk="0" hangingPunct="1"/>
             <a:r>
-              <a:rPr lang="en-US" smtClean="0"/>
+              <a:rPr lang="en-US"/>
               <a:t>Click to edit Master text styles</a:t>
             </a:r>
           </a:p>
           <a:p>
             <a:pPr lvl="1" eaLnBrk="1" latinLnBrk="0" hangingPunct="1"/>
             <a:r>
-              <a:rPr lang="en-US" smtClean="0"/>
+              <a:rPr lang="en-US"/>
               <a:t>Second level</a:t>
             </a:r>
           </a:p>
           <a:p>
             <a:pPr lvl="2" eaLnBrk="1" latinLnBrk="0" hangingPunct="1"/>
             <a:r>
-              <a:rPr lang="en-US" smtClean="0"/>
+              <a:rPr lang="en-US"/>
               <a:t>Third level</a:t>
             </a:r>
           </a:p>
           <a:p>
             <a:pPr lvl="3" eaLnBrk="1" latinLnBrk="0" hangingPunct="1"/>
             <a:r>
-              <a:rPr lang="en-US" smtClean="0"/>
+              <a:rPr lang="en-US"/>
               <a:t>Fourth level</a:t>
             </a:r>
           </a:p>
           <a:p>
             <a:pPr lvl="4" eaLnBrk="1" latinLnBrk="0" hangingPunct="1"/>
             <a:r>
-              <a:rPr lang="en-US" smtClean="0"/>
+              <a:rPr lang="en-US"/>
               <a:t>Fifth level</a:t>
             </a:r>
             <a:endParaRPr kumimoji="0" lang="en-US"/>
@@ -1771,7 +1942,7 @@
           <a:p>
             <a:fld id="{F7088B4A-5E74-4E7B-8C78-CA63012A9A2F}" type="datetimeFigureOut">
               <a:rPr lang="en-US" smtClean="0"/>
-              <a:t>6/25/2026</a:t>
+              <a:t>7/9/2026</a:t>
             </a:fld>
             <a:endParaRPr lang="en-IN"/>
           </a:p>
@@ -1817,10 +1988,9 @@
           <a:lstStyle/>
           <a:p>
             <a:r>
-              <a:rPr kumimoji="0" lang="en-US" smtClean="0"/>
+              <a:rPr kumimoji="0" lang="en-US"/>
               <a:t>Click to edit Master title style</a:t>
             </a:r>
-            <a:endParaRPr kumimoji="0" lang="en-US"/>
           </a:p>
         </p:txBody>
       </p:sp>
@@ -1883,10 +2053,9 @@
           </a:lstStyle>
           <a:p>
             <a:r>
-              <a:rPr kumimoji="0" lang="en-US" smtClean="0"/>
+              <a:rPr kumimoji="0" lang="en-US"/>
               <a:t>Click to edit Master title style</a:t>
             </a:r>
-            <a:endParaRPr kumimoji="0" lang="en-US"/>
           </a:p>
         </p:txBody>
       </p:sp>
@@ -1907,7 +2076,7 @@
           <a:p>
             <a:fld id="{F7088B4A-5E74-4E7B-8C78-CA63012A9A2F}" type="datetimeFigureOut">
               <a:rPr lang="en-US" smtClean="0"/>
-              <a:t>6/25/2026</a:t>
+              <a:t>7/9/2026</a:t>
             </a:fld>
             <a:endParaRPr lang="en-IN"/>
           </a:p>
@@ -1982,35 +2151,35 @@
           <a:p>
             <a:pPr lvl="0" eaLnBrk="1" latinLnBrk="0" hangingPunct="1"/>
             <a:r>
-              <a:rPr lang="en-US" smtClean="0"/>
+              <a:rPr lang="en-US"/>
               <a:t>Click to edit Master text styles</a:t>
             </a:r>
           </a:p>
           <a:p>
             <a:pPr lvl="1" eaLnBrk="1" latinLnBrk="0" hangingPunct="1"/>
             <a:r>
-              <a:rPr lang="en-US" smtClean="0"/>
+              <a:rPr lang="en-US"/>
               <a:t>Second level</a:t>
             </a:r>
           </a:p>
           <a:p>
             <a:pPr lvl="2" eaLnBrk="1" latinLnBrk="0" hangingPunct="1"/>
             <a:r>
-              <a:rPr lang="en-US" smtClean="0"/>
+              <a:rPr lang="en-US"/>
               <a:t>Third level</a:t>
             </a:r>
           </a:p>
           <a:p>
             <a:pPr lvl="3" eaLnBrk="1" latinLnBrk="0" hangingPunct="1"/>
             <a:r>
-              <a:rPr lang="en-US" smtClean="0"/>
+              <a:rPr lang="en-US"/>
               <a:t>Fourth level</a:t>
             </a:r>
           </a:p>
           <a:p>
             <a:pPr lvl="4" eaLnBrk="1" latinLnBrk="0" hangingPunct="1"/>
             <a:r>
-              <a:rPr lang="en-US" smtClean="0"/>
+              <a:rPr lang="en-US"/>
               <a:t>Fifth level</a:t>
             </a:r>
             <a:endParaRPr kumimoji="0" lang="en-US"/>
@@ -2337,7 +2506,7 @@
           <a:p>
             <a:pPr lvl="0" eaLnBrk="1" latinLnBrk="0" hangingPunct="1"/>
             <a:r>
-              <a:rPr kumimoji="0" lang="en-US" smtClean="0"/>
+              <a:rPr kumimoji="0" lang="en-US"/>
               <a:t>Click to edit Master text styles</a:t>
             </a:r>
           </a:p>
@@ -2453,7 +2622,7 @@
           <a:p>
             <a:fld id="{F7088B4A-5E74-4E7B-8C78-CA63012A9A2F}" type="datetimeFigureOut">
               <a:rPr lang="en-US" smtClean="0"/>
-              <a:t>6/25/2026</a:t>
+              <a:t>7/9/2026</a:t>
             </a:fld>
             <a:endParaRPr lang="en-IN"/>
           </a:p>
@@ -2661,10 +2830,9 @@
           </a:lstStyle>
           <a:p>
             <a:r>
-              <a:rPr kumimoji="0" lang="en-US" smtClean="0"/>
+              <a:rPr kumimoji="0" lang="en-US"/>
               <a:t>Click to edit Master title style</a:t>
             </a:r>
-            <a:endParaRPr kumimoji="0" lang="en-US"/>
           </a:p>
         </p:txBody>
       </p:sp>
@@ -2722,10 +2890,9 @@
           <a:lstStyle/>
           <a:p>
             <a:r>
-              <a:rPr kumimoji="0" lang="en-US" smtClean="0"/>
+              <a:rPr kumimoji="0" lang="en-US"/>
               <a:t>Click to edit Master title style</a:t>
             </a:r>
-            <a:endParaRPr kumimoji="0" lang="en-US"/>
           </a:p>
         </p:txBody>
       </p:sp>
@@ -2751,7 +2918,7 @@
           <a:p>
             <a:fld id="{F7088B4A-5E74-4E7B-8C78-CA63012A9A2F}" type="datetimeFigureOut">
               <a:rPr lang="en-US" smtClean="0"/>
-              <a:t>6/25/2026</a:t>
+              <a:t>7/9/2026</a:t>
             </a:fld>
             <a:endParaRPr lang="en-IN"/>
           </a:p>
@@ -2861,35 +3028,35 @@
           <a:p>
             <a:pPr lvl="0" eaLnBrk="1" latinLnBrk="0" hangingPunct="1"/>
             <a:r>
-              <a:rPr lang="en-US" smtClean="0"/>
+              <a:rPr lang="en-US"/>
               <a:t>Click to edit Master text styles</a:t>
             </a:r>
           </a:p>
           <a:p>
             <a:pPr lvl="1" eaLnBrk="1" latinLnBrk="0" hangingPunct="1"/>
             <a:r>
-              <a:rPr lang="en-US" smtClean="0"/>
+              <a:rPr lang="en-US"/>
               <a:t>Second level</a:t>
             </a:r>
           </a:p>
           <a:p>
             <a:pPr lvl="2" eaLnBrk="1" latinLnBrk="0" hangingPunct="1"/>
             <a:r>
-              <a:rPr lang="en-US" smtClean="0"/>
+              <a:rPr lang="en-US"/>
               <a:t>Third level</a:t>
             </a:r>
           </a:p>
           <a:p>
             <a:pPr lvl="3" eaLnBrk="1" latinLnBrk="0" hangingPunct="1"/>
             <a:r>
-              <a:rPr lang="en-US" smtClean="0"/>
+              <a:rPr lang="en-US"/>
               <a:t>Fourth level</a:t>
             </a:r>
           </a:p>
           <a:p>
             <a:pPr lvl="4" eaLnBrk="1" latinLnBrk="0" hangingPunct="1"/>
             <a:r>
-              <a:rPr lang="en-US" smtClean="0"/>
+              <a:rPr lang="en-US"/>
               <a:t>Fifth level</a:t>
             </a:r>
             <a:endParaRPr kumimoji="0" lang="en-US"/>
@@ -2922,35 +3089,35 @@
           <a:p>
             <a:pPr lvl="0" eaLnBrk="1" latinLnBrk="0" hangingPunct="1"/>
             <a:r>
-              <a:rPr lang="en-US" smtClean="0"/>
+              <a:rPr lang="en-US"/>
               <a:t>Click to edit Master text styles</a:t>
             </a:r>
           </a:p>
           <a:p>
             <a:pPr lvl="1" eaLnBrk="1" latinLnBrk="0" hangingPunct="1"/>
             <a:r>
-              <a:rPr lang="en-US" smtClean="0"/>
+              <a:rPr lang="en-US"/>
               <a:t>Second level</a:t>
             </a:r>
           </a:p>
           <a:p>
             <a:pPr lvl="2" eaLnBrk="1" latinLnBrk="0" hangingPunct="1"/>
             <a:r>
-              <a:rPr lang="en-US" smtClean="0"/>
+              <a:rPr lang="en-US"/>
               <a:t>Third level</a:t>
             </a:r>
           </a:p>
           <a:p>
             <a:pPr lvl="3" eaLnBrk="1" latinLnBrk="0" hangingPunct="1"/>
             <a:r>
-              <a:rPr lang="en-US" smtClean="0"/>
+              <a:rPr lang="en-US"/>
               <a:t>Fourth level</a:t>
             </a:r>
           </a:p>
           <a:p>
             <a:pPr lvl="4" eaLnBrk="1" latinLnBrk="0" hangingPunct="1"/>
             <a:r>
-              <a:rPr lang="en-US" smtClean="0"/>
+              <a:rPr lang="en-US"/>
               <a:t>Fifth level</a:t>
             </a:r>
             <a:endParaRPr kumimoji="0" lang="en-US"/>
@@ -3320,7 +3487,7 @@
           <a:p>
             <a:pPr lvl="0" eaLnBrk="1" latinLnBrk="0" hangingPunct="1"/>
             <a:r>
-              <a:rPr kumimoji="0" lang="en-US" smtClean="0"/>
+              <a:rPr kumimoji="0" lang="en-US"/>
               <a:t>Click to edit Master text styles</a:t>
             </a:r>
           </a:p>
@@ -3390,7 +3557,7 @@
           <a:p>
             <a:pPr lvl="0" eaLnBrk="1" latinLnBrk="0" hangingPunct="1"/>
             <a:r>
-              <a:rPr kumimoji="0" lang="en-US" smtClean="0"/>
+              <a:rPr kumimoji="0" lang="en-US"/>
               <a:t>Click to edit Master text styles</a:t>
             </a:r>
           </a:p>
@@ -3413,7 +3580,7 @@
           <a:p>
             <a:fld id="{F7088B4A-5E74-4E7B-8C78-CA63012A9A2F}" type="datetimeFigureOut">
               <a:rPr lang="en-US" smtClean="0"/>
-              <a:t>6/25/2026</a:t>
+              <a:t>7/9/2026</a:t>
             </a:fld>
             <a:endParaRPr lang="en-IN"/>
           </a:p>
@@ -3541,35 +3708,35 @@
           <a:p>
             <a:pPr lvl="0" eaLnBrk="1" latinLnBrk="0" hangingPunct="1"/>
             <a:r>
-              <a:rPr lang="en-US" smtClean="0"/>
+              <a:rPr lang="en-US"/>
               <a:t>Click to edit Master text styles</a:t>
             </a:r>
           </a:p>
           <a:p>
             <a:pPr lvl="1" eaLnBrk="1" latinLnBrk="0" hangingPunct="1"/>
             <a:r>
-              <a:rPr lang="en-US" smtClean="0"/>
+              <a:rPr lang="en-US"/>
               <a:t>Second level</a:t>
             </a:r>
           </a:p>
           <a:p>
             <a:pPr lvl="2" eaLnBrk="1" latinLnBrk="0" hangingPunct="1"/>
             <a:r>
-              <a:rPr lang="en-US" smtClean="0"/>
+              <a:rPr lang="en-US"/>
               <a:t>Third level</a:t>
             </a:r>
           </a:p>
           <a:p>
             <a:pPr lvl="3" eaLnBrk="1" latinLnBrk="0" hangingPunct="1"/>
             <a:r>
-              <a:rPr lang="en-US" smtClean="0"/>
+              <a:rPr lang="en-US"/>
               <a:t>Fourth level</a:t>
             </a:r>
           </a:p>
           <a:p>
             <a:pPr lvl="4" eaLnBrk="1" latinLnBrk="0" hangingPunct="1"/>
             <a:r>
-              <a:rPr lang="en-US" smtClean="0"/>
+              <a:rPr lang="en-US"/>
               <a:t>Fifth level</a:t>
             </a:r>
             <a:endParaRPr kumimoji="0" lang="en-US"/>
@@ -3598,35 +3765,35 @@
           <a:p>
             <a:pPr lvl="0" eaLnBrk="1" latinLnBrk="0" hangingPunct="1"/>
             <a:r>
-              <a:rPr lang="en-US" smtClean="0"/>
+              <a:rPr lang="en-US"/>
               <a:t>Click to edit Master text styles</a:t>
             </a:r>
           </a:p>
           <a:p>
             <a:pPr lvl="1" eaLnBrk="1" latinLnBrk="0" hangingPunct="1"/>
             <a:r>
-              <a:rPr lang="en-US" smtClean="0"/>
+              <a:rPr lang="en-US"/>
               <a:t>Second level</a:t>
             </a:r>
           </a:p>
           <a:p>
             <a:pPr lvl="2" eaLnBrk="1" latinLnBrk="0" hangingPunct="1"/>
             <a:r>
-              <a:rPr lang="en-US" smtClean="0"/>
+              <a:rPr lang="en-US"/>
               <a:t>Third level</a:t>
             </a:r>
           </a:p>
           <a:p>
             <a:pPr lvl="3" eaLnBrk="1" latinLnBrk="0" hangingPunct="1"/>
             <a:r>
-              <a:rPr lang="en-US" smtClean="0"/>
+              <a:rPr lang="en-US"/>
               <a:t>Fourth level</a:t>
             </a:r>
           </a:p>
           <a:p>
             <a:pPr lvl="4" eaLnBrk="1" latinLnBrk="0" hangingPunct="1"/>
             <a:r>
-              <a:rPr lang="en-US" smtClean="0"/>
+              <a:rPr lang="en-US"/>
               <a:t>Fifth level</a:t>
             </a:r>
             <a:endParaRPr kumimoji="0" lang="en-US"/>
@@ -3777,10 +3944,9 @@
           <a:lstStyle/>
           <a:p>
             <a:r>
-              <a:rPr kumimoji="0" lang="en-US" smtClean="0"/>
+              <a:rPr kumimoji="0" lang="en-US"/>
               <a:t>Click to edit Master title style</a:t>
             </a:r>
-            <a:endParaRPr kumimoji="0" lang="en-US"/>
           </a:p>
         </p:txBody>
       </p:sp>
@@ -3828,10 +3994,9 @@
           <a:lstStyle/>
           <a:p>
             <a:r>
-              <a:rPr kumimoji="0" lang="en-US" smtClean="0"/>
+              <a:rPr kumimoji="0" lang="en-US"/>
               <a:t>Click to edit Master title style</a:t>
             </a:r>
-            <a:endParaRPr kumimoji="0" lang="en-US"/>
           </a:p>
         </p:txBody>
       </p:sp>
@@ -3852,7 +4017,7 @@
           <a:p>
             <a:fld id="{F7088B4A-5E74-4E7B-8C78-CA63012A9A2F}" type="datetimeFigureOut">
               <a:rPr lang="en-US" smtClean="0"/>
-              <a:t>6/25/2026</a:t>
+              <a:t>7/9/2026</a:t>
             </a:fld>
             <a:endParaRPr lang="en-IN"/>
           </a:p>
@@ -4168,7 +4333,7 @@
           <a:p>
             <a:fld id="{F7088B4A-5E74-4E7B-8C78-CA63012A9A2F}" type="datetimeFigureOut">
               <a:rPr lang="en-US" smtClean="0"/>
-              <a:t>6/25/2026</a:t>
+              <a:t>7/9/2026</a:t>
             </a:fld>
             <a:endParaRPr lang="en-IN"/>
           </a:p>
@@ -4520,10 +4685,9 @@
           </a:lstStyle>
           <a:p>
             <a:r>
-              <a:rPr kumimoji="0" lang="en-US" smtClean="0"/>
+              <a:rPr kumimoji="0" lang="en-US"/>
               <a:t>Click to edit Master title style</a:t>
             </a:r>
-            <a:endParaRPr kumimoji="0" lang="en-US"/>
           </a:p>
         </p:txBody>
       </p:sp>
@@ -4577,7 +4741,7 @@
           <a:p>
             <a:pPr lvl="0" eaLnBrk="1" latinLnBrk="0" hangingPunct="1"/>
             <a:r>
-              <a:rPr kumimoji="0" lang="en-US" smtClean="0"/>
+              <a:rPr kumimoji="0" lang="en-US"/>
               <a:t>Click to edit Master text styles</a:t>
             </a:r>
           </a:p>
@@ -4681,35 +4845,35 @@
           <a:p>
             <a:pPr lvl="0" eaLnBrk="1" latinLnBrk="0" hangingPunct="1"/>
             <a:r>
-              <a:rPr lang="en-US" smtClean="0"/>
+              <a:rPr lang="en-US"/>
               <a:t>Click to edit Master text styles</a:t>
             </a:r>
           </a:p>
           <a:p>
             <a:pPr lvl="1" eaLnBrk="1" latinLnBrk="0" hangingPunct="1"/>
             <a:r>
-              <a:rPr lang="en-US" smtClean="0"/>
+              <a:rPr lang="en-US"/>
               <a:t>Second level</a:t>
             </a:r>
           </a:p>
           <a:p>
             <a:pPr lvl="2" eaLnBrk="1" latinLnBrk="0" hangingPunct="1"/>
             <a:r>
-              <a:rPr lang="en-US" smtClean="0"/>
+              <a:rPr lang="en-US"/>
               <a:t>Third level</a:t>
             </a:r>
           </a:p>
           <a:p>
             <a:pPr lvl="3" eaLnBrk="1" latinLnBrk="0" hangingPunct="1"/>
             <a:r>
-              <a:rPr lang="en-US" smtClean="0"/>
+              <a:rPr lang="en-US"/>
               <a:t>Fourth level</a:t>
             </a:r>
           </a:p>
           <a:p>
             <a:pPr lvl="4" eaLnBrk="1" latinLnBrk="0" hangingPunct="1"/>
             <a:r>
-              <a:rPr lang="en-US" smtClean="0"/>
+              <a:rPr lang="en-US"/>
               <a:t>Fifth level</a:t>
             </a:r>
             <a:endParaRPr kumimoji="0" lang="en-US"/>
@@ -4903,7 +5067,7 @@
           <a:p>
             <a:fld id="{F7088B4A-5E74-4E7B-8C78-CA63012A9A2F}" type="datetimeFigureOut">
               <a:rPr lang="en-US" smtClean="0"/>
-              <a:t>6/25/2026</a:t>
+              <a:t>7/9/2026</a:t>
             </a:fld>
             <a:endParaRPr lang="en-IN"/>
           </a:p>
@@ -5419,10 +5583,9 @@
           </a:lstStyle>
           <a:p>
             <a:r>
-              <a:rPr kumimoji="0" lang="en-US" smtClean="0"/>
+              <a:rPr kumimoji="0" lang="en-US"/>
               <a:t>Click to edit Master title style</a:t>
             </a:r>
-            <a:endParaRPr kumimoji="0" lang="en-US"/>
           </a:p>
         </p:txBody>
       </p:sp>
@@ -5452,7 +5615,7 @@
           </a:lstStyle>
           <a:p>
             <a:r>
-              <a:rPr kumimoji="0" lang="en-US" smtClean="0"/>
+              <a:rPr kumimoji="0" lang="en-US"/>
               <a:t>Click icon to add picture</a:t>
             </a:r>
             <a:endParaRPr kumimoji="0" lang="en-US" dirty="0"/>
@@ -5506,7 +5669,7 @@
           <a:p>
             <a:pPr lvl="0" eaLnBrk="1" latinLnBrk="0" hangingPunct="1"/>
             <a:r>
-              <a:rPr kumimoji="0" lang="en-US" smtClean="0"/>
+              <a:rPr kumimoji="0" lang="en-US"/>
               <a:t>Click to edit Master text styles</a:t>
             </a:r>
           </a:p>
@@ -5570,7 +5733,7 @@
           <a:p>
             <a:fld id="{F7088B4A-5E74-4E7B-8C78-CA63012A9A2F}" type="datetimeFigureOut">
               <a:rPr lang="en-US" smtClean="0"/>
-              <a:t>6/25/2026</a:t>
+              <a:t>7/9/2026</a:t>
             </a:fld>
             <a:endParaRPr lang="en-IN"/>
           </a:p>
@@ -5846,7 +6009,7 @@
           <a:p>
             <a:fld id="{F7088B4A-5E74-4E7B-8C78-CA63012A9A2F}" type="datetimeFigureOut">
               <a:rPr lang="en-US" smtClean="0"/>
-              <a:t>6/25/2026</a:t>
+              <a:t>7/9/2026</a:t>
             </a:fld>
             <a:endParaRPr lang="en-IN"/>
           </a:p>
@@ -6128,10 +6291,9 @@
           <a:lstStyle/>
           <a:p>
             <a:r>
-              <a:rPr kumimoji="0" lang="en-US" smtClean="0"/>
+              <a:rPr kumimoji="0" lang="en-US"/>
               <a:t>Click to edit Master title style</a:t>
             </a:r>
-            <a:endParaRPr kumimoji="0" lang="en-US"/>
           </a:p>
         </p:txBody>
       </p:sp>
@@ -6162,38 +6324,37 @@
           <a:p>
             <a:pPr lvl="0" eaLnBrk="1" latinLnBrk="0" hangingPunct="1"/>
             <a:r>
-              <a:rPr kumimoji="0" lang="en-US" smtClean="0"/>
+              <a:rPr kumimoji="0" lang="en-US"/>
               <a:t>Click to edit Master text styles</a:t>
             </a:r>
           </a:p>
           <a:p>
             <a:pPr lvl="1" eaLnBrk="1" latinLnBrk="0" hangingPunct="1"/>
             <a:r>
-              <a:rPr kumimoji="0" lang="en-US" smtClean="0"/>
+              <a:rPr kumimoji="0" lang="en-US"/>
               <a:t>Second level</a:t>
             </a:r>
           </a:p>
           <a:p>
             <a:pPr lvl="2" eaLnBrk="1" latinLnBrk="0" hangingPunct="1"/>
             <a:r>
-              <a:rPr kumimoji="0" lang="en-US" smtClean="0"/>
+              <a:rPr kumimoji="0" lang="en-US"/>
               <a:t>Third level</a:t>
             </a:r>
           </a:p>
           <a:p>
             <a:pPr lvl="3" eaLnBrk="1" latinLnBrk="0" hangingPunct="1"/>
             <a:r>
-              <a:rPr kumimoji="0" lang="en-US" smtClean="0"/>
+              <a:rPr kumimoji="0" lang="en-US"/>
               <a:t>Fourth level</a:t>
             </a:r>
           </a:p>
           <a:p>
             <a:pPr lvl="4" eaLnBrk="1" latinLnBrk="0" hangingPunct="1"/>
             <a:r>
-              <a:rPr kumimoji="0" lang="en-US" smtClean="0"/>
+              <a:rPr kumimoji="0" lang="en-US"/>
               <a:t>Fifth level</a:t>
             </a:r>
-            <a:endParaRPr kumimoji="0" lang="en-US"/>
           </a:p>
         </p:txBody>
       </p:sp>
@@ -6594,8 +6755,8 @@
         </p:nvSpPr>
         <p:spPr>
           <a:xfrm>
-            <a:off x="0" y="5072074"/>
-            <a:ext cx="3071833" cy="477054"/>
+            <a:off x="142844" y="4097676"/>
+            <a:ext cx="8964488" cy="1200329"/>
           </a:xfrm>
           <a:prstGeom prst="rect">
             <a:avLst/>
@@ -6620,6 +6781,7 @@
               </a:defRPr>
             </a:pPr>
             <a:r>
+              <a:rPr dirty="0"/>
               <a:t>Q-GUARD AI</a:t>
             </a:r>
           </a:p>
@@ -6633,6 +6795,7 @@
               </a:defRPr>
             </a:pPr>
             <a:r>
+              <a:rPr dirty="0"/>
               <a:t>Multi-Agent Quantum Fraud Intelligence</a:t>
             </a:r>
           </a:p>
@@ -6702,8 +6865,8 @@
         </p:nvSpPr>
         <p:spPr>
           <a:xfrm>
-            <a:off x="142876" y="5572140"/>
-            <a:ext cx="4500562" cy="477054"/>
+            <a:off x="158918" y="5286393"/>
+            <a:ext cx="6429306" cy="1384995"/>
           </a:xfrm>
           <a:prstGeom prst="rect">
             <a:avLst/>
@@ -6728,8 +6891,21 @@
               </a:defRPr>
             </a:pPr>
             <a:r>
-              <a:t>Team Schrödinger’s Coders</a:t>
-            </a:r>
+              <a:rPr dirty="0"/>
+              <a:t>Team</a:t>
+            </a:r>
+            <a:r>
+              <a:rPr lang="en-IN" dirty="0"/>
+              <a:t> Name :</a:t>
+            </a:r>
+            <a:r>
+              <a:rPr dirty="0"/>
+              <a:t> Schrödinger’s Coders</a:t>
+            </a:r>
+            <a:br>
+              <a:rPr lang="en-IN" dirty="0"/>
+            </a:br>
+            <a:endParaRPr dirty="0"/>
           </a:p>
           <a:p>
             <a:pPr>
@@ -6741,47 +6917,54 @@
               </a:defRPr>
             </a:pPr>
             <a:r>
-              <a:t>Members: Dhinith Pragalyan, Dhanveer M, Venkatesan S, Elamaran B</a:t>
-            </a:r>
-          </a:p>
-        </p:txBody>
-      </p:sp>
-      <p:sp>
-        <p:nvSpPr>
-          <p:cNvPr id="18" name="Rectangle 17"/>
-          <p:cNvSpPr/>
-          <p:nvPr/>
-        </p:nvSpPr>
-        <p:spPr>
-          <a:xfrm>
-            <a:off x="142844" y="6000768"/>
-            <a:ext cx="4929222" cy="477054"/>
-          </a:xfrm>
-          <a:prstGeom prst="rect">
-            <a:avLst/>
-          </a:prstGeom>
-          <a:noFill/>
-          <a:ln>
-            <a:noFill/>
-          </a:ln>
-        </p:spPr>
-        <p:txBody>
-          <a:bodyPr wrap="square" lIns="91440" tIns="45720" rIns="91440" bIns="45720">
-            <a:spAutoFit/>
-          </a:bodyPr>
-          <a:lstStyle/>
-          <a:p>
-            <a:pPr>
-              <a:defRPr sz="1400">
+              <a:rPr dirty="0"/>
+              <a:t>Members: </a:t>
+            </a:r>
+            <a:r>
+              <a:rPr dirty="0" err="1"/>
+              <a:t>Dhinith</a:t>
+            </a:r>
+            <a:r>
+              <a:rPr dirty="0"/>
+              <a:t> </a:t>
+            </a:r>
+            <a:r>
+              <a:rPr dirty="0" err="1"/>
+              <a:t>Pragalyan</a:t>
+            </a:r>
+            <a:r>
+              <a:rPr lang="en-IN" dirty="0"/>
+              <a:t> M</a:t>
+            </a:r>
+            <a:r>
+              <a:rPr dirty="0"/>
+              <a:t>, Dhanveer M, Venkatesan S, Elamaran B</a:t>
+            </a:r>
+            <a:br>
+              <a:rPr lang="en-IN" dirty="0"/>
+            </a:br>
+            <a:br>
+              <a:rPr lang="en-IN" dirty="0"/>
+            </a:br>
+            <a:r>
+              <a:rPr lang="en-IN" dirty="0">
                 <a:solidFill>
-                  <a:srgbClr val="C8C8C8"/>
+                  <a:srgbClr val="00C07C"/>
                 </a:solidFill>
-                <a:latin typeface="Share Tech Mono"/>
+              </a:rPr>
+              <a:t>Panimalar engineering college , Chennai.</a:t>
+            </a:r>
+          </a:p>
+          <a:p>
+            <a:pPr>
+              <a:defRPr sz="1400" b="1">
+                <a:solidFill>
+                  <a:srgbClr val="00FF9D"/>
+                </a:solidFill>
+                <a:latin typeface="Exo 2"/>
               </a:defRPr>
             </a:pPr>
-            <a:r>
-              <a:t>RIT Chennai — Quantathan 2026</a:t>
-            </a:r>
+            <a:endParaRPr dirty="0"/>
           </a:p>
         </p:txBody>
       </p:sp>
@@ -6823,33 +7006,792 @@
   <p:transition>
     <p:fade/>
   </p:transition>
-  <p:timing>
-    <p:tnLst>
-      <p:par>
-        <p:cTn id="1" dur="indefinite" restart="never" nodeType="tmRoot"/>
-      </p:par>
-    </p:tnLst>
-  </p:timing>
 </p:sld>
 </file>
 
-<file path=ppt/slides/slide2.xml><?xml version="1.0" encoding="utf-8"?>
+<file path=ppt/slides/slide10.xml><?xml version="1.0" encoding="utf-8"?>
+<p:sld xmlns:a="http://schemas.openxmlformats.org/drawingml/2006/main" xmlns:p="http://schemas.openxmlformats.org/presentationml/2006/main" xmlns:r="http://schemas.openxmlformats.org/officeDocument/2006/relationships">
+  <p:cSld>
+    <p:spTree>
+      <p:nvGrpSpPr>
+        <p:cNvPr id="1" name=""/>
+        <p:cNvGrpSpPr/>
+        <p:nvPr/>
+      </p:nvGrpSpPr>
+      <p:grpSpPr/>
+      <p:sp>
+        <p:nvSpPr>
+          <p:cNvPr id="2" name="Title 1"/>
+          <p:cNvSpPr>
+            <a:spLocks noGrp="1"/>
+          </p:cNvSpPr>
+          <p:nvPr>
+            <p:ph type="title"/>
+          </p:nvPr>
+        </p:nvSpPr>
+        <p:spPr/>
+        <p:txBody>
+          <a:bodyPr/>
+          <a:lstStyle/>
+          <a:p>
+            <a:r>
+              <a:t>9. SELF-EXPLAINABLE AI (XAI) &amp; AUDITING</a:t>
+            </a:r>
+          </a:p>
+        </p:txBody>
+      </p:sp>
+      <p:sp>
+        <p:nvSpPr>
+          <p:cNvPr id="3" name="Content Placeholder 2"/>
+          <p:cNvSpPr>
+            <a:spLocks noGrp="1"/>
+          </p:cNvSpPr>
+          <p:nvPr>
+            <p:ph idx="1" sz="quarter"/>
+          </p:nvPr>
+        </p:nvSpPr>
+        <p:spPr/>
+        <p:txBody>
+          <a:bodyPr wrap="square"/>
+          <a:lstStyle/>
+          <a:p>
+            <a:pPr>
+              <a:spcAft>
+                <a:spcPts val="1400"/>
+              </a:spcAft>
+            </a:pPr>
+            <a:r>
+              <a:t>Translation Pipeline: Converts VQC coordinates into natural language audit logs.</a:t>
+            </a:r>
+          </a:p>
+          <a:p>
+            <a:pPr>
+              <a:spcAft>
+                <a:spcPts val="1400"/>
+              </a:spcAft>
+            </a:pPr>
+            <a:r>
+              <a:t>Regulatory Compliance: Outlines exactly why a transaction was flagged or blocked.</a:t>
+            </a:r>
+          </a:p>
+          <a:p>
+            <a:pPr>
+              <a:spcAft>
+                <a:spcPts val="1400"/>
+              </a:spcAft>
+            </a:pPr>
+            <a:r>
+              <a:t>Anti-Black Box: Ensures fraud analysts can explain any system decision to RBI auditors.</a:t>
+            </a:r>
+          </a:p>
+          <a:p>
+            <a:pPr>
+              <a:spcAft>
+                <a:spcPts val="1400"/>
+              </a:spcAft>
+            </a:pPr>
+            <a:r>
+              <a:t>Visual Threat Mapping: Provides a dynamic 3D visual of the Bloch sphere state space.</a:t>
+            </a:r>
+          </a:p>
+        </p:txBody>
+      </p:sp>
+    </p:spTree>
+  </p:cSld>
+  <p:clrMapOvr>
+    <a:masterClrMapping/>
+  </p:clrMapOvr>
+</p:sld>
+</file>
+
+<file path=ppt/slides/slide10.xml><?xml version="1.0" encoding="utf-8"?>
+<p:sld xmlns:a="http://schemas.openxmlformats.org/drawingml/2006/main" xmlns:p="http://schemas.openxmlformats.org/presentationml/2006/main" xmlns:r="http://schemas.openxmlformats.org/officeDocument/2006/relationships">
+  <p:cSld>
+    <p:spTree>
+      <p:nvGrpSpPr>
+        <p:cNvPr id="1" name=""/>
+        <p:cNvGrpSpPr/>
+        <p:nvPr/>
+      </p:nvGrpSpPr>
+      <p:grpSpPr/>
+      <p:sp>
+        <p:nvSpPr>
+          <p:cNvPr id="2" name="Title 1"/>
+          <p:cNvSpPr>
+            <a:spLocks noGrp="1"/>
+          </p:cNvSpPr>
+          <p:nvPr>
+            <p:ph type="title"/>
+          </p:nvPr>
+        </p:nvSpPr>
+        <p:spPr/>
+        <p:txBody>
+          <a:bodyPr/>
+          <a:lstStyle/>
+          <a:p>
+            <a:r>
+              <a:t>9. SELF-EXPLAINABLE AI (XAI) &amp; AUDITING</a:t>
+            </a:r>
+          </a:p>
+        </p:txBody>
+      </p:sp>
+      <p:sp>
+        <p:nvSpPr>
+          <p:cNvPr id="3" name="Content Placeholder 2"/>
+          <p:cNvSpPr>
+            <a:spLocks noGrp="1"/>
+          </p:cNvSpPr>
+          <p:nvPr>
+            <p:ph idx="1" sz="quarter"/>
+          </p:nvPr>
+        </p:nvSpPr>
+        <p:spPr/>
+        <p:txBody>
+          <a:bodyPr wrap="square"/>
+          <a:lstStyle/>
+          <a:p>
+            <a:pPr>
+              <a:spcAft>
+                <a:spcPts val="1400"/>
+              </a:spcAft>
+            </a:pPr>
+            <a:r>
+              <a:t>Translation Pipeline: Converts VQC coordinates into natural language audit logs.</a:t>
+            </a:r>
+          </a:p>
+          <a:p>
+            <a:pPr>
+              <a:spcAft>
+                <a:spcPts val="1400"/>
+              </a:spcAft>
+            </a:pPr>
+            <a:r>
+              <a:t>Regulatory Compliance: Outlines exactly why a transaction was flagged or blocked.</a:t>
+            </a:r>
+          </a:p>
+          <a:p>
+            <a:pPr>
+              <a:spcAft>
+                <a:spcPts val="1400"/>
+              </a:spcAft>
+            </a:pPr>
+            <a:r>
+              <a:t>Anti-Black Box: Ensures fraud analysts can explain any system decision to RBI auditors.</a:t>
+            </a:r>
+          </a:p>
+          <a:p>
+            <a:pPr>
+              <a:spcAft>
+                <a:spcPts val="1400"/>
+              </a:spcAft>
+            </a:pPr>
+            <a:r>
+              <a:t>Visual Threat Mapping: Provides a dynamic 3D visual of the Bloch sphere state space.</a:t>
+            </a:r>
+          </a:p>
+        </p:txBody>
+      </p:sp>
+    </p:spTree>
+  </p:cSld>
+  <p:clrMapOvr>
+    <a:masterClrMapping/>
+  </p:clrMapOvr>
+</p:sld>
+</file>
+
+<file path=ppt/slides/slide11.xml><?xml version="1.0" encoding="utf-8"?>
+<p:sld xmlns:a="http://schemas.openxmlformats.org/drawingml/2006/main" xmlns:p="http://schemas.openxmlformats.org/presentationml/2006/main" xmlns:r="http://schemas.openxmlformats.org/officeDocument/2006/relationships">
+  <p:cSld>
+    <p:spTree>
+      <p:nvGrpSpPr>
+        <p:cNvPr id="1" name=""/>
+        <p:cNvGrpSpPr/>
+        <p:nvPr/>
+      </p:nvGrpSpPr>
+      <p:grpSpPr/>
+      <p:sp>
+        <p:nvSpPr>
+          <p:cNvPr id="2" name="Title 1"/>
+          <p:cNvSpPr>
+            <a:spLocks noGrp="1"/>
+          </p:cNvSpPr>
+          <p:nvPr>
+            <p:ph type="title"/>
+          </p:nvPr>
+        </p:nvSpPr>
+        <p:spPr/>
+        <p:txBody>
+          <a:bodyPr/>
+          <a:lstStyle/>
+          <a:p>
+            <a:r>
+              <a:t>10. STRATEGIC MITIGATION CHECKLISTS</a:t>
+            </a:r>
+          </a:p>
+        </p:txBody>
+      </p:sp>
+      <p:sp>
+        <p:nvSpPr>
+          <p:cNvPr id="3" name="Content Placeholder 2"/>
+          <p:cNvSpPr>
+            <a:spLocks noGrp="1"/>
+          </p:cNvSpPr>
+          <p:nvPr>
+            <p:ph idx="1" sz="quarter"/>
+          </p:nvPr>
+        </p:nvSpPr>
+        <p:spPr/>
+        <p:txBody>
+          <a:bodyPr wrap="square"/>
+          <a:lstStyle/>
+          <a:p>
+            <a:pPr>
+              <a:spcAft>
+                <a:spcPts val="1400"/>
+              </a:spcAft>
+            </a:pPr>
+            <a:r>
+              <a:t>Multi-Stage Security: Replaces crude binary block decisions with progressive checklists.</a:t>
+            </a:r>
+          </a:p>
+          <a:p>
+            <a:pPr>
+              <a:spcAft>
+                <a:spcPts val="1400"/>
+              </a:spcAft>
+            </a:pPr>
+            <a:r>
+              <a:t>Low Risk: Process transaction instantly (frictionless flow).</a:t>
+            </a:r>
+          </a:p>
+          <a:p>
+            <a:pPr>
+              <a:spcAft>
+                <a:spcPts val="1400"/>
+              </a:spcAft>
+            </a:pPr>
+            <a:r>
+              <a:t>Medium Risk: Prompt for SMS OTP and email code verification.</a:t>
+            </a:r>
+          </a:p>
+          <a:p>
+            <a:pPr>
+              <a:spcAft>
+                <a:spcPts val="1400"/>
+              </a:spcAft>
+            </a:pPr>
+            <a:r>
+              <a:t>High Risk: Require biometric Face Authentication check.</a:t>
+            </a:r>
+          </a:p>
+          <a:p>
+            <a:pPr>
+              <a:spcAft>
+                <a:spcPts val="1400"/>
+              </a:spcAft>
+            </a:pPr>
+            <a:r>
+              <a:t>Critical Risk: Freeze transaction and alert the bank's fraud mitigation desk.</a:t>
+            </a:r>
+          </a:p>
+        </p:txBody>
+      </p:sp>
+    </p:spTree>
+  </p:cSld>
+  <p:clrMapOvr>
+    <a:masterClrMapping/>
+  </p:clrMapOvr>
+</p:sld>
+</file>
+
+<file path=ppt/slides/slide11.xml><?xml version="1.0" encoding="utf-8"?>
+<p:sld xmlns:a="http://schemas.openxmlformats.org/drawingml/2006/main" xmlns:p="http://schemas.openxmlformats.org/presentationml/2006/main" xmlns:r="http://schemas.openxmlformats.org/officeDocument/2006/relationships">
+  <p:cSld>
+    <p:spTree>
+      <p:nvGrpSpPr>
+        <p:cNvPr id="1" name=""/>
+        <p:cNvGrpSpPr/>
+        <p:nvPr/>
+      </p:nvGrpSpPr>
+      <p:grpSpPr/>
+      <p:sp>
+        <p:nvSpPr>
+          <p:cNvPr id="2" name="Title 1"/>
+          <p:cNvSpPr>
+            <a:spLocks noGrp="1"/>
+          </p:cNvSpPr>
+          <p:nvPr>
+            <p:ph type="title"/>
+          </p:nvPr>
+        </p:nvSpPr>
+        <p:spPr/>
+        <p:txBody>
+          <a:bodyPr/>
+          <a:lstStyle/>
+          <a:p>
+            <a:r>
+              <a:t>10. STRATEGIC MITIGATION CHECKLISTS</a:t>
+            </a:r>
+          </a:p>
+        </p:txBody>
+      </p:sp>
+      <p:sp>
+        <p:nvSpPr>
+          <p:cNvPr id="3" name="Content Placeholder 2"/>
+          <p:cNvSpPr>
+            <a:spLocks noGrp="1"/>
+          </p:cNvSpPr>
+          <p:nvPr>
+            <p:ph idx="1" sz="quarter"/>
+          </p:nvPr>
+        </p:nvSpPr>
+        <p:spPr/>
+        <p:txBody>
+          <a:bodyPr wrap="square"/>
+          <a:lstStyle/>
+          <a:p>
+            <a:pPr>
+              <a:spcAft>
+                <a:spcPts val="1400"/>
+              </a:spcAft>
+            </a:pPr>
+            <a:r>
+              <a:t>Multi-Stage Security: Replaces crude binary block decisions with progressive checklists.</a:t>
+            </a:r>
+          </a:p>
+          <a:p>
+            <a:pPr>
+              <a:spcAft>
+                <a:spcPts val="1400"/>
+              </a:spcAft>
+            </a:pPr>
+            <a:r>
+              <a:t>Low Risk: Process transaction instantly (frictionless flow).</a:t>
+            </a:r>
+          </a:p>
+          <a:p>
+            <a:pPr>
+              <a:spcAft>
+                <a:spcPts val="1400"/>
+              </a:spcAft>
+            </a:pPr>
+            <a:r>
+              <a:t>Medium Risk: Prompt for SMS OTP and email code verification.</a:t>
+            </a:r>
+          </a:p>
+          <a:p>
+            <a:pPr>
+              <a:spcAft>
+                <a:spcPts val="1400"/>
+              </a:spcAft>
+            </a:pPr>
+            <a:r>
+              <a:t>High Risk: Require biometric Face Authentication check.</a:t>
+            </a:r>
+          </a:p>
+          <a:p>
+            <a:pPr>
+              <a:spcAft>
+                <a:spcPts val="1400"/>
+              </a:spcAft>
+            </a:pPr>
+            <a:r>
+              <a:t>Critical Risk: Freeze transaction and alert the bank's fraud mitigation desk.</a:t>
+            </a:r>
+          </a:p>
+        </p:txBody>
+      </p:sp>
+    </p:spTree>
+  </p:cSld>
+  <p:clrMapOvr>
+    <a:masterClrMapping/>
+  </p:clrMapOvr>
+</p:sld>
+</file>
+
+<file path=ppt/slides/slide12.xml><?xml version="1.0" encoding="utf-8"?>
+<p:sld xmlns:a="http://schemas.openxmlformats.org/drawingml/2006/main" xmlns:p="http://schemas.openxmlformats.org/presentationml/2006/main" xmlns:r="http://schemas.openxmlformats.org/officeDocument/2006/relationships">
+  <p:cSld>
+    <p:spTree>
+      <p:nvGrpSpPr>
+        <p:cNvPr id="1" name=""/>
+        <p:cNvGrpSpPr/>
+        <p:nvPr/>
+      </p:nvGrpSpPr>
+      <p:grpSpPr/>
+      <p:sp>
+        <p:nvSpPr>
+          <p:cNvPr id="2" name="Title 1"/>
+          <p:cNvSpPr>
+            <a:spLocks noGrp="1"/>
+          </p:cNvSpPr>
+          <p:nvPr>
+            <p:ph type="title"/>
+          </p:nvPr>
+        </p:nvSpPr>
+        <p:spPr/>
+        <p:txBody>
+          <a:bodyPr/>
+          <a:lstStyle/>
+          <a:p>
+            <a:r>
+              <a:t>11. SCALABILITY &amp; DATABASE INTEGRATION</a:t>
+            </a:r>
+          </a:p>
+        </p:txBody>
+      </p:sp>
+      <p:sp>
+        <p:nvSpPr>
+          <p:cNvPr id="3" name="Content Placeholder 2"/>
+          <p:cNvSpPr>
+            <a:spLocks noGrp="1"/>
+          </p:cNvSpPr>
+          <p:nvPr>
+            <p:ph idx="1" sz="quarter"/>
+          </p:nvPr>
+        </p:nvSpPr>
+        <p:spPr/>
+        <p:txBody>
+          <a:bodyPr wrap="square"/>
+          <a:lstStyle/>
+          <a:p>
+            <a:pPr>
+              <a:spcAft>
+                <a:spcPts val="1400"/>
+              </a:spcAft>
+            </a:pPr>
+            <a:r>
+              <a:t>Dataset Loading: Mapped to 3,000 real-world transaction logs from the Kaggle dataset.</a:t>
+            </a:r>
+          </a:p>
+          <a:p>
+            <a:pPr>
+              <a:spcAft>
+                <a:spcPts val="1400"/>
+              </a:spcAft>
+            </a:pPr>
+            <a:r>
+              <a:t>MongoDB Pipeline: Stores telemetry, dynamic weights, and strategies in indexed collections.</a:t>
+            </a:r>
+          </a:p>
+          <a:p>
+            <a:pPr>
+              <a:spcAft>
+                <a:spcPts val="1400"/>
+              </a:spcAft>
+            </a:pPr>
+            <a:r>
+              <a:t>FastAPI REST Endpoints: Exposes Bloch coordinates, agent weights, and explanation logs.</a:t>
+            </a:r>
+          </a:p>
+          <a:p>
+            <a:pPr>
+              <a:spcAft>
+                <a:spcPts val="1400"/>
+              </a:spcAft>
+            </a:pPr>
+            <a:r>
+              <a:t>Vercel Deployment: Live static visualizer deployed on secure cloud servers.</a:t>
+            </a:r>
+          </a:p>
+        </p:txBody>
+      </p:sp>
+    </p:spTree>
+  </p:cSld>
+  <p:clrMapOvr>
+    <a:masterClrMapping/>
+  </p:clrMapOvr>
+</p:sld>
+</file>
+
+<file path=ppt/slides/slide12.xml><?xml version="1.0" encoding="utf-8"?>
+<p:sld xmlns:a="http://schemas.openxmlformats.org/drawingml/2006/main" xmlns:p="http://schemas.openxmlformats.org/presentationml/2006/main" xmlns:r="http://schemas.openxmlformats.org/officeDocument/2006/relationships">
+  <p:cSld>
+    <p:spTree>
+      <p:nvGrpSpPr>
+        <p:cNvPr id="1" name=""/>
+        <p:cNvGrpSpPr/>
+        <p:nvPr/>
+      </p:nvGrpSpPr>
+      <p:grpSpPr/>
+      <p:sp>
+        <p:nvSpPr>
+          <p:cNvPr id="2" name="Title 1"/>
+          <p:cNvSpPr>
+            <a:spLocks noGrp="1"/>
+          </p:cNvSpPr>
+          <p:nvPr>
+            <p:ph type="title"/>
+          </p:nvPr>
+        </p:nvSpPr>
+        <p:spPr/>
+        <p:txBody>
+          <a:bodyPr/>
+          <a:lstStyle/>
+          <a:p>
+            <a:r>
+              <a:t>11. SCALABILITY &amp; DATABASE INTEGRATION</a:t>
+            </a:r>
+          </a:p>
+        </p:txBody>
+      </p:sp>
+      <p:sp>
+        <p:nvSpPr>
+          <p:cNvPr id="3" name="Content Placeholder 2"/>
+          <p:cNvSpPr>
+            <a:spLocks noGrp="1"/>
+          </p:cNvSpPr>
+          <p:nvPr>
+            <p:ph idx="1" sz="quarter"/>
+          </p:nvPr>
+        </p:nvSpPr>
+        <p:spPr/>
+        <p:txBody>
+          <a:bodyPr wrap="square"/>
+          <a:lstStyle/>
+          <a:p>
+            <a:pPr>
+              <a:spcAft>
+                <a:spcPts val="1400"/>
+              </a:spcAft>
+            </a:pPr>
+            <a:r>
+              <a:t>Dataset Loading: Mapped to 3,000 real-world transaction logs from the Kaggle dataset.</a:t>
+            </a:r>
+          </a:p>
+          <a:p>
+            <a:pPr>
+              <a:spcAft>
+                <a:spcPts val="1400"/>
+              </a:spcAft>
+            </a:pPr>
+            <a:r>
+              <a:t>MongoDB Pipeline: Stores telemetry, dynamic weights, and strategies in indexed collections.</a:t>
+            </a:r>
+          </a:p>
+          <a:p>
+            <a:pPr>
+              <a:spcAft>
+                <a:spcPts val="1400"/>
+              </a:spcAft>
+            </a:pPr>
+            <a:r>
+              <a:t>FastAPI REST Endpoints: Exposes Bloch coordinates, agent weights, and explanation logs.</a:t>
+            </a:r>
+          </a:p>
+          <a:p>
+            <a:pPr>
+              <a:spcAft>
+                <a:spcPts val="1400"/>
+              </a:spcAft>
+            </a:pPr>
+            <a:r>
+              <a:t>Vercel Deployment: Live static visualizer deployed on secure cloud servers.</a:t>
+            </a:r>
+          </a:p>
+        </p:txBody>
+      </p:sp>
+    </p:spTree>
+  </p:cSld>
+  <p:clrMapOvr>
+    <a:masterClrMapping/>
+  </p:clrMapOvr>
+</p:sld>
+</file>
+
+<file path=ppt/slides/slide13.xml><?xml version="1.0" encoding="utf-8"?>
+<p:sld xmlns:a="http://schemas.openxmlformats.org/drawingml/2006/main" xmlns:p="http://schemas.openxmlformats.org/presentationml/2006/main" xmlns:r="http://schemas.openxmlformats.org/officeDocument/2006/relationships">
+  <p:cSld>
+    <p:spTree>
+      <p:nvGrpSpPr>
+        <p:cNvPr id="1" name=""/>
+        <p:cNvGrpSpPr/>
+        <p:nvPr/>
+      </p:nvGrpSpPr>
+      <p:grpSpPr/>
+      <p:sp>
+        <p:nvSpPr>
+          <p:cNvPr id="2" name="Title 1"/>
+          <p:cNvSpPr>
+            <a:spLocks noGrp="1"/>
+          </p:cNvSpPr>
+          <p:nvPr>
+            <p:ph type="title"/>
+          </p:nvPr>
+        </p:nvSpPr>
+        <p:spPr/>
+        <p:txBody>
+          <a:bodyPr/>
+          <a:lstStyle/>
+          <a:p>
+            <a:r>
+              <a:t>12. FUTURE SCOPE &amp; CONCLUSION</a:t>
+            </a:r>
+          </a:p>
+        </p:txBody>
+      </p:sp>
+      <p:sp>
+        <p:nvSpPr>
+          <p:cNvPr id="3" name="Content Placeholder 2"/>
+          <p:cNvSpPr>
+            <a:spLocks noGrp="1"/>
+          </p:cNvSpPr>
+          <p:nvPr>
+            <p:ph idx="1" sz="quarter"/>
+          </p:nvPr>
+        </p:nvSpPr>
+        <p:spPr/>
+        <p:txBody>
+          <a:bodyPr wrap="square"/>
+          <a:lstStyle/>
+          <a:p>
+            <a:pPr>
+              <a:spcAft>
+                <a:spcPts val="1400"/>
+              </a:spcAft>
+            </a:pPr>
+            <a:r>
+              <a:t>QPU Deployment: Porting the simulated quantum layers directly to physical IBM QPUs.</a:t>
+            </a:r>
+          </a:p>
+          <a:p>
+            <a:pPr>
+              <a:spcAft>
+                <a:spcPts val="1400"/>
+              </a:spcAft>
+            </a:pPr>
+            <a:r>
+              <a:t>Graph Neural Network (GNN): Merging VQC with GNNs to trace large money laundering rings.</a:t>
+            </a:r>
+          </a:p>
+          <a:p>
+            <a:pPr>
+              <a:spcAft>
+                <a:spcPts val="1400"/>
+              </a:spcAft>
+            </a:pPr>
+            <a:r>
+              <a:t>Open Banking API: Packaging Q-Guard as a plug-and-play middleware module.</a:t>
+            </a:r>
+          </a:p>
+          <a:p>
+            <a:pPr>
+              <a:spcAft>
+                <a:spcPts val="1400"/>
+              </a:spcAft>
+            </a:pPr>
+            <a:r>
+              <a:t>Schrödinger's Coders: Securing the future of payments using quantum computing principles.</a:t>
+            </a:r>
+          </a:p>
+        </p:txBody>
+      </p:sp>
+    </p:spTree>
+  </p:cSld>
+  <p:clrMapOvr>
+    <a:masterClrMapping/>
+  </p:clrMapOvr>
+</p:sld>
+</file>
+
+<file path=ppt/slides/slide13.xml><?xml version="1.0" encoding="utf-8"?>
+<p:sld xmlns:a="http://schemas.openxmlformats.org/drawingml/2006/main" xmlns:p="http://schemas.openxmlformats.org/presentationml/2006/main" xmlns:r="http://schemas.openxmlformats.org/officeDocument/2006/relationships">
+  <p:cSld>
+    <p:spTree>
+      <p:nvGrpSpPr>
+        <p:cNvPr id="1" name=""/>
+        <p:cNvGrpSpPr/>
+        <p:nvPr/>
+      </p:nvGrpSpPr>
+      <p:grpSpPr/>
+      <p:sp>
+        <p:nvSpPr>
+          <p:cNvPr id="2" name="Title 1"/>
+          <p:cNvSpPr>
+            <a:spLocks noGrp="1"/>
+          </p:cNvSpPr>
+          <p:nvPr>
+            <p:ph type="title"/>
+          </p:nvPr>
+        </p:nvSpPr>
+        <p:spPr/>
+        <p:txBody>
+          <a:bodyPr/>
+          <a:lstStyle/>
+          <a:p>
+            <a:r>
+              <a:t>12. FUTURE SCOPE &amp; CONCLUSION</a:t>
+            </a:r>
+          </a:p>
+        </p:txBody>
+      </p:sp>
+      <p:sp>
+        <p:nvSpPr>
+          <p:cNvPr id="3" name="Content Placeholder 2"/>
+          <p:cNvSpPr>
+            <a:spLocks noGrp="1"/>
+          </p:cNvSpPr>
+          <p:nvPr>
+            <p:ph idx="1" sz="quarter"/>
+          </p:nvPr>
+        </p:nvSpPr>
+        <p:spPr/>
+        <p:txBody>
+          <a:bodyPr wrap="square"/>
+          <a:lstStyle/>
+          <a:p>
+            <a:pPr>
+              <a:spcAft>
+                <a:spcPts val="1400"/>
+              </a:spcAft>
+            </a:pPr>
+            <a:r>
+              <a:t>QPU Deployment: Porting the simulated quantum layers directly to physical IBM QPUs.</a:t>
+            </a:r>
+          </a:p>
+          <a:p>
+            <a:pPr>
+              <a:spcAft>
+                <a:spcPts val="1400"/>
+              </a:spcAft>
+            </a:pPr>
+            <a:r>
+              <a:t>Graph Neural Network (GNN): Merging VQC with GNNs to trace large money laundering rings.</a:t>
+            </a:r>
+          </a:p>
+          <a:p>
+            <a:pPr>
+              <a:spcAft>
+                <a:spcPts val="1400"/>
+              </a:spcAft>
+            </a:pPr>
+            <a:r>
+              <a:t>Open Banking API: Packaging Q-Guard as a plug-and-play middleware module.</a:t>
+            </a:r>
+          </a:p>
+          <a:p>
+            <a:pPr>
+              <a:spcAft>
+                <a:spcPts val="1400"/>
+              </a:spcAft>
+            </a:pPr>
+            <a:r>
+              <a:t>Schrödinger's Coders: Securing the future of payments using quantum computing principles.</a:t>
+            </a:r>
+          </a:p>
+        </p:txBody>
+      </p:sp>
+    </p:spTree>
+  </p:cSld>
+  <p:clrMapOvr>
+    <a:masterClrMapping/>
+  </p:clrMapOvr>
+</p:sld>
+</file>
+
+<file path=ppt/slides/slide14.xml><?xml version="1.0" encoding="utf-8"?>
 <p:sld xmlns:a="http://schemas.openxmlformats.org/drawingml/2006/main" xmlns:r="http://schemas.openxmlformats.org/officeDocument/2006/relationships" xmlns:p="http://schemas.openxmlformats.org/presentationml/2006/main">
   <p:cSld>
-    <p:bg>
-      <p:bgPr>
-        <a:blipFill dpi="0" rotWithShape="1">
-          <a:blip r:embed="rId3" cstate="print">
-            <a:lum/>
-          </a:blip>
-          <a:srcRect/>
-          <a:stretch>
-            <a:fillRect l="-24000" r="-24000"/>
-          </a:stretch>
-        </a:blipFill>
-        <a:effectLst/>
-      </p:bgPr>
-    </p:bg>
     <p:spTree>
       <p:nvGrpSpPr>
         <p:cNvPr id="1" name=""/>
@@ -6866,140 +7808,122 @@
       </p:grpSpPr>
       <p:sp>
         <p:nvSpPr>
-          <p:cNvPr id="2" name="TextBox 1"/>
-          <p:cNvSpPr txBox="1"/>
-          <p:nvPr/>
+          <p:cNvPr id="2" name="Title 1">
+            <a:extLst>
+              <a:ext uri="{FF2B5EF4-FFF2-40B4-BE49-F238E27FC236}">
+                <a16:creationId xmlns:a16="http://schemas.microsoft.com/office/drawing/2014/main" id="{59250CB0-4719-654B-6943-E02F7DD09760}"/>
+              </a:ext>
+            </a:extLst>
+          </p:cNvPr>
+          <p:cNvSpPr>
+            <a:spLocks noGrp="1"/>
+          </p:cNvSpPr>
+          <p:nvPr>
+            <p:ph type="title"/>
+          </p:nvPr>
         </p:nvSpPr>
         <p:spPr>
           <a:xfrm>
-            <a:off x="685800" y="457200"/>
-            <a:ext cx="7772400" cy="914400"/>
-          </a:xfrm>
-          <a:prstGeom prst="rect">
-            <a:avLst/>
-          </a:prstGeom>
-          <a:noFill/>
-        </p:spPr>
-        <p:txBody>
-          <a:bodyPr wrap="none">
-            <a:spAutoFit/>
+            <a:off x="301752" y="476672"/>
+            <a:ext cx="8534400" cy="758952"/>
+          </a:xfrm>
+        </p:spPr>
+        <p:txBody>
+          <a:bodyPr>
+            <a:normAutofit fontScale="90000"/>
           </a:bodyPr>
           <a:lstStyle/>
           <a:p>
-            <a:pPr>
-              <a:defRPr sz="2800" b="1">
-                <a:solidFill>
-                  <a:srgbClr val="00D4FF"/>
-                </a:solidFill>
-                <a:latin typeface="Rajdhani"/>
-              </a:defRPr>
-            </a:pPr>
-            <a:r>
-              <a:t>1. PROBLEM STATEMENT (QT-2.8)</a:t>
-            </a:r>
-          </a:p>
-        </p:txBody>
-      </p:sp>
-      <p:sp>
-        <p:nvSpPr>
-          <p:cNvPr id="3" name="TextBox 2"/>
-          <p:cNvSpPr txBox="1"/>
-          <p:nvPr/>
-        </p:nvSpPr>
-        <p:spPr>
-          <a:xfrm>
-            <a:off x="685800" y="1645920"/>
-            <a:ext cx="7772400" cy="4114800"/>
-          </a:xfrm>
-          <a:prstGeom prst="rect">
-            <a:avLst/>
-          </a:prstGeom>
-          <a:noFill/>
-        </p:spPr>
-        <p:txBody>
-          <a:bodyPr wrap="square">
-            <a:spAutoFit/>
+            <a:r>
+              <a:rPr lang="en-IN" b="1" dirty="0"/>
+              <a:t>Future Scope &amp; Conclusion</a:t>
+            </a:r>
+            <a:br>
+              <a:rPr lang="en-IN" dirty="0"/>
+            </a:br>
+            <a:endParaRPr lang="en-IN" b="1" dirty="0"/>
+          </a:p>
+        </p:txBody>
+      </p:sp>
+      <p:sp>
+        <p:nvSpPr>
+          <p:cNvPr id="3" name="Content Placeholder 2">
+            <a:extLst>
+              <a:ext uri="{FF2B5EF4-FFF2-40B4-BE49-F238E27FC236}">
+                <a16:creationId xmlns:a16="http://schemas.microsoft.com/office/drawing/2014/main" id="{B05D51C3-1493-886D-A1E2-9C8249A24802}"/>
+              </a:ext>
+            </a:extLst>
+          </p:cNvPr>
+          <p:cNvSpPr>
+            <a:spLocks noGrp="1"/>
+          </p:cNvSpPr>
+          <p:nvPr>
+            <p:ph sz="quarter" idx="1"/>
+          </p:nvPr>
+        </p:nvSpPr>
+        <p:spPr/>
+        <p:txBody>
+          <a:bodyPr>
+            <a:normAutofit/>
           </a:bodyPr>
           <a:lstStyle/>
-          <a:p/>
-          <a:p>
-            <a:pPr>
-              <a:spcAft>
-                <a:spcPts val="1200"/>
-              </a:spcAft>
-              <a:defRPr sz="1600">
-                <a:solidFill>
-                  <a:srgbClr val="DCF0FF"/>
-                </a:solidFill>
-              </a:defRPr>
-            </a:pPr>
-            <a:r>
-              <a:t>• Classical ML models check transactions in isolation, missing temporal loops.</a:t>
-            </a:r>
-          </a:p>
-          <a:p>
-            <a:pPr>
-              <a:spcAft>
-                <a:spcPts val="1200"/>
-              </a:spcAft>
-              <a:defRPr sz="1600">
-                <a:solidFill>
-                  <a:srgbClr val="DCF0FF"/>
-                </a:solidFill>
-              </a:defRPr>
-            </a:pPr>
-            <a:r>
-              <a:t>• High False Positive rates annoy regular customers, increasing churn and operational friction.</a:t>
-            </a:r>
-          </a:p>
-          <a:p>
-            <a:pPr>
-              <a:spcAft>
-                <a:spcPts val="1200"/>
-              </a:spcAft>
-              <a:defRPr sz="1600">
-                <a:solidFill>
-                  <a:srgbClr val="DCF0FF"/>
-                </a:solidFill>
-              </a:defRPr>
-            </a:pPr>
-            <a:r>
-              <a:t>• Regulatory compliance (RBI/Central Bank) requires Explainable AI (XAI) parameters.</a:t>
-            </a:r>
-          </a:p>
-          <a:p>
-            <a:pPr>
-              <a:spcAft>
-                <a:spcPts val="1200"/>
-              </a:spcAft>
-              <a:defRPr sz="1600">
-                <a:solidFill>
-                  <a:srgbClr val="DCF0FF"/>
-                </a:solidFill>
-              </a:defRPr>
-            </a:pPr>
-            <a:r>
-              <a:t>• Coordinated attacks (Mule Rings, shared device farms) bypass linear threshold rules.</a:t>
-            </a:r>
-          </a:p>
-          <a:p>
-            <a:pPr>
-              <a:spcAft>
-                <a:spcPts val="1200"/>
-              </a:spcAft>
-              <a:defRPr sz="1600">
-                <a:solidFill>
-                  <a:srgbClr val="DCF0FF"/>
-                </a:solidFill>
-              </a:defRPr>
-            </a:pPr>
-            <a:r>
-              <a:t>• Solution: Q-Guard AI combines Multi-Agent intelligence with a Quantum Optimization layer.</a:t>
-            </a:r>
+          <a:p>
+            <a:r>
+              <a:rPr lang="en-IN" sz="2200" b="1" dirty="0"/>
+              <a:t>Physical QPU Deployment</a:t>
+            </a:r>
+            <a:r>
+              <a:rPr lang="en-IN" sz="2200" dirty="0"/>
+              <a:t>: Transitioning from simulated quantum noise-free circuits to physical QPUs (like IBM Quantum).</a:t>
+            </a:r>
+          </a:p>
+          <a:p>
+            <a:r>
+              <a:rPr lang="en-IN" sz="2200" b="1" dirty="0"/>
+              <a:t>Real-time Graph Neural Networks (GNN)</a:t>
+            </a:r>
+            <a:r>
+              <a:rPr lang="en-IN" sz="2200" dirty="0"/>
+              <a:t>: Combining VQC with GNNs to map fraud loops across millions of bank accounts.</a:t>
+            </a:r>
+          </a:p>
+          <a:p>
+            <a:r>
+              <a:rPr lang="en-IN" sz="2200" b="1" dirty="0"/>
+              <a:t>Open-Source Integration</a:t>
+            </a:r>
+            <a:r>
+              <a:rPr lang="en-IN" sz="2200" dirty="0"/>
+              <a:t>: Standardizing Q-Guard APIs to plug directly into classical core banking software.</a:t>
+            </a:r>
+          </a:p>
+          <a:p>
+            <a:r>
+              <a:rPr lang="en-IN" sz="2200" b="1" dirty="0"/>
+              <a:t>Schrödinger's Coders Vision</a:t>
+            </a:r>
+            <a:r>
+              <a:rPr lang="en-IN" sz="2200" dirty="0"/>
+              <a:t>: Reimagining digital transaction security through the lens of quantum physics.</a:t>
+            </a:r>
+          </a:p>
+          <a:p>
+            <a:pPr marL="0" indent="0">
+              <a:buNone/>
+            </a:pPr>
+            <a:br>
+              <a:rPr lang="en-IN" sz="2200" dirty="0"/>
+            </a:br>
+            <a:endParaRPr lang="en-IN" sz="2200" dirty="0"/>
           </a:p>
         </p:txBody>
       </p:sp>
     </p:spTree>
+    <p:extLst>
+      <p:ext uri="{BB962C8B-B14F-4D97-AF65-F5344CB8AC3E}">
+        <p14:creationId xmlns:p14="http://schemas.microsoft.com/office/powerpoint/2010/main" val="1575665909"/>
+      </p:ext>
+    </p:extLst>
   </p:cSld>
   <p:clrMapOvr>
     <a:masterClrMapping/>
@@ -7007,13 +7931,289 @@
   <p:transition>
     <p:fade/>
   </p:transition>
-  <p:timing>
-    <p:tnLst>
-      <p:par>
-        <p:cTn id="1" dur="indefinite" restart="never" nodeType="tmRoot"/>
-      </p:par>
-    </p:tnLst>
-  </p:timing>
+</p:sld>
+</file>
+
+<file path=ppt/slides/slide15.xml><?xml version="1.0" encoding="utf-8"?>
+<p:sld xmlns:a="http://schemas.openxmlformats.org/drawingml/2006/main" xmlns:r="http://schemas.openxmlformats.org/officeDocument/2006/relationships" xmlns:p="http://schemas.openxmlformats.org/presentationml/2006/main">
+  <p:cSld>
+    <p:spTree>
+      <p:nvGrpSpPr>
+        <p:cNvPr id="1" name=""/>
+        <p:cNvGrpSpPr/>
+        <p:nvPr/>
+      </p:nvGrpSpPr>
+      <p:grpSpPr>
+        <a:xfrm>
+          <a:off x="0" y="0"/>
+          <a:ext cx="0" cy="0"/>
+          <a:chOff x="0" y="0"/>
+          <a:chExt cx="0" cy="0"/>
+        </a:xfrm>
+      </p:grpSpPr>
+      <p:sp>
+        <p:nvSpPr>
+          <p:cNvPr id="3" name="TextBox 2">
+            <a:extLst>
+              <a:ext uri="{FF2B5EF4-FFF2-40B4-BE49-F238E27FC236}">
+                <a16:creationId xmlns:a16="http://schemas.microsoft.com/office/drawing/2014/main" id="{FF7B93C8-F277-C1D5-9097-F9CB8533CBC2}"/>
+              </a:ext>
+            </a:extLst>
+          </p:cNvPr>
+          <p:cNvSpPr txBox="1"/>
+          <p:nvPr/>
+        </p:nvSpPr>
+        <p:spPr>
+          <a:xfrm>
+            <a:off x="1732248" y="2921168"/>
+            <a:ext cx="5679504" cy="1015663"/>
+          </a:xfrm>
+          <a:prstGeom prst="rect">
+            <a:avLst/>
+          </a:prstGeom>
+          <a:noFill/>
+        </p:spPr>
+        <p:txBody>
+          <a:bodyPr wrap="square">
+            <a:spAutoFit/>
+          </a:bodyPr>
+          <a:lstStyle/>
+          <a:p>
+            <a:pPr indent="0" algn="ctr"/>
+            <a:r>
+              <a:rPr lang="en-IN" sz="6000" b="1" i="0" dirty="0">
+                <a:effectLst/>
+                <a:latin typeface="ui-sans-serif"/>
+              </a:rPr>
+              <a:t>THANK YOU!</a:t>
+            </a:r>
+            <a:endParaRPr lang="en-IN" sz="6000" dirty="0"/>
+          </a:p>
+        </p:txBody>
+      </p:sp>
+    </p:spTree>
+    <p:extLst>
+      <p:ext uri="{BB962C8B-B14F-4D97-AF65-F5344CB8AC3E}">
+        <p14:creationId xmlns:p14="http://schemas.microsoft.com/office/powerpoint/2010/main" val="166655773"/>
+      </p:ext>
+    </p:extLst>
+  </p:cSld>
+  <p:clrMapOvr>
+    <a:masterClrMapping/>
+  </p:clrMapOvr>
+  <p:transition>
+    <p:fade/>
+  </p:transition>
+</p:sld>
+</file>
+
+<file path=ppt/slides/slide2.xml><?xml version="1.0" encoding="utf-8"?>
+<p:sld xmlns:a="http://schemas.openxmlformats.org/drawingml/2006/main" xmlns:p="http://schemas.openxmlformats.org/presentationml/2006/main" xmlns:r="http://schemas.openxmlformats.org/officeDocument/2006/relationships">
+  <p:cSld>
+    <p:spTree>
+      <p:nvGrpSpPr>
+        <p:cNvPr id="1" name=""/>
+        <p:cNvGrpSpPr/>
+        <p:nvPr/>
+      </p:nvGrpSpPr>
+      <p:grpSpPr/>
+      <p:sp>
+        <p:nvSpPr>
+          <p:cNvPr id="2" name="Title 1"/>
+          <p:cNvSpPr>
+            <a:spLocks noGrp="1"/>
+          </p:cNvSpPr>
+          <p:nvPr>
+            <p:ph type="title"/>
+          </p:nvPr>
+        </p:nvSpPr>
+        <p:spPr/>
+        <p:txBody>
+          <a:bodyPr/>
+          <a:lstStyle/>
+          <a:p>
+            <a:r>
+              <a:t>1. PROBLEM STATEMENT (QT-2.8)</a:t>
+            </a:r>
+          </a:p>
+        </p:txBody>
+      </p:sp>
+      <p:sp>
+        <p:nvSpPr>
+          <p:cNvPr id="3" name="Content Placeholder 2"/>
+          <p:cNvSpPr>
+            <a:spLocks noGrp="1"/>
+          </p:cNvSpPr>
+          <p:nvPr>
+            <p:ph idx="1" sz="quarter"/>
+          </p:nvPr>
+        </p:nvSpPr>
+        <p:spPr/>
+        <p:txBody>
+          <a:bodyPr wrap="square"/>
+          <a:lstStyle/>
+          <a:p>
+            <a:pPr>
+              <a:spcAft>
+                <a:spcPts val="1400"/>
+              </a:spcAft>
+            </a:pPr>
+            <a:r>
+              <a:t>Mule Fund Relays: Syndicates route stolen funds through intermediate accounts in minutes.</a:t>
+            </a:r>
+          </a:p>
+          <a:p>
+            <a:pPr>
+              <a:spcAft>
+                <a:spcPts val="1400"/>
+              </a:spcAft>
+            </a:pPr>
+            <a:r>
+              <a:t>Device Farms: Fraudsters use virtual emulators to spoof 'trusted devices' at scale.</a:t>
+            </a:r>
+          </a:p>
+          <a:p>
+            <a:pPr>
+              <a:spcAft>
+                <a:spcPts val="1400"/>
+              </a:spcAft>
+            </a:pPr>
+            <a:r>
+              <a:t>Velocity Structuring: Bots slice transactions into micro-amounts below default detection limits.</a:t>
+            </a:r>
+          </a:p>
+          <a:p>
+            <a:pPr>
+              <a:spcAft>
+                <a:spcPts val="1400"/>
+              </a:spcAft>
+            </a:pPr>
+            <a:r>
+              <a:t>Linear Blindspot: Traditional rules evaluate details in isolation, missing non-linear loops.</a:t>
+            </a:r>
+          </a:p>
+          <a:p>
+            <a:pPr>
+              <a:spcAft>
+                <a:spcPts val="1400"/>
+              </a:spcAft>
+            </a:pPr>
+            <a:r>
+              <a:t>Solution: Q-Guard AI blends Multi-Agent ingestion with a Parameterized Quantum Circuit.</a:t>
+            </a:r>
+          </a:p>
+        </p:txBody>
+      </p:sp>
+    </p:spTree>
+  </p:cSld>
+  <p:clrMapOvr>
+    <a:masterClrMapping/>
+  </p:clrMapOvr>
+</p:sld>
+</file>
+
+<file path=ppt/slides/slide2.xml><?xml version="1.0" encoding="utf-8"?>
+<p:sld xmlns:a="http://schemas.openxmlformats.org/drawingml/2006/main" xmlns:p="http://schemas.openxmlformats.org/presentationml/2006/main" xmlns:r="http://schemas.openxmlformats.org/officeDocument/2006/relationships">
+  <p:cSld>
+    <p:spTree>
+      <p:nvGrpSpPr>
+        <p:cNvPr id="1" name=""/>
+        <p:cNvGrpSpPr/>
+        <p:nvPr/>
+      </p:nvGrpSpPr>
+      <p:grpSpPr/>
+      <p:sp>
+        <p:nvSpPr>
+          <p:cNvPr id="2" name="Title 1"/>
+          <p:cNvSpPr>
+            <a:spLocks noGrp="1"/>
+          </p:cNvSpPr>
+          <p:nvPr>
+            <p:ph type="title"/>
+          </p:nvPr>
+        </p:nvSpPr>
+        <p:spPr/>
+        <p:txBody>
+          <a:bodyPr/>
+          <a:lstStyle/>
+          <a:p>
+            <a:r>
+              <a:t>1. PROBLEM STATEMENT (QT-2.8)</a:t>
+            </a:r>
+          </a:p>
+        </p:txBody>
+      </p:sp>
+      <p:sp>
+        <p:nvSpPr>
+          <p:cNvPr id="3" name="Content Placeholder 2"/>
+          <p:cNvSpPr>
+            <a:spLocks noGrp="1"/>
+          </p:cNvSpPr>
+          <p:nvPr>
+            <p:ph idx="1" sz="quarter"/>
+          </p:nvPr>
+        </p:nvSpPr>
+        <p:spPr/>
+        <p:txBody>
+          <a:bodyPr wrap="square"/>
+          <a:lstStyle/>
+          <a:p>
+            <a:pPr>
+              <a:spcAft>
+                <a:spcPts val="1400"/>
+              </a:spcAft>
+            </a:pPr>
+            <a:r>
+              <a:t>Mule Fund Relays: Syndicates route stolen funds through intermediate accounts in minutes.</a:t>
+            </a:r>
+          </a:p>
+          <a:p>
+            <a:pPr>
+              <a:spcAft>
+                <a:spcPts val="1400"/>
+              </a:spcAft>
+            </a:pPr>
+            <a:r>
+              <a:t>Device Farms: Fraudsters use virtual emulators to spoof 'trusted devices' at scale.</a:t>
+            </a:r>
+          </a:p>
+          <a:p>
+            <a:pPr>
+              <a:spcAft>
+                <a:spcPts val="1400"/>
+              </a:spcAft>
+            </a:pPr>
+            <a:r>
+              <a:t>Velocity Structuring: Bots slice transactions into micro-amounts below default detection limits.</a:t>
+            </a:r>
+          </a:p>
+          <a:p>
+            <a:pPr>
+              <a:spcAft>
+                <a:spcPts val="1400"/>
+              </a:spcAft>
+            </a:pPr>
+            <a:r>
+              <a:t>Linear Blindspot: Traditional rules evaluate details in isolation, missing non-linear loops.</a:t>
+            </a:r>
+          </a:p>
+          <a:p>
+            <a:pPr>
+              <a:spcAft>
+                <a:spcPts val="1400"/>
+              </a:spcAft>
+            </a:pPr>
+            <a:r>
+              <a:t>Solution: Q-Guard AI blends Multi-Agent ingestion with a Parameterized Quantum Circuit.</a:t>
+            </a:r>
+          </a:p>
+        </p:txBody>
+      </p:sp>
+    </p:spTree>
+  </p:cSld>
+  <p:clrMapOvr>
+    <a:masterClrMapping/>
+  </p:clrMapOvr>
 </p:sld>
 </file>
 
@@ -7043,7 +8243,7 @@
           <a:lstStyle/>
           <a:p>
             <a:r>
-              <a:t>2. Q-GUARD ARCHITECTURE: MULTI-AGENT INGESTION</a:t>
+              <a:t>2. WHY CLASSICAL MACHINE LEARNING FAILS</a:t>
             </a:r>
           </a:p>
         </p:txBody>
@@ -7065,76 +8265,136 @@
           <a:p>
             <a:pPr>
               <a:spcAft>
-                <a:spcPts val="1200"/>
-              </a:spcAft>
-              <a:defRPr sz="1600">
-                <a:solidFill>
-                  <a:srgbClr val="DCF0FF"/>
-                </a:solidFill>
-              </a:defRPr>
-            </a:pPr>
-            <a:r>
-              <a:t>• User Behavior Agent: Analyzes daily spending limit fractions and time deviation.</a:t>
-            </a:r>
-          </a:p>
-          <a:p>
-            <a:pPr>
-              <a:spcAft>
-                <a:spcPts val="1200"/>
-              </a:spcAft>
-              <a:defRPr sz="1600">
-                <a:solidFill>
-                  <a:srgbClr val="DCF0FF"/>
-                </a:solidFill>
-              </a:defRPr>
-            </a:pPr>
-            <a:r>
-              <a:t>• Device Intelligence Agent: Detects OS versions, emulators, and device trust rating.</a:t>
-            </a:r>
-          </a:p>
-          <a:p>
-            <a:pPr>
-              <a:spcAft>
-                <a:spcPts val="1200"/>
-              </a:spcAft>
-              <a:defRPr sz="1600">
-                <a:solidFill>
-                  <a:srgbClr val="DCF0FF"/>
-                </a:solidFill>
-              </a:defRPr>
-            </a:pPr>
-            <a:r>
-              <a:t>• Merchant Rating Agent: Assesses merchant category hazard and chargeback rates.</a:t>
-            </a:r>
-          </a:p>
-          <a:p>
-            <a:pPr>
-              <a:spcAft>
-                <a:spcPts val="1200"/>
-              </a:spcAft>
-              <a:defRPr sz="1600">
-                <a:solidFill>
-                  <a:srgbClr val="DCF0FF"/>
-                </a:solidFill>
-              </a:defRPr>
-            </a:pPr>
-            <a:r>
-              <a:t>• Network Intelligence Agent: Monitors VPN usage, proxy IPs, and impossible travel.</a:t>
-            </a:r>
-          </a:p>
-          <a:p>
-            <a:pPr>
-              <a:spcAft>
-                <a:spcPts val="1200"/>
-              </a:spcAft>
-              <a:defRPr sz="1600">
-                <a:solidFill>
-                  <a:srgbClr val="DCF0FF"/>
-                </a:solidFill>
-              </a:defRPr>
-            </a:pPr>
-            <a:r>
-              <a:t>• Benefit: Decentralized analysis captures separate threat layers simultaneously.</a:t>
+                <a:spcPts val="1400"/>
+              </a:spcAft>
+            </a:pPr>
+            <a:r>
+              <a:t>High False Positives: Static rules trigger blocks on regular traveler activity, creating churn.</a:t>
+            </a:r>
+          </a:p>
+          <a:p>
+            <a:pPr>
+              <a:spcAft>
+                <a:spcPts val="1400"/>
+              </a:spcAft>
+            </a:pPr>
+            <a:r>
+              <a:t>Dimensionality Curse: Linking deep behavior details requires heavy classical networks.</a:t>
+            </a:r>
+          </a:p>
+          <a:p>
+            <a:pPr>
+              <a:spcAft>
+                <a:spcPts val="1400"/>
+              </a:spcAft>
+            </a:pPr>
+            <a:r>
+              <a:t>Black-Box Decisioning: Deep learning models cannot explain logs for audit compliance.</a:t>
+            </a:r>
+          </a:p>
+          <a:p>
+            <a:pPr>
+              <a:spcAft>
+                <a:spcPts val="1400"/>
+              </a:spcAft>
+            </a:pPr>
+            <a:r>
+              <a:t>Rigid Threshold Limits: Static fraud limits leave banks open to off-peak night exploits.</a:t>
+            </a:r>
+          </a:p>
+        </p:txBody>
+      </p:sp>
+    </p:spTree>
+  </p:cSld>
+  <p:clrMapOvr>
+    <a:masterClrMapping/>
+  </p:clrMapOvr>
+</p:sld>
+</file>
+
+<file path=ppt/slides/slide3.xml><?xml version="1.0" encoding="utf-8"?>
+<p:sld xmlns:a="http://schemas.openxmlformats.org/drawingml/2006/main" xmlns:p="http://schemas.openxmlformats.org/presentationml/2006/main" xmlns:r="http://schemas.openxmlformats.org/officeDocument/2006/relationships">
+  <p:cSld>
+    <p:spTree>
+      <p:nvGrpSpPr>
+        <p:cNvPr id="1" name=""/>
+        <p:cNvGrpSpPr/>
+        <p:nvPr/>
+      </p:nvGrpSpPr>
+      <p:grpSpPr/>
+      <p:sp>
+        <p:nvSpPr>
+          <p:cNvPr id="2" name="Title 1"/>
+          <p:cNvSpPr>
+            <a:spLocks noGrp="1"/>
+          </p:cNvSpPr>
+          <p:nvPr>
+            <p:ph type="title"/>
+          </p:nvPr>
+        </p:nvSpPr>
+        <p:spPr/>
+        <p:txBody>
+          <a:bodyPr/>
+          <a:lstStyle/>
+          <a:p>
+            <a:r>
+              <a:t>2. WHY CLASSICAL MACHINE LEARNING FAILS</a:t>
+            </a:r>
+          </a:p>
+        </p:txBody>
+      </p:sp>
+      <p:sp>
+        <p:nvSpPr>
+          <p:cNvPr id="3" name="Content Placeholder 2"/>
+          <p:cNvSpPr>
+            <a:spLocks noGrp="1"/>
+          </p:cNvSpPr>
+          <p:nvPr>
+            <p:ph idx="1" sz="quarter"/>
+          </p:nvPr>
+        </p:nvSpPr>
+        <p:spPr/>
+        <p:txBody>
+          <a:bodyPr wrap="square"/>
+          <a:lstStyle/>
+          <a:p>
+            <a:pPr>
+              <a:spcAft>
+                <a:spcPts val="1400"/>
+              </a:spcAft>
+            </a:pPr>
+            <a:r>
+              <a:t>High False Positives: Static rules trigger blocks on regular traveler activity, creating churn.</a:t>
+            </a:r>
+          </a:p>
+          <a:p>
+            <a:pPr>
+              <a:spcAft>
+                <a:spcPts val="1400"/>
+              </a:spcAft>
+            </a:pPr>
+            <a:r>
+              <a:t>Dimensionality Curse: Linking deep behavior details requires heavy classical networks.</a:t>
+            </a:r>
+          </a:p>
+          <a:p>
+            <a:pPr>
+              <a:spcAft>
+                <a:spcPts val="1400"/>
+              </a:spcAft>
+            </a:pPr>
+            <a:r>
+              <a:t>Black-Box Decisioning: Deep learning models cannot explain logs for audit compliance.</a:t>
+            </a:r>
+          </a:p>
+          <a:p>
+            <a:pPr>
+              <a:spcAft>
+                <a:spcPts val="1400"/>
+              </a:spcAft>
+            </a:pPr>
+            <a:r>
+              <a:t>Rigid Threshold Limits: Static fraud limits leave banks open to off-peak night exploits.</a:t>
             </a:r>
           </a:p>
         </p:txBody>
@@ -7173,7 +8433,7 @@
           <a:lstStyle/>
           <a:p>
             <a:r>
-              <a:t>3. QUANTUM WEIGHT OPTIMIZATION (QML LAYER)</a:t>
+              <a:t>3. THE QUANTUM ADVANTAGE (QML LAYER)</a:t>
             </a:r>
           </a:p>
         </p:txBody>
@@ -7195,76 +8455,136 @@
           <a:p>
             <a:pPr>
               <a:spcAft>
-                <a:spcPts val="1200"/>
-              </a:spcAft>
-              <a:defRPr sz="1600">
-                <a:solidFill>
-                  <a:srgbClr val="DCF0FF"/>
-                </a:solidFill>
-              </a:defRPr>
-            </a:pPr>
-            <a:r>
-              <a:t>• State Encoding: Maps the 4 Agent risk variables directly to 4 Qubits (Q0 to Q3).</a:t>
-            </a:r>
-          </a:p>
-          <a:p>
-            <a:pPr>
-              <a:spcAft>
-                <a:spcPts val="1200"/>
-              </a:spcAft>
-              <a:defRPr sz="1600">
-                <a:solidFill>
-                  <a:srgbClr val="DCF0FF"/>
-                </a:solidFill>
-              </a:defRPr>
-            </a:pPr>
-            <a:r>
-              <a:t>• Entangling Circuit: Employs a Ring CNOT entangler to learn inter-agent correlations.</a:t>
-            </a:r>
-          </a:p>
-          <a:p>
-            <a:pPr>
-              <a:spcAft>
-                <a:spcPts val="1200"/>
-              </a:spcAft>
-              <a:defRPr sz="1600">
-                <a:solidFill>
-                  <a:srgbClr val="DCF0FF"/>
-                </a:solidFill>
-              </a:defRPr>
-            </a:pPr>
-            <a:r>
-              <a:t>• Dynamic Weighting: Aggregates risk dynamically based on Qubit Z-coordinate excitation.</a:t>
-            </a:r>
-          </a:p>
-          <a:p>
-            <a:pPr>
-              <a:spcAft>
-                <a:spcPts val="1200"/>
-              </a:spcAft>
-              <a:defRPr sz="1600">
-                <a:solidFill>
-                  <a:srgbClr val="DCF0FF"/>
-                </a:solidFill>
-              </a:defRPr>
-            </a:pPr>
-            <a:r>
-              <a:t>• Bloch Projections: Agent weights are proportional to excitation (Weight = 1.0 - Z).</a:t>
-            </a:r>
-          </a:p>
-          <a:p>
-            <a:pPr>
-              <a:spcAft>
-                <a:spcPts val="1200"/>
-              </a:spcAft>
-              <a:defRPr sz="1600">
-                <a:solidFill>
-                  <a:srgbClr val="DCF0FF"/>
-                </a:solidFill>
-              </a:defRPr>
-            </a:pPr>
-            <a:r>
-              <a:t>• Benefit: Captures non-linear threat vectors using 90% fewer parameters than classical NN.</a:t>
+                <a:spcPts val="1400"/>
+              </a:spcAft>
+            </a:pPr>
+            <a:r>
+              <a:t>Non-Linear Correlation: Quantum state entanglements capture inter-agent correlations naturally.</a:t>
+            </a:r>
+          </a:p>
+          <a:p>
+            <a:pPr>
+              <a:spcAft>
+                <a:spcPts val="1400"/>
+              </a:spcAft>
+            </a:pPr>
+            <a:r>
+              <a:t>Parameter Efficiency: A 4-qubit classifier uses 90% fewer weights than classical models.</a:t>
+            </a:r>
+          </a:p>
+          <a:p>
+            <a:pPr>
+              <a:spcAft>
+                <a:spcPts val="1400"/>
+              </a:spcAft>
+            </a:pPr>
+            <a:r>
+              <a:t>Hilbert Mapping: Translates complex user behavior metrics to subatomic quantum states.</a:t>
+            </a:r>
+          </a:p>
+          <a:p>
+            <a:pPr>
+              <a:spcAft>
+                <a:spcPts val="1400"/>
+              </a:spcAft>
+            </a:pPr>
+            <a:r>
+              <a:t>Hardware Readiness: Designed to plug natively into physical NISQ QPUs (like IBM Quantum).</a:t>
+            </a:r>
+          </a:p>
+        </p:txBody>
+      </p:sp>
+    </p:spTree>
+  </p:cSld>
+  <p:clrMapOvr>
+    <a:masterClrMapping/>
+  </p:clrMapOvr>
+</p:sld>
+</file>
+
+<file path=ppt/slides/slide4.xml><?xml version="1.0" encoding="utf-8"?>
+<p:sld xmlns:a="http://schemas.openxmlformats.org/drawingml/2006/main" xmlns:p="http://schemas.openxmlformats.org/presentationml/2006/main" xmlns:r="http://schemas.openxmlformats.org/officeDocument/2006/relationships">
+  <p:cSld>
+    <p:spTree>
+      <p:nvGrpSpPr>
+        <p:cNvPr id="1" name=""/>
+        <p:cNvGrpSpPr/>
+        <p:nvPr/>
+      </p:nvGrpSpPr>
+      <p:grpSpPr/>
+      <p:sp>
+        <p:nvSpPr>
+          <p:cNvPr id="2" name="Title 1"/>
+          <p:cNvSpPr>
+            <a:spLocks noGrp="1"/>
+          </p:cNvSpPr>
+          <p:nvPr>
+            <p:ph type="title"/>
+          </p:nvPr>
+        </p:nvSpPr>
+        <p:spPr/>
+        <p:txBody>
+          <a:bodyPr/>
+          <a:lstStyle/>
+          <a:p>
+            <a:r>
+              <a:t>3. THE QUANTUM ADVANTAGE (QML LAYER)</a:t>
+            </a:r>
+          </a:p>
+        </p:txBody>
+      </p:sp>
+      <p:sp>
+        <p:nvSpPr>
+          <p:cNvPr id="3" name="Content Placeholder 2"/>
+          <p:cNvSpPr>
+            <a:spLocks noGrp="1"/>
+          </p:cNvSpPr>
+          <p:nvPr>
+            <p:ph idx="1" sz="quarter"/>
+          </p:nvPr>
+        </p:nvSpPr>
+        <p:spPr/>
+        <p:txBody>
+          <a:bodyPr wrap="square"/>
+          <a:lstStyle/>
+          <a:p>
+            <a:pPr>
+              <a:spcAft>
+                <a:spcPts val="1400"/>
+              </a:spcAft>
+            </a:pPr>
+            <a:r>
+              <a:t>Non-Linear Correlation: Quantum state entanglements capture inter-agent correlations naturally.</a:t>
+            </a:r>
+          </a:p>
+          <a:p>
+            <a:pPr>
+              <a:spcAft>
+                <a:spcPts val="1400"/>
+              </a:spcAft>
+            </a:pPr>
+            <a:r>
+              <a:t>Parameter Efficiency: A 4-qubit classifier uses 90% fewer weights than classical models.</a:t>
+            </a:r>
+          </a:p>
+          <a:p>
+            <a:pPr>
+              <a:spcAft>
+                <a:spcPts val="1400"/>
+              </a:spcAft>
+            </a:pPr>
+            <a:r>
+              <a:t>Hilbert Mapping: Translates complex user behavior metrics to subatomic quantum states.</a:t>
+            </a:r>
+          </a:p>
+          <a:p>
+            <a:pPr>
+              <a:spcAft>
+                <a:spcPts val="1400"/>
+              </a:spcAft>
+            </a:pPr>
+            <a:r>
+              <a:t>Hardware Readiness: Designed to plug natively into physical NISQ QPUs (like IBM Quantum).</a:t>
             </a:r>
           </a:p>
         </p:txBody>
@@ -7303,7 +8623,7 @@
           <a:lstStyle/>
           <a:p>
             <a:r>
-              <a:t>4. ADAPTIVE CONTEXT THRESHOLD ENGINE</a:t>
+              <a:t>4. MULTI-AGENT INGESTION ARCHITECTURE</a:t>
             </a:r>
           </a:p>
         </p:txBody>
@@ -7325,76 +8645,156 @@
           <a:p>
             <a:pPr>
               <a:spcAft>
-                <a:spcPts val="1200"/>
-              </a:spcAft>
-              <a:defRPr sz="1600">
-                <a:solidFill>
-                  <a:srgbClr val="DCF0FF"/>
-                </a:solidFill>
-              </a:defRPr>
-            </a:pPr>
-            <a:r>
-              <a:t>• Standard Thresholds: Traditional banks use static 80% limits (high friction).</a:t>
-            </a:r>
-          </a:p>
-          <a:p>
-            <a:pPr>
-              <a:spcAft>
-                <a:spcPts val="1200"/>
-              </a:spcAft>
-              <a:defRPr sz="1600">
-                <a:solidFill>
-                  <a:srgbClr val="DCF0FF"/>
-                </a:solidFill>
-              </a:defRPr>
-            </a:pPr>
-            <a:r>
-              <a:t>• Adaptive Threshold: Q-Guard shifts limits dynamically based on transaction context.</a:t>
-            </a:r>
-          </a:p>
-          <a:p>
-            <a:pPr>
-              <a:spcAft>
-                <a:spcPts val="1200"/>
-              </a:spcAft>
-              <a:defRPr sz="1600">
-                <a:solidFill>
-                  <a:srgbClr val="DCF0FF"/>
-                </a:solidFill>
-              </a:defRPr>
-            </a:pPr>
-            <a:r>
-              <a:t>• Late Night Hour Window (12 AM - 5 AM): Threshold drops to 65% (restrictive).</a:t>
-            </a:r>
-          </a:p>
-          <a:p>
-            <a:pPr>
-              <a:spcAft>
-                <a:spcPts val="1200"/>
-              </a:spcAft>
-              <a:defRPr sz="1600">
-                <a:solidFill>
-                  <a:srgbClr val="DCF0FF"/>
-                </a:solidFill>
-              </a:defRPr>
-            </a:pPr>
-            <a:r>
-              <a:t>• High chargeback Merchant Terminal: Threshold drops to 58% (highly secure).</a:t>
-            </a:r>
-          </a:p>
-          <a:p>
-            <a:pPr>
-              <a:spcAft>
-                <a:spcPts val="1200"/>
-              </a:spcAft>
-              <a:defRPr sz="1600">
-                <a:solidFill>
-                  <a:srgbClr val="DCF0FF"/>
-                </a:solidFill>
-              </a:defRPr>
-            </a:pPr>
-            <a:r>
-              <a:t>• Trusted Regular Customer: Threshold rises to 95% (minimizes customer friction).</a:t>
+                <a:spcPts val="1400"/>
+              </a:spcAft>
+            </a:pPr>
+            <a:r>
+              <a:t>User Agent: Analyzes spending limit fraction deviations and transaction timestamps.</a:t>
+            </a:r>
+          </a:p>
+          <a:p>
+            <a:pPr>
+              <a:spcAft>
+                <a:spcPts val="1400"/>
+              </a:spcAft>
+            </a:pPr>
+            <a:r>
+              <a:t>Device Agent: Assesses browser attributes, OS versions, emulator footprints, and device age.</a:t>
+            </a:r>
+          </a:p>
+          <a:p>
+            <a:pPr>
+              <a:spcAft>
+                <a:spcPts val="1400"/>
+              </a:spcAft>
+            </a:pPr>
+            <a:r>
+              <a:t>Merchant Agent: Monitors seller category hazard levels and historic chargeback metrics.</a:t>
+            </a:r>
+          </a:p>
+          <a:p>
+            <a:pPr>
+              <a:spcAft>
+                <a:spcPts val="1400"/>
+              </a:spcAft>
+            </a:pPr>
+            <a:r>
+              <a:t>Network Agent: Assesses VPN/proxy usage, geodistance anomalies, and impossible travel velocity.</a:t>
+            </a:r>
+          </a:p>
+          <a:p>
+            <a:pPr>
+              <a:spcAft>
+                <a:spcPts val="1400"/>
+              </a:spcAft>
+            </a:pPr>
+            <a:r>
+              <a:t>Decentralized Design: Ensures multiple threat dimensions are ingested simultaneously.</a:t>
+            </a:r>
+          </a:p>
+        </p:txBody>
+      </p:sp>
+    </p:spTree>
+  </p:cSld>
+  <p:clrMapOvr>
+    <a:masterClrMapping/>
+  </p:clrMapOvr>
+</p:sld>
+</file>
+
+<file path=ppt/slides/slide5.xml><?xml version="1.0" encoding="utf-8"?>
+<p:sld xmlns:a="http://schemas.openxmlformats.org/drawingml/2006/main" xmlns:p="http://schemas.openxmlformats.org/presentationml/2006/main" xmlns:r="http://schemas.openxmlformats.org/officeDocument/2006/relationships">
+  <p:cSld>
+    <p:spTree>
+      <p:nvGrpSpPr>
+        <p:cNvPr id="1" name=""/>
+        <p:cNvGrpSpPr/>
+        <p:nvPr/>
+      </p:nvGrpSpPr>
+      <p:grpSpPr/>
+      <p:sp>
+        <p:nvSpPr>
+          <p:cNvPr id="2" name="Title 1"/>
+          <p:cNvSpPr>
+            <a:spLocks noGrp="1"/>
+          </p:cNvSpPr>
+          <p:nvPr>
+            <p:ph type="title"/>
+          </p:nvPr>
+        </p:nvSpPr>
+        <p:spPr/>
+        <p:txBody>
+          <a:bodyPr/>
+          <a:lstStyle/>
+          <a:p>
+            <a:r>
+              <a:t>4. MULTI-AGENT INGESTION ARCHITECTURE</a:t>
+            </a:r>
+          </a:p>
+        </p:txBody>
+      </p:sp>
+      <p:sp>
+        <p:nvSpPr>
+          <p:cNvPr id="3" name="Content Placeholder 2"/>
+          <p:cNvSpPr>
+            <a:spLocks noGrp="1"/>
+          </p:cNvSpPr>
+          <p:nvPr>
+            <p:ph idx="1" sz="quarter"/>
+          </p:nvPr>
+        </p:nvSpPr>
+        <p:spPr/>
+        <p:txBody>
+          <a:bodyPr wrap="square"/>
+          <a:lstStyle/>
+          <a:p>
+            <a:pPr>
+              <a:spcAft>
+                <a:spcPts val="1400"/>
+              </a:spcAft>
+            </a:pPr>
+            <a:r>
+              <a:t>User Agent: Analyzes spending limit fraction deviations and transaction timestamps.</a:t>
+            </a:r>
+          </a:p>
+          <a:p>
+            <a:pPr>
+              <a:spcAft>
+                <a:spcPts val="1400"/>
+              </a:spcAft>
+            </a:pPr>
+            <a:r>
+              <a:t>Device Agent: Assesses browser attributes, OS versions, emulator footprints, and device age.</a:t>
+            </a:r>
+          </a:p>
+          <a:p>
+            <a:pPr>
+              <a:spcAft>
+                <a:spcPts val="1400"/>
+              </a:spcAft>
+            </a:pPr>
+            <a:r>
+              <a:t>Merchant Agent: Monitors seller category hazard levels and historic chargeback metrics.</a:t>
+            </a:r>
+          </a:p>
+          <a:p>
+            <a:pPr>
+              <a:spcAft>
+                <a:spcPts val="1400"/>
+              </a:spcAft>
+            </a:pPr>
+            <a:r>
+              <a:t>Network Agent: Assesses VPN/proxy usage, geodistance anomalies, and impossible travel velocity.</a:t>
+            </a:r>
+          </a:p>
+          <a:p>
+            <a:pPr>
+              <a:spcAft>
+                <a:spcPts val="1400"/>
+              </a:spcAft>
+            </a:pPr>
+            <a:r>
+              <a:t>Decentralized Design: Ensures multiple threat dimensions are ingested simultaneously.</a:t>
             </a:r>
           </a:p>
         </p:txBody>
@@ -7433,7 +8833,7 @@
           <a:lstStyle/>
           <a:p>
             <a:r>
-              <a:t>5. SELF-EXPLAINABLE AI &amp; MITIGATION CHECKLISTS</a:t>
+              <a:t>5. BLOCH SPHERE &amp; STATE VECTOR MAPPING</a:t>
             </a:r>
           </a:p>
         </p:txBody>
@@ -7455,76 +8855,136 @@
           <a:p>
             <a:pPr>
               <a:spcAft>
-                <a:spcPts val="1200"/>
-              </a:spcAft>
-              <a:defRPr sz="1600">
-                <a:solidFill>
-                  <a:srgbClr val="DCF0FF"/>
-                </a:solidFill>
-              </a:defRPr>
-            </a:pPr>
-            <a:r>
-              <a:t>• Self-Explainable AI (XAI): Translates VQC state vectors into warning logs.</a:t>
-            </a:r>
-          </a:p>
-          <a:p>
-            <a:pPr>
-              <a:spcAft>
-                <a:spcPts val="1200"/>
-              </a:spcAft>
-              <a:defRPr sz="1600">
-                <a:solidFill>
-                  <a:srgbClr val="DCF0FF"/>
-                </a:solidFill>
-              </a:defRPr>
-            </a:pPr>
-            <a:r>
-              <a:t>• Auditable Compliance: Outlines exactly why an agent triggered the transaction block.</a:t>
-            </a:r>
-          </a:p>
-          <a:p>
-            <a:pPr>
-              <a:spcAft>
-                <a:spcPts val="1200"/>
-              </a:spcAft>
-              <a:defRPr sz="1600">
-                <a:solidFill>
-                  <a:srgbClr val="DCF0FF"/>
-                </a:solidFill>
-              </a:defRPr>
-            </a:pPr>
-            <a:r>
-              <a:t>• Fraud Strategy Advisor: Recommends progressive mitigation checklists instead of binary blocks.</a:t>
-            </a:r>
-          </a:p>
-          <a:p>
-            <a:pPr>
-              <a:spcAft>
-                <a:spcPts val="1200"/>
-              </a:spcAft>
-              <a:defRPr sz="1600">
-                <a:solidFill>
-                  <a:srgbClr val="DCF0FF"/>
-                </a:solidFill>
-              </a:defRPr>
-            </a:pPr>
-            <a:r>
-              <a:t>• Mitigation Checklist: Request Face Authentication, Require SMS OTP, or Hold payout.</a:t>
-            </a:r>
-          </a:p>
-          <a:p>
-            <a:pPr>
-              <a:spcAft>
-                <a:spcPts val="1200"/>
-              </a:spcAft>
-              <a:defRPr sz="1600">
-                <a:solidFill>
-                  <a:srgbClr val="DCF0FF"/>
-                </a:solidFill>
-              </a:defRPr>
-            </a:pPr>
-            <a:r>
-              <a:t>• Benefit: Reduces manual review audit delays and matches regulatory frameworks.</a:t>
+                <a:spcPts val="1400"/>
+              </a:spcAft>
+            </a:pPr>
+            <a:r>
+              <a:t>Angle Encoding: Local agent threat outputs (0 to 1) map to rotation angles (0 to Pi).</a:t>
+            </a:r>
+          </a:p>
+          <a:p>
+            <a:pPr>
+              <a:spcAft>
+                <a:spcPts val="1400"/>
+              </a:spcAft>
+            </a:pPr>
+            <a:r>
+              <a:t>Qubit Allocation: Initializes a 4-qubit state, applying Ry rotation gates to each qubit.</a:t>
+            </a:r>
+          </a:p>
+          <a:p>
+            <a:pPr>
+              <a:spcAft>
+                <a:spcPts val="1400"/>
+              </a:spcAft>
+            </a:pPr>
+            <a:r>
+              <a:t>Bloch Projections: Risk levels are mapped as coordinates on a 3D Bloch Sphere vector.</a:t>
+            </a:r>
+          </a:p>
+          <a:p>
+            <a:pPr>
+              <a:spcAft>
+                <a:spcPts val="1400"/>
+              </a:spcAft>
+            </a:pPr>
+            <a:r>
+              <a:t>Excitation Tracking: Elevated telemetry flags push the state vectors closer to the |1&gt; pole.</a:t>
+            </a:r>
+          </a:p>
+        </p:txBody>
+      </p:sp>
+    </p:spTree>
+  </p:cSld>
+  <p:clrMapOvr>
+    <a:masterClrMapping/>
+  </p:clrMapOvr>
+</p:sld>
+</file>
+
+<file path=ppt/slides/slide6.xml><?xml version="1.0" encoding="utf-8"?>
+<p:sld xmlns:a="http://schemas.openxmlformats.org/drawingml/2006/main" xmlns:p="http://schemas.openxmlformats.org/presentationml/2006/main" xmlns:r="http://schemas.openxmlformats.org/officeDocument/2006/relationships">
+  <p:cSld>
+    <p:spTree>
+      <p:nvGrpSpPr>
+        <p:cNvPr id="1" name=""/>
+        <p:cNvGrpSpPr/>
+        <p:nvPr/>
+      </p:nvGrpSpPr>
+      <p:grpSpPr/>
+      <p:sp>
+        <p:nvSpPr>
+          <p:cNvPr id="2" name="Title 1"/>
+          <p:cNvSpPr>
+            <a:spLocks noGrp="1"/>
+          </p:cNvSpPr>
+          <p:nvPr>
+            <p:ph type="title"/>
+          </p:nvPr>
+        </p:nvSpPr>
+        <p:spPr/>
+        <p:txBody>
+          <a:bodyPr/>
+          <a:lstStyle/>
+          <a:p>
+            <a:r>
+              <a:t>5. BLOCH SPHERE &amp; STATE VECTOR MAPPING</a:t>
+            </a:r>
+          </a:p>
+        </p:txBody>
+      </p:sp>
+      <p:sp>
+        <p:nvSpPr>
+          <p:cNvPr id="3" name="Content Placeholder 2"/>
+          <p:cNvSpPr>
+            <a:spLocks noGrp="1"/>
+          </p:cNvSpPr>
+          <p:nvPr>
+            <p:ph idx="1" sz="quarter"/>
+          </p:nvPr>
+        </p:nvSpPr>
+        <p:spPr/>
+        <p:txBody>
+          <a:bodyPr wrap="square"/>
+          <a:lstStyle/>
+          <a:p>
+            <a:pPr>
+              <a:spcAft>
+                <a:spcPts val="1400"/>
+              </a:spcAft>
+            </a:pPr>
+            <a:r>
+              <a:t>Angle Encoding: Local agent threat outputs (0 to 1) map to rotation angles (0 to Pi).</a:t>
+            </a:r>
+          </a:p>
+          <a:p>
+            <a:pPr>
+              <a:spcAft>
+                <a:spcPts val="1400"/>
+              </a:spcAft>
+            </a:pPr>
+            <a:r>
+              <a:t>Qubit Allocation: Initializes a 4-qubit state, applying Ry rotation gates to each qubit.</a:t>
+            </a:r>
+          </a:p>
+          <a:p>
+            <a:pPr>
+              <a:spcAft>
+                <a:spcPts val="1400"/>
+              </a:spcAft>
+            </a:pPr>
+            <a:r>
+              <a:t>Bloch Projections: Risk levels are mapped as coordinates on a 3D Bloch Sphere vector.</a:t>
+            </a:r>
+          </a:p>
+          <a:p>
+            <a:pPr>
+              <a:spcAft>
+                <a:spcPts val="1400"/>
+              </a:spcAft>
+            </a:pPr>
+            <a:r>
+              <a:t>Excitation Tracking: Elevated telemetry flags push the state vectors closer to the |1&gt; pole.</a:t>
             </a:r>
           </a:p>
         </p:txBody>
@@ -7563,7 +9023,7 @@
           <a:lstStyle/>
           <a:p>
             <a:r>
-              <a:t>6. SCALABILITY &amp; DATABASE PIPELINE Integration</a:t>
+              <a:t>6. VARIATIONAL QUANTUM CIRCUIT (VQC) DETAILS</a:t>
             </a:r>
           </a:p>
         </p:txBody>
@@ -7585,76 +9045,516 @@
           <a:p>
             <a:pPr>
               <a:spcAft>
-                <a:spcPts val="1200"/>
-              </a:spcAft>
-              <a:defRPr sz="1600">
-                <a:solidFill>
-                  <a:srgbClr val="DCF0FF"/>
-                </a:solidFill>
-              </a:defRPr>
-            </a:pPr>
-            <a:r>
-              <a:t>• Kaggle Database: Integrated with 3,000 real-world transaction logs (IEEE-CIS).</a:t>
-            </a:r>
-          </a:p>
-          <a:p>
-            <a:pPr>
-              <a:spcAft>
-                <a:spcPts val="1200"/>
-              </a:spcAft>
-              <a:defRPr sz="1600">
-                <a:solidFill>
-                  <a:srgbClr val="DCF0FF"/>
-                </a:solidFill>
-              </a:defRPr>
-            </a:pPr>
-            <a:r>
-              <a:t>• MongoDB Integration: Stores transactions and quantum telemetry in indexed collections.</a:t>
-            </a:r>
-          </a:p>
-          <a:p>
-            <a:pPr>
-              <a:spcAft>
-                <a:spcPts val="1200"/>
-              </a:spcAft>
-              <a:defRPr sz="1600">
-                <a:solidFill>
-                  <a:srgbClr val="DCF0FF"/>
-                </a:solidFill>
-              </a:defRPr>
-            </a:pPr>
-            <a:r>
-              <a:t>• FastAPI REST endpoints: Exposes VQC coordinates, dynamic weights, and strategies.</a:t>
-            </a:r>
-          </a:p>
-          <a:p>
-            <a:pPr>
-              <a:spcAft>
-                <a:spcPts val="1200"/>
-              </a:spcAft>
-              <a:defRPr sz="1600">
-                <a:solidFill>
-                  <a:srgbClr val="DCF0FF"/>
-                </a:solidFill>
-              </a:defRPr>
-            </a:pPr>
-            <a:r>
-              <a:t>• Vercel Deployment: Standalone HTML visualizer deployed live on cloud static servers.</a:t>
-            </a:r>
-          </a:p>
-          <a:p>
-            <a:pPr>
-              <a:spcAft>
-                <a:spcPts val="1200"/>
-              </a:spcAft>
-              <a:defRPr sz="1600">
-                <a:solidFill>
-                  <a:srgbClr val="DCF0FF"/>
-                </a:solidFill>
-              </a:defRPr>
-            </a:pPr>
-            <a:r>
-              <a:t>• Result: A scalable, production-grade Quantum-Graph system ready for deployment.</a:t>
+                <a:spcPts val="1400"/>
+              </a:spcAft>
+            </a:pPr>
+            <a:r>
+              <a:t>Ansatz Entanglement: Connects qubits in a ring topology (Q0-&gt;Q1-&gt;Q2-&gt;Q3-&gt;Q0) using CNOT gates.</a:t>
+            </a:r>
+          </a:p>
+          <a:p>
+            <a:pPr>
+              <a:spcAft>
+                <a:spcPts val="1400"/>
+              </a:spcAft>
+            </a:pPr>
+            <a:r>
+              <a:t>Coordinated Learning: Entanglement allows Q-Guard to associate user details with device risk.</a:t>
+            </a:r>
+          </a:p>
+          <a:p>
+            <a:pPr>
+              <a:spcAft>
+                <a:spcPts val="1400"/>
+              </a:spcAft>
+            </a:pPr>
+            <a:r>
+              <a:t>Variational Tuning: Fine-tunes model weights dynamically using rotation parameter loops.</a:t>
+            </a:r>
+          </a:p>
+          <a:p>
+            <a:pPr>
+              <a:spcAft>
+                <a:spcPts val="1400"/>
+              </a:spcAft>
+            </a:pPr>
+            <a:r>
+              <a:t>Output Expectation: Calculates the Z-axis expectation value of each qubit upon measurement.</a:t>
+            </a:r>
+          </a:p>
+        </p:txBody>
+      </p:sp>
+    </p:spTree>
+  </p:cSld>
+  <p:clrMapOvr>
+    <a:masterClrMapping/>
+  </p:clrMapOvr>
+</p:sld>
+</file>
+
+<file path=ppt/slides/slide7.xml><?xml version="1.0" encoding="utf-8"?>
+<p:sld xmlns:a="http://schemas.openxmlformats.org/drawingml/2006/main" xmlns:p="http://schemas.openxmlformats.org/presentationml/2006/main" xmlns:r="http://schemas.openxmlformats.org/officeDocument/2006/relationships">
+  <p:cSld>
+    <p:spTree>
+      <p:nvGrpSpPr>
+        <p:cNvPr id="1" name=""/>
+        <p:cNvGrpSpPr/>
+        <p:nvPr/>
+      </p:nvGrpSpPr>
+      <p:grpSpPr/>
+      <p:sp>
+        <p:nvSpPr>
+          <p:cNvPr id="2" name="Title 1"/>
+          <p:cNvSpPr>
+            <a:spLocks noGrp="1"/>
+          </p:cNvSpPr>
+          <p:nvPr>
+            <p:ph type="title"/>
+          </p:nvPr>
+        </p:nvSpPr>
+        <p:spPr/>
+        <p:txBody>
+          <a:bodyPr/>
+          <a:lstStyle/>
+          <a:p>
+            <a:r>
+              <a:t>6. VARIATIONAL QUANTUM CIRCUIT (VQC) DETAILS</a:t>
+            </a:r>
+          </a:p>
+        </p:txBody>
+      </p:sp>
+      <p:sp>
+        <p:nvSpPr>
+          <p:cNvPr id="3" name="Content Placeholder 2"/>
+          <p:cNvSpPr>
+            <a:spLocks noGrp="1"/>
+          </p:cNvSpPr>
+          <p:nvPr>
+            <p:ph idx="1" sz="quarter"/>
+          </p:nvPr>
+        </p:nvSpPr>
+        <p:spPr/>
+        <p:txBody>
+          <a:bodyPr wrap="square"/>
+          <a:lstStyle/>
+          <a:p>
+            <a:pPr>
+              <a:spcAft>
+                <a:spcPts val="1400"/>
+              </a:spcAft>
+            </a:pPr>
+            <a:r>
+              <a:t>Ansatz Entanglement: Connects qubits in a ring topology (Q0-&gt;Q1-&gt;Q2-&gt;Q3-&gt;Q0) using CNOT gates.</a:t>
+            </a:r>
+          </a:p>
+          <a:p>
+            <a:pPr>
+              <a:spcAft>
+                <a:spcPts val="1400"/>
+              </a:spcAft>
+            </a:pPr>
+            <a:r>
+              <a:t>Coordinated Learning: Entanglement allows Q-Guard to associate user details with device risk.</a:t>
+            </a:r>
+          </a:p>
+          <a:p>
+            <a:pPr>
+              <a:spcAft>
+                <a:spcPts val="1400"/>
+              </a:spcAft>
+            </a:pPr>
+            <a:r>
+              <a:t>Variational Tuning: Fine-tunes model weights dynamically using rotation parameter loops.</a:t>
+            </a:r>
+          </a:p>
+          <a:p>
+            <a:pPr>
+              <a:spcAft>
+                <a:spcPts val="1400"/>
+              </a:spcAft>
+            </a:pPr>
+            <a:r>
+              <a:t>Output Expectation: Calculates the Z-axis expectation value of each qubit upon measurement.</a:t>
+            </a:r>
+          </a:p>
+        </p:txBody>
+      </p:sp>
+    </p:spTree>
+  </p:cSld>
+  <p:clrMapOvr>
+    <a:masterClrMapping/>
+  </p:clrMapOvr>
+</p:sld>
+</file>
+
+<file path=ppt/slides/slide8.xml><?xml version="1.0" encoding="utf-8"?>
+<p:sld xmlns:a="http://schemas.openxmlformats.org/drawingml/2006/main" xmlns:p="http://schemas.openxmlformats.org/presentationml/2006/main" xmlns:r="http://schemas.openxmlformats.org/officeDocument/2006/relationships">
+  <p:cSld>
+    <p:spTree>
+      <p:nvGrpSpPr>
+        <p:cNvPr id="1" name=""/>
+        <p:cNvGrpSpPr/>
+        <p:nvPr/>
+      </p:nvGrpSpPr>
+      <p:grpSpPr/>
+      <p:sp>
+        <p:nvSpPr>
+          <p:cNvPr id="2" name="Title 1"/>
+          <p:cNvSpPr>
+            <a:spLocks noGrp="1"/>
+          </p:cNvSpPr>
+          <p:nvPr>
+            <p:ph type="title"/>
+          </p:nvPr>
+        </p:nvSpPr>
+        <p:spPr/>
+        <p:txBody>
+          <a:bodyPr/>
+          <a:lstStyle/>
+          <a:p>
+            <a:r>
+              <a:t>7. DYNAMIC BLOCH VECTOR WEIGHTING</a:t>
+            </a:r>
+          </a:p>
+        </p:txBody>
+      </p:sp>
+      <p:sp>
+        <p:nvSpPr>
+          <p:cNvPr id="3" name="Content Placeholder 2"/>
+          <p:cNvSpPr>
+            <a:spLocks noGrp="1"/>
+          </p:cNvSpPr>
+          <p:nvPr>
+            <p:ph idx="1" sz="quarter"/>
+          </p:nvPr>
+        </p:nvSpPr>
+        <p:spPr/>
+        <p:txBody>
+          <a:bodyPr wrap="square"/>
+          <a:lstStyle/>
+          <a:p>
+            <a:pPr>
+              <a:spcAft>
+                <a:spcPts val="1400"/>
+              </a:spcAft>
+            </a:pPr>
+            <a:r>
+              <a:t>Dynamic Weights: Calculates weights directly from Bloch Z-projection: W = (1 - Z)/2.</a:t>
+            </a:r>
+          </a:p>
+          <a:p>
+            <a:pPr>
+              <a:spcAft>
+                <a:spcPts val="1400"/>
+              </a:spcAft>
+            </a:pPr>
+            <a:r>
+              <a:t>Adaptive Focus: System dynamically shifts priority to the agent showing the highest anomaly.</a:t>
+            </a:r>
+          </a:p>
+          <a:p>
+            <a:pPr>
+              <a:spcAft>
+                <a:spcPts val="1400"/>
+              </a:spcAft>
+            </a:pPr>
+            <a:r>
+              <a:t>Combined Risk Scoring: Calculates final score as a weighted sum of qubit measurements.</a:t>
+            </a:r>
+          </a:p>
+          <a:p>
+            <a:pPr>
+              <a:spcAft>
+                <a:spcPts val="1400"/>
+              </a:spcAft>
+            </a:pPr>
+            <a:r>
+              <a:t>Noise Suppression: Low-risk background telemetry is dynamically ignored to save database bandwidth.</a:t>
+            </a:r>
+          </a:p>
+        </p:txBody>
+      </p:sp>
+    </p:spTree>
+  </p:cSld>
+  <p:clrMapOvr>
+    <a:masterClrMapping/>
+  </p:clrMapOvr>
+</p:sld>
+</file>
+
+<file path=ppt/slides/slide8.xml><?xml version="1.0" encoding="utf-8"?>
+<p:sld xmlns:a="http://schemas.openxmlformats.org/drawingml/2006/main" xmlns:p="http://schemas.openxmlformats.org/presentationml/2006/main" xmlns:r="http://schemas.openxmlformats.org/officeDocument/2006/relationships">
+  <p:cSld>
+    <p:spTree>
+      <p:nvGrpSpPr>
+        <p:cNvPr id="1" name=""/>
+        <p:cNvGrpSpPr/>
+        <p:nvPr/>
+      </p:nvGrpSpPr>
+      <p:grpSpPr/>
+      <p:sp>
+        <p:nvSpPr>
+          <p:cNvPr id="2" name="Title 1"/>
+          <p:cNvSpPr>
+            <a:spLocks noGrp="1"/>
+          </p:cNvSpPr>
+          <p:nvPr>
+            <p:ph type="title"/>
+          </p:nvPr>
+        </p:nvSpPr>
+        <p:spPr/>
+        <p:txBody>
+          <a:bodyPr/>
+          <a:lstStyle/>
+          <a:p>
+            <a:r>
+              <a:t>7. DYNAMIC BLOCH VECTOR WEIGHTING</a:t>
+            </a:r>
+          </a:p>
+        </p:txBody>
+      </p:sp>
+      <p:sp>
+        <p:nvSpPr>
+          <p:cNvPr id="3" name="Content Placeholder 2"/>
+          <p:cNvSpPr>
+            <a:spLocks noGrp="1"/>
+          </p:cNvSpPr>
+          <p:nvPr>
+            <p:ph idx="1" sz="quarter"/>
+          </p:nvPr>
+        </p:nvSpPr>
+        <p:spPr/>
+        <p:txBody>
+          <a:bodyPr wrap="square"/>
+          <a:lstStyle/>
+          <a:p>
+            <a:pPr>
+              <a:spcAft>
+                <a:spcPts val="1400"/>
+              </a:spcAft>
+            </a:pPr>
+            <a:r>
+              <a:t>Dynamic Weights: Calculates weights directly from Bloch Z-projection: W = (1 - Z)/2.</a:t>
+            </a:r>
+          </a:p>
+          <a:p>
+            <a:pPr>
+              <a:spcAft>
+                <a:spcPts val="1400"/>
+              </a:spcAft>
+            </a:pPr>
+            <a:r>
+              <a:t>Adaptive Focus: System dynamically shifts priority to the agent showing the highest anomaly.</a:t>
+            </a:r>
+          </a:p>
+          <a:p>
+            <a:pPr>
+              <a:spcAft>
+                <a:spcPts val="1400"/>
+              </a:spcAft>
+            </a:pPr>
+            <a:r>
+              <a:t>Combined Risk Scoring: Calculates final score as a weighted sum of qubit measurements.</a:t>
+            </a:r>
+          </a:p>
+          <a:p>
+            <a:pPr>
+              <a:spcAft>
+                <a:spcPts val="1400"/>
+              </a:spcAft>
+            </a:pPr>
+            <a:r>
+              <a:t>Noise Suppression: Low-risk background telemetry is dynamically ignored to save database bandwidth.</a:t>
+            </a:r>
+          </a:p>
+        </p:txBody>
+      </p:sp>
+    </p:spTree>
+  </p:cSld>
+  <p:clrMapOvr>
+    <a:masterClrMapping/>
+  </p:clrMapOvr>
+</p:sld>
+</file>
+
+<file path=ppt/slides/slide9.xml><?xml version="1.0" encoding="utf-8"?>
+<p:sld xmlns:a="http://schemas.openxmlformats.org/drawingml/2006/main" xmlns:p="http://schemas.openxmlformats.org/presentationml/2006/main" xmlns:r="http://schemas.openxmlformats.org/officeDocument/2006/relationships">
+  <p:cSld>
+    <p:spTree>
+      <p:nvGrpSpPr>
+        <p:cNvPr id="1" name=""/>
+        <p:cNvGrpSpPr/>
+        <p:nvPr/>
+      </p:nvGrpSpPr>
+      <p:grpSpPr/>
+      <p:sp>
+        <p:nvSpPr>
+          <p:cNvPr id="2" name="Title 1"/>
+          <p:cNvSpPr>
+            <a:spLocks noGrp="1"/>
+          </p:cNvSpPr>
+          <p:nvPr>
+            <p:ph type="title"/>
+          </p:nvPr>
+        </p:nvSpPr>
+        <p:spPr/>
+        <p:txBody>
+          <a:bodyPr/>
+          <a:lstStyle/>
+          <a:p>
+            <a:r>
+              <a:t>8. ADAPTIVE CONTEXT THRESHOLD ENGINE</a:t>
+            </a:r>
+          </a:p>
+        </p:txBody>
+      </p:sp>
+      <p:sp>
+        <p:nvSpPr>
+          <p:cNvPr id="3" name="Content Placeholder 2"/>
+          <p:cNvSpPr>
+            <a:spLocks noGrp="1"/>
+          </p:cNvSpPr>
+          <p:nvPr>
+            <p:ph idx="1" sz="quarter"/>
+          </p:nvPr>
+        </p:nvSpPr>
+        <p:spPr/>
+        <p:txBody>
+          <a:bodyPr wrap="square"/>
+          <a:lstStyle/>
+          <a:p>
+            <a:pPr>
+              <a:spcAft>
+                <a:spcPts val="1400"/>
+              </a:spcAft>
+            </a:pPr>
+            <a:r>
+              <a:t>Dynamic Guardrails: Replaces flat, static 80% limits with context-aware boundaries.</a:t>
+            </a:r>
+          </a:p>
+          <a:p>
+            <a:pPr>
+              <a:spcAft>
+                <a:spcPts val="1400"/>
+              </a:spcAft>
+            </a:pPr>
+            <a:r>
+              <a:t>Time Window (12 AM - 5 AM): Threshold drops to 65% to defend against off-hour scams.</a:t>
+            </a:r>
+          </a:p>
+          <a:p>
+            <a:pPr>
+              <a:spcAft>
+                <a:spcPts val="1400"/>
+              </a:spcAft>
+            </a:pPr>
+            <a:r>
+              <a:t>Merchant Context: Limit drops to 58% for high-hazard category terminal devices.</a:t>
+            </a:r>
+          </a:p>
+          <a:p>
+            <a:pPr>
+              <a:spcAft>
+                <a:spcPts val="1400"/>
+              </a:spcAft>
+            </a:pPr>
+            <a:r>
+              <a:t>Customer Context: Threshold relaxes to 95% for trusted, long-standing user profiles.</a:t>
+            </a:r>
+          </a:p>
+        </p:txBody>
+      </p:sp>
+    </p:spTree>
+  </p:cSld>
+  <p:clrMapOvr>
+    <a:masterClrMapping/>
+  </p:clrMapOvr>
+</p:sld>
+</file>
+
+<file path=ppt/slides/slide9.xml><?xml version="1.0" encoding="utf-8"?>
+<p:sld xmlns:a="http://schemas.openxmlformats.org/drawingml/2006/main" xmlns:p="http://schemas.openxmlformats.org/presentationml/2006/main" xmlns:r="http://schemas.openxmlformats.org/officeDocument/2006/relationships">
+  <p:cSld>
+    <p:spTree>
+      <p:nvGrpSpPr>
+        <p:cNvPr id="1" name=""/>
+        <p:cNvGrpSpPr/>
+        <p:nvPr/>
+      </p:nvGrpSpPr>
+      <p:grpSpPr/>
+      <p:sp>
+        <p:nvSpPr>
+          <p:cNvPr id="2" name="Title 1"/>
+          <p:cNvSpPr>
+            <a:spLocks noGrp="1"/>
+          </p:cNvSpPr>
+          <p:nvPr>
+            <p:ph type="title"/>
+          </p:nvPr>
+        </p:nvSpPr>
+        <p:spPr/>
+        <p:txBody>
+          <a:bodyPr/>
+          <a:lstStyle/>
+          <a:p>
+            <a:r>
+              <a:t>8. ADAPTIVE CONTEXT THRESHOLD ENGINE</a:t>
+            </a:r>
+          </a:p>
+        </p:txBody>
+      </p:sp>
+      <p:sp>
+        <p:nvSpPr>
+          <p:cNvPr id="3" name="Content Placeholder 2"/>
+          <p:cNvSpPr>
+            <a:spLocks noGrp="1"/>
+          </p:cNvSpPr>
+          <p:nvPr>
+            <p:ph idx="1" sz="quarter"/>
+          </p:nvPr>
+        </p:nvSpPr>
+        <p:spPr/>
+        <p:txBody>
+          <a:bodyPr wrap="square"/>
+          <a:lstStyle/>
+          <a:p>
+            <a:pPr>
+              <a:spcAft>
+                <a:spcPts val="1400"/>
+              </a:spcAft>
+            </a:pPr>
+            <a:r>
+              <a:t>Dynamic Guardrails: Replaces flat, static 80% limits with context-aware boundaries.</a:t>
+            </a:r>
+          </a:p>
+          <a:p>
+            <a:pPr>
+              <a:spcAft>
+                <a:spcPts val="1400"/>
+              </a:spcAft>
+            </a:pPr>
+            <a:r>
+              <a:t>Time Window (12 AM - 5 AM): Threshold drops to 65% to defend against off-hour scams.</a:t>
+            </a:r>
+          </a:p>
+          <a:p>
+            <a:pPr>
+              <a:spcAft>
+                <a:spcPts val="1400"/>
+              </a:spcAft>
+            </a:pPr>
+            <a:r>
+              <a:t>Merchant Context: Limit drops to 58% for high-hazard category terminal devices.</a:t>
+            </a:r>
+          </a:p>
+          <a:p>
+            <a:pPr>
+              <a:spcAft>
+                <a:spcPts val="1400"/>
+              </a:spcAft>
+            </a:pPr>
+            <a:r>
+              <a:t>Customer Context: Threshold relaxes to 95% for trusted, long-standing user profiles.</a:t>
             </a:r>
           </a:p>
         </p:txBody>

</xml_diff>